<commit_message>
docs: align candidate with architecture review
</commit_message>
<xml_diff>
--- a/AURA/submission/AURA_5_SLIDES_AFTER_FEEDBACK_FINAL.pptx
+++ b/AURA/submission/AURA_5_SLIDES_AFTER_FEEDBACK_FINAL.pptx
@@ -2,17 +2,17 @@
 <file path=ppt/presentation.xml><?xml version="1.0" encoding="utf-8"?>
 <p:presentation xmlns:p="http://schemas.openxmlformats.org/presentationml/2006/main">
   <p:sldMasterIdLst>
-    <p:sldMasterId xmlns:r="http://schemas.openxmlformats.org/officeDocument/2006/relationships" id="2147483648" r:id="R09c6beab9bea4feb"/>
+    <p:sldMasterId xmlns:r="http://schemas.openxmlformats.org/officeDocument/2006/relationships" id="2147483648" r:id="R04c3212187524e4c"/>
   </p:sldMasterIdLst>
   <p:notesMasterIdLst>
-    <p:notesMasterId xmlns:r="http://schemas.openxmlformats.org/officeDocument/2006/relationships" r:id="R60401ce95ec44af8"/>
+    <p:notesMasterId xmlns:r="http://schemas.openxmlformats.org/officeDocument/2006/relationships" r:id="R4e986cc36a9e44b6"/>
   </p:notesMasterIdLst>
   <p:sldIdLst>
-    <p:sldId xmlns:r="http://schemas.openxmlformats.org/officeDocument/2006/relationships" id="256" r:id="R660f375d548440ab"/>
-    <p:sldId xmlns:r="http://schemas.openxmlformats.org/officeDocument/2006/relationships" id="257" r:id="Ra53d905c8ef343b0"/>
-    <p:sldId xmlns:r="http://schemas.openxmlformats.org/officeDocument/2006/relationships" id="258" r:id="R29f4dd4a03ba4a4c"/>
-    <p:sldId xmlns:r="http://schemas.openxmlformats.org/officeDocument/2006/relationships" id="259" r:id="R17cf4ebf6ec04b9c"/>
-    <p:sldId xmlns:r="http://schemas.openxmlformats.org/officeDocument/2006/relationships" id="260" r:id="R7fbe90d7c9a34c35"/>
+    <p:sldId xmlns:r="http://schemas.openxmlformats.org/officeDocument/2006/relationships" id="256" r:id="R66b82ea9162d47a7"/>
+    <p:sldId xmlns:r="http://schemas.openxmlformats.org/officeDocument/2006/relationships" id="257" r:id="R39d326d226a1477b"/>
+    <p:sldId xmlns:r="http://schemas.openxmlformats.org/officeDocument/2006/relationships" id="258" r:id="Rf3c6a0e818b14552"/>
+    <p:sldId xmlns:r="http://schemas.openxmlformats.org/officeDocument/2006/relationships" id="259" r:id="R3154f74726d34146"/>
+    <p:sldId xmlns:r="http://schemas.openxmlformats.org/officeDocument/2006/relationships" id="260" r:id="R92c006bf2dc54d67"/>
   </p:sldIdLst>
   <p:sldSz cx="12192000" cy="6858000"/>
   <p:notesSz cx="6858000" cy="9144000"/>
@@ -576,7 +576,7 @@
           </a:p>
           <a:p xmlns:a="http://schemas.openxmlformats.org/drawingml/2006/main">
             <a:r>
-              <a:t>Pha A nhận tối đa mười ảnh nhưng vẫn kiểm từng file, lưu riêng tư, tính SHA-256 rồi ghi một SQL row và AI_QUEUED riêng. UI gọi tuần tự cùng endpoint HTTP 202, nên đây không phải một pipeline batch thứ hai.</a:t>
+              <a:t>Pha A nhận tối đa mười ảnh nhưng vẫn kiểm từng file, lưu riêng tư, tính SHA-256 rồi ghi một SQL row và AI_QUEUED riêng. UI gọi tuần tự cùng endpoint HTTP 202; mỗi ảnh là một hồ sơ độc lập, chưa có InvoiceBatch hoặc batchId phía server.</a:t>
             </a:r>
           </a:p>
           <a:p xmlns:a="http://schemas.openxmlformats.org/drawingml/2006/main">
@@ -846,7 +846,7 @@
           </a:p>
           <a:p xmlns:a="http://schemas.openxmlformats.org/drawingml/2006/main">
             <a:r>
-              <a:t>Bốn lớp bên trái đã có trong source: giao diện batch, dashboard và CSV report; SQL queue/worker; adapter cùng schema/semantic validation; amount resolver, privacy classifier và policy C#.</a:t>
+              <a:t>Bốn lớp bên trái đã có trong source: giao diện multi-file, dashboard và CSV report; SQL queue/worker; adapter cùng schema/semantic validation; amount resolver, privacy classifier và policy C#.</a:t>
             </a:r>
           </a:p>
           <a:p xmlns:a="http://schemas.openxmlformats.org/drawingml/2006/main">
@@ -856,7 +856,7 @@
           </a:p>
           <a:p xmlns:a="http://schemas.openxmlformats.org/drawingml/2006/main">
             <a:r>
-              <a:t>Model chỉ nhận ảnh và trả DTO theo contract. Model không có tool, không có credential ghi database và không tự sửa trạng thái. Privacy classifier không cấp quyền; nó chỉ tạo category để policy C# fail-safe sang ESCALATE_PRIVACY.</a:t>
+              <a:t>Model chỉ nhận ảnh và trả DTO theo contract. Model không có tool, không có credential ghi database và không tự sửa trạng thái. Privacy classifier không cấp quyền; nó chỉ tạo category để policy C# fail-safe sang ESCALATE_PRIVACY. Vì triage chạy sau VLM, demo ưu tiên chứng từ tổng hợp hoặc đã ẩn danh; production cần pre-inference redaction hoặc local VLM cho dữ liệu nhạy cảm.</a:t>
             </a:r>
           </a:p>
           <a:p xmlns:a="http://schemas.openxmlformats.org/drawingml/2006/main">
@@ -996,7 +996,7 @@
           </a:p>
           <a:p xmlns:a="http://schemas.openxmlformats.org/drawingml/2006/main">
             <a:r>
-              <a:t>Sau feedback, source đã có batch upload, AI-derived amount có provenance, privacy triage, dashboard ngày tháng năm và CSV report. Release build sạch, 181 trên 181 test; report không sửa database model.</a:t>
+              <a:t>Sau feedback, source đã có lượt chọn nhiều ảnh, AI-derived amount có provenance, privacy triage, dashboard ngày tháng năm và CSV report. Mỗi ảnh là một hồ sơ độc lập; chưa có InvoiceBatch hoặc batchId phía server. Release build sạch, 181 trên 181 test; report không sửa database model.</a:t>
             </a:r>
           </a:p>
           <a:p xmlns:a="http://schemas.openxmlformats.org/drawingml/2006/main">
@@ -1006,7 +1006,7 @@
           </a:p>
           <a:p xmlns:a="http://schemas.openxmlformats.org/drawingml/2006/main">
             <a:r>
-              <a:t>Gate trước demo chiều nay là publish/recycle, health 200, rồi một single upload không nhập amount, một batch nhỏ, một privacy synthetic case và tải CSV tháng. Không rerun holdout cũ để tạo claim accuracy mới.</a:t>
+              <a:t>Gate trước demo chiều nay là publish/recycle, health 200, rồi một single upload không nhập amount, một lượt nhiều ảnh nhỏ, một privacy synthetic case và tải CSV tháng. Không rerun holdout cũ để tạo claim accuracy mới.</a:t>
             </a:r>
           </a:p>
           <a:p xmlns:a="http://schemas.openxmlformats.org/drawingml/2006/main">
@@ -1016,7 +1016,7 @@
           </a:p>
           <a:p xmlns:a="http://schemas.openxmlformats.org/drawingml/2006/main">
             <a:r>
-              <a:t>Privacy triage không phải compliance. Production còn cần identity thật, least privilege, private object storage, retention, monitoring và legal review. Luật 91/2025 và Nghị định 356/2025 là bối cảnh hiện hành, không phải chứng nhận cho sản phẩm.</a:t>
+              <a:t>Privacy triage không phải compliance và chạy sau inference. Production còn cần pre-inference control hoặc local VLM, identity thật, least privilege, private object storage, retention, monitoring và legal review. Luật 91/2025 và Nghị định 356/2025 là bối cảnh hiện hành, không phải chứng nhận cho sản phẩm.</a:t>
             </a:r>
           </a:p>
           <a:p xmlns:a="http://schemas.openxmlformats.org/drawingml/2006/main">
@@ -1093,7 +1093,7 @@
           <p:cNvPr id="3" name="Title">
             <a:extLst xmlns:a="http://schemas.openxmlformats.org/drawingml/2006/main">
               <a:ext uri="{FF2B5EF4-FFF2-40B4-BE49-F238E27FC236}">
-                <a16:creationId xmlns:a16="http://schemas.microsoft.com/office/drawing/2014/main" id="{335D242E-4202-4A7F-B16A-DF7AD43FA5D1}"/>
+                <a16:creationId xmlns:a16="http://schemas.microsoft.com/office/drawing/2014/main" id="{12187CDD-AB00-4A11-948A-EE9170FC0A51}"/>
               </a:ext>
             </a:extLst>
           </p:cNvPr>
@@ -1322,7 +1322,7 @@
           <p:cNvPr id="2" name="Subtitle">
             <a:extLst xmlns:a="http://schemas.openxmlformats.org/drawingml/2006/main">
               <a:ext uri="{FF2B5EF4-FFF2-40B4-BE49-F238E27FC236}">
-                <a16:creationId xmlns:a16="http://schemas.microsoft.com/office/drawing/2014/main" id="{40781641-7F54-4A81-9533-664A5244B49C}"/>
+                <a16:creationId xmlns:a16="http://schemas.microsoft.com/office/drawing/2014/main" id="{3D7A2B52-CDE7-48C5-93B1-42FDF454C4C8}"/>
               </a:ext>
             </a:extLst>
           </p:cNvPr>
@@ -1568,7 +1568,7 @@
           <p:cNvPr id="4" name="Layout_Divider">
             <a:extLst xmlns:a="http://schemas.openxmlformats.org/drawingml/2006/main">
               <a:ext uri="{FF2B5EF4-FFF2-40B4-BE49-F238E27FC236}">
-                <a16:creationId xmlns:a16="http://schemas.microsoft.com/office/drawing/2014/main" id="{00E83E47-9C78-4E2C-B470-563C8EA27E3E}"/>
+                <a16:creationId xmlns:a16="http://schemas.microsoft.com/office/drawing/2014/main" id="{4F6CD396-A6E0-4DF3-B4C9-06F680ADE270}"/>
               </a:ext>
             </a:extLst>
           </p:cNvPr>
@@ -1599,7 +1599,7 @@
           <p:cNvPr id="2" name="Layout_Footer">
             <a:extLst xmlns:a="http://schemas.openxmlformats.org/drawingml/2006/main">
               <a:ext uri="{FF2B5EF4-FFF2-40B4-BE49-F238E27FC236}">
-                <a16:creationId xmlns:a16="http://schemas.microsoft.com/office/drawing/2014/main" id="{2B64706B-8355-4370-A66E-FF9D07FD3863}"/>
+                <a16:creationId xmlns:a16="http://schemas.microsoft.com/office/drawing/2014/main" id="{2DB0A4AB-7C16-473F-8FEE-A9531F10F6A7}"/>
               </a:ext>
             </a:extLst>
           </p:cNvPr>
@@ -1757,7 +1757,7 @@
           <p:cNvPr id="3" name="Layout_PageNumber">
             <a:extLst xmlns:a="http://schemas.openxmlformats.org/drawingml/2006/main">
               <a:ext uri="{FF2B5EF4-FFF2-40B4-BE49-F238E27FC236}">
-                <a16:creationId xmlns:a16="http://schemas.microsoft.com/office/drawing/2014/main" id="{19D13645-8DE2-4898-8C1B-54FB74D667C7}"/>
+                <a16:creationId xmlns:a16="http://schemas.microsoft.com/office/drawing/2014/main" id="{9D7711FE-6762-4AB2-89F2-14F47AFB43B3}"/>
               </a:ext>
             </a:extLst>
           </p:cNvPr>
@@ -1932,7 +1932,7 @@
           <p:cNvPr id="5" name="Layout_Divider">
             <a:extLst xmlns:a="http://schemas.openxmlformats.org/drawingml/2006/main">
               <a:ext uri="{FF2B5EF4-FFF2-40B4-BE49-F238E27FC236}">
-                <a16:creationId xmlns:a16="http://schemas.microsoft.com/office/drawing/2014/main" id="{76B4AE66-AAA7-4F7A-A467-4881BCBEF6A2}"/>
+                <a16:creationId xmlns:a16="http://schemas.microsoft.com/office/drawing/2014/main" id="{3CDB3A81-D278-45BA-BC8D-5190E8E4B439}"/>
               </a:ext>
             </a:extLst>
           </p:cNvPr>
@@ -1963,7 +1963,7 @@
           <p:cNvPr id="2" name="Layout_Footer">
             <a:extLst xmlns:a="http://schemas.openxmlformats.org/drawingml/2006/main">
               <a:ext uri="{FF2B5EF4-FFF2-40B4-BE49-F238E27FC236}">
-                <a16:creationId xmlns:a16="http://schemas.microsoft.com/office/drawing/2014/main" id="{FBD48F1E-AED1-4D2C-A0C0-265329AF282A}"/>
+                <a16:creationId xmlns:a16="http://schemas.microsoft.com/office/drawing/2014/main" id="{4E0F32BF-BE4A-4C88-8E59-144FF1847C9C}"/>
               </a:ext>
             </a:extLst>
           </p:cNvPr>
@@ -2121,7 +2121,7 @@
           <p:cNvPr id="3" name="Layout_LimitFooter">
             <a:extLst xmlns:a="http://schemas.openxmlformats.org/drawingml/2006/main">
               <a:ext uri="{FF2B5EF4-FFF2-40B4-BE49-F238E27FC236}">
-                <a16:creationId xmlns:a16="http://schemas.microsoft.com/office/drawing/2014/main" id="{55C66DBF-EB2F-495F-B9A3-F48023EEA6D6}"/>
+                <a16:creationId xmlns:a16="http://schemas.microsoft.com/office/drawing/2014/main" id="{AD559905-2F7C-48AC-BA96-6E5D83A1BBE8}"/>
               </a:ext>
             </a:extLst>
           </p:cNvPr>
@@ -2279,7 +2279,7 @@
           <p:cNvPr id="4" name="Layout_PageNumber">
             <a:extLst xmlns:a="http://schemas.openxmlformats.org/drawingml/2006/main">
               <a:ext uri="{FF2B5EF4-FFF2-40B4-BE49-F238E27FC236}">
-                <a16:creationId xmlns:a16="http://schemas.microsoft.com/office/drawing/2014/main" id="{F1D4F857-73EF-4A1A-A64F-F554E003261A}"/>
+                <a16:creationId xmlns:a16="http://schemas.microsoft.com/office/drawing/2014/main" id="{E4BFB60F-F1C6-4C20-838C-42C0D9954AB1}"/>
               </a:ext>
             </a:extLst>
           </p:cNvPr>
@@ -2454,7 +2454,7 @@
           <p:cNvPr id="2" name="Section title">
             <a:extLst xmlns:a="http://schemas.openxmlformats.org/drawingml/2006/main">
               <a:ext uri="{FF2B5EF4-FFF2-40B4-BE49-F238E27FC236}">
-                <a16:creationId xmlns:a16="http://schemas.microsoft.com/office/drawing/2014/main" id="{5200B3B8-0C2A-48C5-A1BA-9411C7F01113}"/>
+                <a16:creationId xmlns:a16="http://schemas.microsoft.com/office/drawing/2014/main" id="{9ACA76B6-0198-4BB3-B529-552017A07788}"/>
               </a:ext>
             </a:extLst>
           </p:cNvPr>
@@ -2700,7 +2700,7 @@
           <p:cNvPr id="3" name="Title">
             <a:extLst xmlns:a="http://schemas.openxmlformats.org/drawingml/2006/main">
               <a:ext uri="{FF2B5EF4-FFF2-40B4-BE49-F238E27FC236}">
-                <a16:creationId xmlns:a16="http://schemas.microsoft.com/office/drawing/2014/main" id="{7ACE41D2-DA9D-43AA-94EC-4241A8C1523F}"/>
+                <a16:creationId xmlns:a16="http://schemas.microsoft.com/office/drawing/2014/main" id="{3B0B8DBC-60BC-4ACD-9113-FC1C283B5ED4}"/>
               </a:ext>
             </a:extLst>
           </p:cNvPr>
@@ -2929,7 +2929,7 @@
           <p:cNvPr id="2" name="Body">
             <a:extLst xmlns:a="http://schemas.openxmlformats.org/drawingml/2006/main">
               <a:ext uri="{FF2B5EF4-FFF2-40B4-BE49-F238E27FC236}">
-                <a16:creationId xmlns:a16="http://schemas.microsoft.com/office/drawing/2014/main" id="{41332E3F-B3D5-4D30-ABBD-73B68DC14469}"/>
+                <a16:creationId xmlns:a16="http://schemas.microsoft.com/office/drawing/2014/main" id="{150BA3C5-1FF3-4AE9-8FCC-6AC82BA03940}"/>
               </a:ext>
             </a:extLst>
           </p:cNvPr>
@@ -3175,7 +3175,7 @@
           <p:cNvPr id="4" name="Title">
             <a:extLst xmlns:a="http://schemas.openxmlformats.org/drawingml/2006/main">
               <a:ext uri="{FF2B5EF4-FFF2-40B4-BE49-F238E27FC236}">
-                <a16:creationId xmlns:a16="http://schemas.microsoft.com/office/drawing/2014/main" id="{934AE80C-6A07-44FE-8906-747078775500}"/>
+                <a16:creationId xmlns:a16="http://schemas.microsoft.com/office/drawing/2014/main" id="{F40BBE38-006C-4341-BA75-10BF98CA96E0}"/>
               </a:ext>
             </a:extLst>
           </p:cNvPr>
@@ -3404,7 +3404,7 @@
           <p:cNvPr id="2" name="Left column">
             <a:extLst xmlns:a="http://schemas.openxmlformats.org/drawingml/2006/main">
               <a:ext uri="{FF2B5EF4-FFF2-40B4-BE49-F238E27FC236}">
-                <a16:creationId xmlns:a16="http://schemas.microsoft.com/office/drawing/2014/main" id="{ABB85D79-F5A8-48BE-B25B-87A3CDA0E727}"/>
+                <a16:creationId xmlns:a16="http://schemas.microsoft.com/office/drawing/2014/main" id="{5E55D2F9-1BA3-4279-BE8E-7DEFF22F0072}"/>
               </a:ext>
             </a:extLst>
           </p:cNvPr>
@@ -3633,7 +3633,7 @@
           <p:cNvPr id="3" name="Right column">
             <a:extLst xmlns:a="http://schemas.openxmlformats.org/drawingml/2006/main">
               <a:ext uri="{FF2B5EF4-FFF2-40B4-BE49-F238E27FC236}">
-                <a16:creationId xmlns:a16="http://schemas.microsoft.com/office/drawing/2014/main" id="{3E6813E2-1484-4CB6-B84A-4ACB11288B87}"/>
+                <a16:creationId xmlns:a16="http://schemas.microsoft.com/office/drawing/2014/main" id="{D6C7A842-9506-406B-9BEE-EA5F1E98CB39}"/>
               </a:ext>
             </a:extLst>
           </p:cNvPr>
@@ -3879,7 +3879,7 @@
           <p:cNvPr id="3" name="Title">
             <a:extLst xmlns:a="http://schemas.openxmlformats.org/drawingml/2006/main">
               <a:ext uri="{FF2B5EF4-FFF2-40B4-BE49-F238E27FC236}">
-                <a16:creationId xmlns:a16="http://schemas.microsoft.com/office/drawing/2014/main" id="{69847072-C51D-449E-8920-A67DFB0FADCC}"/>
+                <a16:creationId xmlns:a16="http://schemas.microsoft.com/office/drawing/2014/main" id="{D27DD856-9362-4401-90BF-92BD234B8A08}"/>
               </a:ext>
             </a:extLst>
           </p:cNvPr>
@@ -4108,7 +4108,7 @@
           <p:cNvPr id="2" name="Left column">
             <a:extLst xmlns:a="http://schemas.openxmlformats.org/drawingml/2006/main">
               <a:ext uri="{FF2B5EF4-FFF2-40B4-BE49-F238E27FC236}">
-                <a16:creationId xmlns:a16="http://schemas.microsoft.com/office/drawing/2014/main" id="{F4D8FB3C-297B-461D-AA7C-3221525F2F11}"/>
+                <a16:creationId xmlns:a16="http://schemas.microsoft.com/office/drawing/2014/main" id="{4616AB63-A8C7-491E-866A-796CA56CED9C}"/>
               </a:ext>
             </a:extLst>
           </p:cNvPr>
@@ -4371,7 +4371,7 @@
           <p:cNvPr id="4" name="Layout_Divider">
             <a:extLst xmlns:a="http://schemas.openxmlformats.org/drawingml/2006/main">
               <a:ext uri="{FF2B5EF4-FFF2-40B4-BE49-F238E27FC236}">
-                <a16:creationId xmlns:a16="http://schemas.microsoft.com/office/drawing/2014/main" id="{BB14E733-8C5A-460A-88E0-2D90E7A6DB6C}"/>
+                <a16:creationId xmlns:a16="http://schemas.microsoft.com/office/drawing/2014/main" id="{F4EB696E-DA16-4BEE-9776-C450DED76939}"/>
               </a:ext>
             </a:extLst>
           </p:cNvPr>
@@ -4402,7 +4402,7 @@
           <p:cNvPr id="2" name="Layout_Footer">
             <a:extLst xmlns:a="http://schemas.openxmlformats.org/drawingml/2006/main">
               <a:ext uri="{FF2B5EF4-FFF2-40B4-BE49-F238E27FC236}">
-                <a16:creationId xmlns:a16="http://schemas.microsoft.com/office/drawing/2014/main" id="{F99C992D-CC8D-4FAB-A5F0-F658BB45DA86}"/>
+                <a16:creationId xmlns:a16="http://schemas.microsoft.com/office/drawing/2014/main" id="{D85B752C-1C49-49AF-9BE8-6ED5363E1C66}"/>
               </a:ext>
             </a:extLst>
           </p:cNvPr>
@@ -4560,7 +4560,7 @@
           <p:cNvPr id="3" name="Layout_PageNumber">
             <a:extLst xmlns:a="http://schemas.openxmlformats.org/drawingml/2006/main">
               <a:ext uri="{FF2B5EF4-FFF2-40B4-BE49-F238E27FC236}">
-                <a16:creationId xmlns:a16="http://schemas.microsoft.com/office/drawing/2014/main" id="{2CB0FEBB-31DF-4A1C-9A32-751575AF75E5}"/>
+                <a16:creationId xmlns:a16="http://schemas.microsoft.com/office/drawing/2014/main" id="{80447396-91CC-4C0A-9658-9D32CCEF2EE3}"/>
               </a:ext>
             </a:extLst>
           </p:cNvPr>
@@ -4735,7 +4735,7 @@
           <p:cNvPr id="4" name="Layout_Divider">
             <a:extLst xmlns:a="http://schemas.openxmlformats.org/drawingml/2006/main">
               <a:ext uri="{FF2B5EF4-FFF2-40B4-BE49-F238E27FC236}">
-                <a16:creationId xmlns:a16="http://schemas.microsoft.com/office/drawing/2014/main" id="{EE461D29-DC0D-4BC6-8F05-2F63098D2847}"/>
+                <a16:creationId xmlns:a16="http://schemas.microsoft.com/office/drawing/2014/main" id="{C154E09E-C726-4E6C-8C00-7CFE91DBAB6B}"/>
               </a:ext>
             </a:extLst>
           </p:cNvPr>
@@ -4766,7 +4766,7 @@
           <p:cNvPr id="2" name="Layout_Footer">
             <a:extLst xmlns:a="http://schemas.openxmlformats.org/drawingml/2006/main">
               <a:ext uri="{FF2B5EF4-FFF2-40B4-BE49-F238E27FC236}">
-                <a16:creationId xmlns:a16="http://schemas.microsoft.com/office/drawing/2014/main" id="{5BBB6F9B-3C7F-4405-91D9-0FE25DFFE3EB}"/>
+                <a16:creationId xmlns:a16="http://schemas.microsoft.com/office/drawing/2014/main" id="{3AAECE1E-FAB6-4257-9657-06793EB8A7D4}"/>
               </a:ext>
             </a:extLst>
           </p:cNvPr>
@@ -4924,7 +4924,7 @@
           <p:cNvPr id="3" name="Layout_PageNumber">
             <a:extLst xmlns:a="http://schemas.openxmlformats.org/drawingml/2006/main">
               <a:ext uri="{FF2B5EF4-FFF2-40B4-BE49-F238E27FC236}">
-                <a16:creationId xmlns:a16="http://schemas.microsoft.com/office/drawing/2014/main" id="{F13874DD-2012-4A59-8EBB-F94A2EB5B178}"/>
+                <a16:creationId xmlns:a16="http://schemas.microsoft.com/office/drawing/2014/main" id="{5E33C388-7DEA-4FC2-B651-1AC5AA952EE0}"/>
               </a:ext>
             </a:extLst>
           </p:cNvPr>
@@ -5099,7 +5099,7 @@
           <p:cNvPr id="4" name="Layout_Divider">
             <a:extLst xmlns:a="http://schemas.openxmlformats.org/drawingml/2006/main">
               <a:ext uri="{FF2B5EF4-FFF2-40B4-BE49-F238E27FC236}">
-                <a16:creationId xmlns:a16="http://schemas.microsoft.com/office/drawing/2014/main" id="{52B67E8D-2229-46FB-9F1B-21306DACF7BB}"/>
+                <a16:creationId xmlns:a16="http://schemas.microsoft.com/office/drawing/2014/main" id="{E4210654-9DC0-4397-B117-3631BA1A9C25}"/>
               </a:ext>
             </a:extLst>
           </p:cNvPr>
@@ -5130,7 +5130,7 @@
           <p:cNvPr id="2" name="Layout_Footer">
             <a:extLst xmlns:a="http://schemas.openxmlformats.org/drawingml/2006/main">
               <a:ext uri="{FF2B5EF4-FFF2-40B4-BE49-F238E27FC236}">
-                <a16:creationId xmlns:a16="http://schemas.microsoft.com/office/drawing/2014/main" id="{22E9D790-47C0-4AE4-A2DB-E5AC0E5A2EB4}"/>
+                <a16:creationId xmlns:a16="http://schemas.microsoft.com/office/drawing/2014/main" id="{6CAA744C-49CA-4A19-A6C2-6BF541179923}"/>
               </a:ext>
             </a:extLst>
           </p:cNvPr>
@@ -5288,7 +5288,7 @@
           <p:cNvPr id="3" name="Layout_PageNumber">
             <a:extLst xmlns:a="http://schemas.openxmlformats.org/drawingml/2006/main">
               <a:ext uri="{FF2B5EF4-FFF2-40B4-BE49-F238E27FC236}">
-                <a16:creationId xmlns:a16="http://schemas.microsoft.com/office/drawing/2014/main" id="{A53792F7-9962-4A74-8884-C1EEA28ED057}"/>
+                <a16:creationId xmlns:a16="http://schemas.microsoft.com/office/drawing/2014/main" id="{E1C782D8-D54C-4984-B039-CBBB396CC34F}"/>
               </a:ext>
             </a:extLst>
           </p:cNvPr>
@@ -5467,17 +5467,17 @@
   </p:cSld>
   <p:clrMap bg1="lt1" tx1="dk1" bg2="lt2" tx2="dk2" accent1="accent1" accent2="accent2" accent3="accent3" accent4="accent4" accent5="accent5" accent6="accent6" hlink="hlink" folHlink="folHlink"/>
   <p:sldLayoutIdLst>
-    <p:sldLayoutId xmlns:r="http://schemas.openxmlformats.org/officeDocument/2006/relationships" id="2147483649" r:id="R9b14d485b547436e"/>
-    <p:sldLayoutId xmlns:r="http://schemas.openxmlformats.org/officeDocument/2006/relationships" id="2147483650" r:id="R936311225139412f"/>
-    <p:sldLayoutId xmlns:r="http://schemas.openxmlformats.org/officeDocument/2006/relationships" id="2147483651" r:id="R1bba70faee8f4b37"/>
-    <p:sldLayoutId xmlns:r="http://schemas.openxmlformats.org/officeDocument/2006/relationships" id="2147483652" r:id="R2bd48b6f2cec4e32"/>
-    <p:sldLayoutId xmlns:r="http://schemas.openxmlformats.org/officeDocument/2006/relationships" id="2147483653" r:id="R0962ca0caf30420e"/>
-    <p:sldLayoutId xmlns:r="http://schemas.openxmlformats.org/officeDocument/2006/relationships" id="2147483654" r:id="R3b0cf138d850421f"/>
-    <p:sldLayoutId xmlns:r="http://schemas.openxmlformats.org/officeDocument/2006/relationships" id="2147483655" r:id="R5f22ee1ab2194ee5"/>
-    <p:sldLayoutId xmlns:r="http://schemas.openxmlformats.org/officeDocument/2006/relationships" id="2147483656" r:id="R5ce10d1c54654d79"/>
-    <p:sldLayoutId xmlns:r="http://schemas.openxmlformats.org/officeDocument/2006/relationships" id="2147483657" r:id="R17274aec887b48a5"/>
-    <p:sldLayoutId xmlns:r="http://schemas.openxmlformats.org/officeDocument/2006/relationships" id="2147483658" r:id="R7acdfa63310640a0"/>
-    <p:sldLayoutId xmlns:r="http://schemas.openxmlformats.org/officeDocument/2006/relationships" id="2147483659" r:id="R7ef12a87db8549c1"/>
+    <p:sldLayoutId xmlns:r="http://schemas.openxmlformats.org/officeDocument/2006/relationships" id="2147483649" r:id="Rc5fd84240dfc455c"/>
+    <p:sldLayoutId xmlns:r="http://schemas.openxmlformats.org/officeDocument/2006/relationships" id="2147483650" r:id="Rcdc4ed1303aa45ce"/>
+    <p:sldLayoutId xmlns:r="http://schemas.openxmlformats.org/officeDocument/2006/relationships" id="2147483651" r:id="R047d3afa2d9740a0"/>
+    <p:sldLayoutId xmlns:r="http://schemas.openxmlformats.org/officeDocument/2006/relationships" id="2147483652" r:id="Ra302de8f63394927"/>
+    <p:sldLayoutId xmlns:r="http://schemas.openxmlformats.org/officeDocument/2006/relationships" id="2147483653" r:id="R0cfc28b2a0384f72"/>
+    <p:sldLayoutId xmlns:r="http://schemas.openxmlformats.org/officeDocument/2006/relationships" id="2147483654" r:id="R5a168920aaf941c7"/>
+    <p:sldLayoutId xmlns:r="http://schemas.openxmlformats.org/officeDocument/2006/relationships" id="2147483655" r:id="Rd374b80323f44307"/>
+    <p:sldLayoutId xmlns:r="http://schemas.openxmlformats.org/officeDocument/2006/relationships" id="2147483656" r:id="R05453e16e1eb46f1"/>
+    <p:sldLayoutId xmlns:r="http://schemas.openxmlformats.org/officeDocument/2006/relationships" id="2147483657" r:id="R2dd8180ff3a3441b"/>
+    <p:sldLayoutId xmlns:r="http://schemas.openxmlformats.org/officeDocument/2006/relationships" id="2147483658" r:id="R48e4e4396ee140b9"/>
+    <p:sldLayoutId xmlns:r="http://schemas.openxmlformats.org/officeDocument/2006/relationships" id="2147483659" r:id="R6656a7a73b3b4b42"/>
   </p:sldLayoutIdLst>
   <p:txStyles>
     <p:titleStyle>
@@ -6028,7 +6028,7 @@
           <p:cNvPr id="37" name="Slide_Title">
             <a:extLst xmlns:a="http://schemas.openxmlformats.org/drawingml/2006/main">
               <a:ext uri="{FF2B5EF4-FFF2-40B4-BE49-F238E27FC236}">
-                <a16:creationId xmlns:a16="http://schemas.microsoft.com/office/drawing/2014/main" id="{4680D3D3-EBB1-43CC-8444-256DD4728970}"/>
+                <a16:creationId xmlns:a16="http://schemas.microsoft.com/office/drawing/2014/main" id="{6B318F80-3727-4069-8DFF-7D97771F56EA}"/>
               </a:ext>
             </a:extLst>
           </p:cNvPr>
@@ -6186,7 +6186,7 @@
           <p:cNvPr id="2" name="Slide_Subtitle">
             <a:extLst xmlns:a="http://schemas.openxmlformats.org/drawingml/2006/main">
               <a:ext uri="{FF2B5EF4-FFF2-40B4-BE49-F238E27FC236}">
-                <a16:creationId xmlns:a16="http://schemas.microsoft.com/office/drawing/2014/main" id="{AD909BA6-0A4B-432B-9C63-30698DFE22E7}"/>
+                <a16:creationId xmlns:a16="http://schemas.microsoft.com/office/drawing/2014/main" id="{920B0482-9D3C-4892-BC16-0AF2EC3100CD}"/>
               </a:ext>
             </a:extLst>
           </p:cNvPr>
@@ -6344,7 +6344,7 @@
           <p:cNvPr id="3" name="S1_Flow_1">
             <a:extLst xmlns:a="http://schemas.openxmlformats.org/drawingml/2006/main">
               <a:ext uri="{FF2B5EF4-FFF2-40B4-BE49-F238E27FC236}">
-                <a16:creationId xmlns:a16="http://schemas.microsoft.com/office/drawing/2014/main" id="{A5D85E21-53E4-4EFB-BBA1-18242098B5C0}"/>
+                <a16:creationId xmlns:a16="http://schemas.microsoft.com/office/drawing/2014/main" id="{788952B1-871F-4485-902C-AA8FF5B4143B}"/>
               </a:ext>
             </a:extLst>
           </p:cNvPr>
@@ -6379,7 +6379,7 @@
           <p:cNvPr id="4" name="S1_FlowIcon_1">
             <a:extLst xmlns:a="http://schemas.openxmlformats.org/drawingml/2006/main">
               <a:ext uri="{FF2B5EF4-FFF2-40B4-BE49-F238E27FC236}">
-                <a16:creationId xmlns:a16="http://schemas.microsoft.com/office/drawing/2014/main" id="{30D0BEB0-CB8F-47AB-963F-BE13D370B79E}"/>
+                <a16:creationId xmlns:a16="http://schemas.microsoft.com/office/drawing/2014/main" id="{DD7BF85B-1616-4E23-8EA9-9EEF497BD4D6}"/>
               </a:ext>
             </a:extLst>
           </p:cNvPr>
@@ -6540,7 +6540,7 @@
           <p:cNvPr id="5" name="S1_FlowLabel_1">
             <a:extLst xmlns:a="http://schemas.openxmlformats.org/drawingml/2006/main">
               <a:ext uri="{FF2B5EF4-FFF2-40B4-BE49-F238E27FC236}">
-                <a16:creationId xmlns:a16="http://schemas.microsoft.com/office/drawing/2014/main" id="{E44A0345-F8D6-44B7-A3B3-4B073172FBE6}"/>
+                <a16:creationId xmlns:a16="http://schemas.microsoft.com/office/drawing/2014/main" id="{D4723D74-B9F8-4DE2-86A2-F55A2E3A6002}"/>
               </a:ext>
             </a:extLst>
           </p:cNvPr>
@@ -6698,7 +6698,7 @@
           <p:cNvPr id="6" name="S1_FlowRule_1">
             <a:extLst xmlns:a="http://schemas.openxmlformats.org/drawingml/2006/main">
               <a:ext uri="{FF2B5EF4-FFF2-40B4-BE49-F238E27FC236}">
-                <a16:creationId xmlns:a16="http://schemas.microsoft.com/office/drawing/2014/main" id="{D58838B7-0ABF-4ACE-B5DA-73C2DE79B1EB}"/>
+                <a16:creationId xmlns:a16="http://schemas.microsoft.com/office/drawing/2014/main" id="{05873335-0B70-4FC2-A0E4-9C09519B2C6D}"/>
               </a:ext>
             </a:extLst>
           </p:cNvPr>
@@ -6729,7 +6729,7 @@
           <p:cNvPr id="7" name="S1_FlowPain_1">
             <a:extLst xmlns:a="http://schemas.openxmlformats.org/drawingml/2006/main">
               <a:ext uri="{FF2B5EF4-FFF2-40B4-BE49-F238E27FC236}">
-                <a16:creationId xmlns:a16="http://schemas.microsoft.com/office/drawing/2014/main" id="{F7A0AD77-D298-4880-BEBC-54BD841D9602}"/>
+                <a16:creationId xmlns:a16="http://schemas.microsoft.com/office/drawing/2014/main" id="{94B71277-974C-41B7-8DF1-8518E0BDE82A}"/>
               </a:ext>
             </a:extLst>
           </p:cNvPr>
@@ -6887,7 +6887,7 @@
           <p:cNvPr id="8" name="S1_Arrow_1">
             <a:extLst xmlns:a="http://schemas.openxmlformats.org/drawingml/2006/main">
               <a:ext uri="{FF2B5EF4-FFF2-40B4-BE49-F238E27FC236}">
-                <a16:creationId xmlns:a16="http://schemas.microsoft.com/office/drawing/2014/main" id="{6FD57036-C50E-4937-9C7A-9AB5B0E8E280}"/>
+                <a16:creationId xmlns:a16="http://schemas.microsoft.com/office/drawing/2014/main" id="{7E8C1DEF-34DB-49DF-851E-FD193A1AF765}"/>
               </a:ext>
             </a:extLst>
           </p:cNvPr>
@@ -6919,7 +6919,7 @@
           <p:cNvPr id="9" name="S1_Flow_2">
             <a:extLst xmlns:a="http://schemas.openxmlformats.org/drawingml/2006/main">
               <a:ext uri="{FF2B5EF4-FFF2-40B4-BE49-F238E27FC236}">
-                <a16:creationId xmlns:a16="http://schemas.microsoft.com/office/drawing/2014/main" id="{1635E87E-E8BE-4BE3-B0D5-FF97B7010BDA}"/>
+                <a16:creationId xmlns:a16="http://schemas.microsoft.com/office/drawing/2014/main" id="{FE28981B-7ECE-4829-A483-C2EE4EA94082}"/>
               </a:ext>
             </a:extLst>
           </p:cNvPr>
@@ -6954,7 +6954,7 @@
           <p:cNvPr id="10" name="S1_FlowIcon_2">
             <a:extLst xmlns:a="http://schemas.openxmlformats.org/drawingml/2006/main">
               <a:ext uri="{FF2B5EF4-FFF2-40B4-BE49-F238E27FC236}">
-                <a16:creationId xmlns:a16="http://schemas.microsoft.com/office/drawing/2014/main" id="{F82D5AA6-8A88-4C17-91FF-FC1FA9B9C475}"/>
+                <a16:creationId xmlns:a16="http://schemas.microsoft.com/office/drawing/2014/main" id="{5984069F-1E90-47E2-846B-93C67139673C}"/>
               </a:ext>
             </a:extLst>
           </p:cNvPr>
@@ -7115,7 +7115,7 @@
           <p:cNvPr id="11" name="S1_FlowLabel_2">
             <a:extLst xmlns:a="http://schemas.openxmlformats.org/drawingml/2006/main">
               <a:ext uri="{FF2B5EF4-FFF2-40B4-BE49-F238E27FC236}">
-                <a16:creationId xmlns:a16="http://schemas.microsoft.com/office/drawing/2014/main" id="{C62B85C8-D23B-4776-810A-A0C2C5C9D2AD}"/>
+                <a16:creationId xmlns:a16="http://schemas.microsoft.com/office/drawing/2014/main" id="{FFDB831D-A42B-4AF8-A552-ED9C62D86326}"/>
               </a:ext>
             </a:extLst>
           </p:cNvPr>
@@ -7273,7 +7273,7 @@
           <p:cNvPr id="12" name="S1_FlowRule_2">
             <a:extLst xmlns:a="http://schemas.openxmlformats.org/drawingml/2006/main">
               <a:ext uri="{FF2B5EF4-FFF2-40B4-BE49-F238E27FC236}">
-                <a16:creationId xmlns:a16="http://schemas.microsoft.com/office/drawing/2014/main" id="{7FF3BB1A-FE52-4AFE-9C9F-511E574734B2}"/>
+                <a16:creationId xmlns:a16="http://schemas.microsoft.com/office/drawing/2014/main" id="{D3F8D3BC-123B-4D9C-B065-ACB881967BF5}"/>
               </a:ext>
             </a:extLst>
           </p:cNvPr>
@@ -7304,7 +7304,7 @@
           <p:cNvPr id="13" name="S1_FlowPain_2">
             <a:extLst xmlns:a="http://schemas.openxmlformats.org/drawingml/2006/main">
               <a:ext uri="{FF2B5EF4-FFF2-40B4-BE49-F238E27FC236}">
-                <a16:creationId xmlns:a16="http://schemas.microsoft.com/office/drawing/2014/main" id="{85BEF643-3C59-4E36-9365-F6AEE5805B31}"/>
+                <a16:creationId xmlns:a16="http://schemas.microsoft.com/office/drawing/2014/main" id="{F9B69E6C-61EB-4F1A-BDFC-3845787EC0BF}"/>
               </a:ext>
             </a:extLst>
           </p:cNvPr>
@@ -7462,7 +7462,7 @@
           <p:cNvPr id="14" name="S1_Arrow_2">
             <a:extLst xmlns:a="http://schemas.openxmlformats.org/drawingml/2006/main">
               <a:ext uri="{FF2B5EF4-FFF2-40B4-BE49-F238E27FC236}">
-                <a16:creationId xmlns:a16="http://schemas.microsoft.com/office/drawing/2014/main" id="{A10CC5E7-AE42-4F68-B9A3-D5F3E7E21E7D}"/>
+                <a16:creationId xmlns:a16="http://schemas.microsoft.com/office/drawing/2014/main" id="{8211CD97-CD12-4ED5-8818-4B385377070A}"/>
               </a:ext>
             </a:extLst>
           </p:cNvPr>
@@ -7494,7 +7494,7 @@
           <p:cNvPr id="15" name="S1_Flow_3">
             <a:extLst xmlns:a="http://schemas.openxmlformats.org/drawingml/2006/main">
               <a:ext uri="{FF2B5EF4-FFF2-40B4-BE49-F238E27FC236}">
-                <a16:creationId xmlns:a16="http://schemas.microsoft.com/office/drawing/2014/main" id="{4F392437-97B6-47E7-8973-4373BBF00E36}"/>
+                <a16:creationId xmlns:a16="http://schemas.microsoft.com/office/drawing/2014/main" id="{A8F7D0EB-3965-4151-A5BF-1BBD4E969882}"/>
               </a:ext>
             </a:extLst>
           </p:cNvPr>
@@ -7529,7 +7529,7 @@
           <p:cNvPr id="16" name="S1_FlowIcon_3">
             <a:extLst xmlns:a="http://schemas.openxmlformats.org/drawingml/2006/main">
               <a:ext uri="{FF2B5EF4-FFF2-40B4-BE49-F238E27FC236}">
-                <a16:creationId xmlns:a16="http://schemas.microsoft.com/office/drawing/2014/main" id="{6ECCD750-0288-45BC-96AB-341F71ED0B99}"/>
+                <a16:creationId xmlns:a16="http://schemas.microsoft.com/office/drawing/2014/main" id="{F6C2DC5A-0970-4565-8E35-0AA4FEA250A4}"/>
               </a:ext>
             </a:extLst>
           </p:cNvPr>
@@ -7690,7 +7690,7 @@
           <p:cNvPr id="17" name="S1_FlowLabel_3">
             <a:extLst xmlns:a="http://schemas.openxmlformats.org/drawingml/2006/main">
               <a:ext uri="{FF2B5EF4-FFF2-40B4-BE49-F238E27FC236}">
-                <a16:creationId xmlns:a16="http://schemas.microsoft.com/office/drawing/2014/main" id="{FC7D6E9A-EFBE-47D4-BE4D-84DE2597649D}"/>
+                <a16:creationId xmlns:a16="http://schemas.microsoft.com/office/drawing/2014/main" id="{D23BC839-36C0-4F5C-8AAE-EDC4D7247295}"/>
               </a:ext>
             </a:extLst>
           </p:cNvPr>
@@ -7848,7 +7848,7 @@
           <p:cNvPr id="18" name="S1_FlowRule_3">
             <a:extLst xmlns:a="http://schemas.openxmlformats.org/drawingml/2006/main">
               <a:ext uri="{FF2B5EF4-FFF2-40B4-BE49-F238E27FC236}">
-                <a16:creationId xmlns:a16="http://schemas.microsoft.com/office/drawing/2014/main" id="{523E1FD2-B8BD-4C52-B2A4-886B8A9D1509}"/>
+                <a16:creationId xmlns:a16="http://schemas.microsoft.com/office/drawing/2014/main" id="{9C3E96EA-5D05-41CB-8DB1-F1DF19B80670}"/>
               </a:ext>
             </a:extLst>
           </p:cNvPr>
@@ -7879,7 +7879,7 @@
           <p:cNvPr id="19" name="S1_FlowPain_3">
             <a:extLst xmlns:a="http://schemas.openxmlformats.org/drawingml/2006/main">
               <a:ext uri="{FF2B5EF4-FFF2-40B4-BE49-F238E27FC236}">
-                <a16:creationId xmlns:a16="http://schemas.microsoft.com/office/drawing/2014/main" id="{66176575-B859-41D9-A76E-EDEBD60A6D21}"/>
+                <a16:creationId xmlns:a16="http://schemas.microsoft.com/office/drawing/2014/main" id="{183D64BC-635C-4948-8CEB-AD81A539D5BC}"/>
               </a:ext>
             </a:extLst>
           </p:cNvPr>
@@ -8037,7 +8037,7 @@
           <p:cNvPr id="20" name="S1_Arrow_3">
             <a:extLst xmlns:a="http://schemas.openxmlformats.org/drawingml/2006/main">
               <a:ext uri="{FF2B5EF4-FFF2-40B4-BE49-F238E27FC236}">
-                <a16:creationId xmlns:a16="http://schemas.microsoft.com/office/drawing/2014/main" id="{59D9A4A0-83DA-4CD8-B2D5-172CDD82B049}"/>
+                <a16:creationId xmlns:a16="http://schemas.microsoft.com/office/drawing/2014/main" id="{D8BB2769-E250-4D78-BA53-F4ACDD9C1C56}"/>
               </a:ext>
             </a:extLst>
           </p:cNvPr>
@@ -8069,7 +8069,7 @@
           <p:cNvPr id="21" name="S1_Flow_4">
             <a:extLst xmlns:a="http://schemas.openxmlformats.org/drawingml/2006/main">
               <a:ext uri="{FF2B5EF4-FFF2-40B4-BE49-F238E27FC236}">
-                <a16:creationId xmlns:a16="http://schemas.microsoft.com/office/drawing/2014/main" id="{AC2CB673-D520-47E1-835A-EC4B73DC66A3}"/>
+                <a16:creationId xmlns:a16="http://schemas.microsoft.com/office/drawing/2014/main" id="{E38574FB-DCA3-4F42-8DDA-C0239ED1F0C1}"/>
               </a:ext>
             </a:extLst>
           </p:cNvPr>
@@ -8104,7 +8104,7 @@
           <p:cNvPr id="22" name="S1_FlowIcon_4">
             <a:extLst xmlns:a="http://schemas.openxmlformats.org/drawingml/2006/main">
               <a:ext uri="{FF2B5EF4-FFF2-40B4-BE49-F238E27FC236}">
-                <a16:creationId xmlns:a16="http://schemas.microsoft.com/office/drawing/2014/main" id="{00832B9D-548E-4DE9-9EBF-7137458A08DB}"/>
+                <a16:creationId xmlns:a16="http://schemas.microsoft.com/office/drawing/2014/main" id="{EF5FDA22-31E3-4304-9852-0EA59F643B9C}"/>
               </a:ext>
             </a:extLst>
           </p:cNvPr>
@@ -8265,7 +8265,7 @@
           <p:cNvPr id="23" name="S1_FlowLabel_4">
             <a:extLst xmlns:a="http://schemas.openxmlformats.org/drawingml/2006/main">
               <a:ext uri="{FF2B5EF4-FFF2-40B4-BE49-F238E27FC236}">
-                <a16:creationId xmlns:a16="http://schemas.microsoft.com/office/drawing/2014/main" id="{1B8D138E-D806-47F3-9FC1-81B4F33E4C36}"/>
+                <a16:creationId xmlns:a16="http://schemas.microsoft.com/office/drawing/2014/main" id="{3D2DDEBB-6070-4B7B-969E-6C6BF3228C9E}"/>
               </a:ext>
             </a:extLst>
           </p:cNvPr>
@@ -8423,7 +8423,7 @@
           <p:cNvPr id="24" name="S1_FlowRule_4">
             <a:extLst xmlns:a="http://schemas.openxmlformats.org/drawingml/2006/main">
               <a:ext uri="{FF2B5EF4-FFF2-40B4-BE49-F238E27FC236}">
-                <a16:creationId xmlns:a16="http://schemas.microsoft.com/office/drawing/2014/main" id="{E366AA38-3D13-42AC-9EC1-814278CAD7F6}"/>
+                <a16:creationId xmlns:a16="http://schemas.microsoft.com/office/drawing/2014/main" id="{76599961-8AA8-43D4-822B-EC6858C49BEA}"/>
               </a:ext>
             </a:extLst>
           </p:cNvPr>
@@ -8454,7 +8454,7 @@
           <p:cNvPr id="25" name="S1_FlowPain_4">
             <a:extLst xmlns:a="http://schemas.openxmlformats.org/drawingml/2006/main">
               <a:ext uri="{FF2B5EF4-FFF2-40B4-BE49-F238E27FC236}">
-                <a16:creationId xmlns:a16="http://schemas.microsoft.com/office/drawing/2014/main" id="{D487F806-5DB3-4735-B21E-25D7F7C09E9E}"/>
+                <a16:creationId xmlns:a16="http://schemas.microsoft.com/office/drawing/2014/main" id="{BC640636-2919-4A3F-A830-2EEC9516286C}"/>
               </a:ext>
             </a:extLst>
           </p:cNvPr>
@@ -8612,7 +8612,7 @@
           <p:cNvPr id="26" name="S1_Arrow_4">
             <a:extLst xmlns:a="http://schemas.openxmlformats.org/drawingml/2006/main">
               <a:ext uri="{FF2B5EF4-FFF2-40B4-BE49-F238E27FC236}">
-                <a16:creationId xmlns:a16="http://schemas.microsoft.com/office/drawing/2014/main" id="{D7576B47-A005-46AA-A8CD-13A79A0D0058}"/>
+                <a16:creationId xmlns:a16="http://schemas.microsoft.com/office/drawing/2014/main" id="{86F9A40E-25B7-4334-9245-23DB38AD40DD}"/>
               </a:ext>
             </a:extLst>
           </p:cNvPr>
@@ -8644,7 +8644,7 @@
           <p:cNvPr id="27" name="S1_Flow_5">
             <a:extLst xmlns:a="http://schemas.openxmlformats.org/drawingml/2006/main">
               <a:ext uri="{FF2B5EF4-FFF2-40B4-BE49-F238E27FC236}">
-                <a16:creationId xmlns:a16="http://schemas.microsoft.com/office/drawing/2014/main" id="{F2ABAD13-1050-437F-95B8-93F0EC16C1C5}"/>
+                <a16:creationId xmlns:a16="http://schemas.microsoft.com/office/drawing/2014/main" id="{659EC34B-9826-4B9D-9E08-FF62A6DF25D5}"/>
               </a:ext>
             </a:extLst>
           </p:cNvPr>
@@ -8679,7 +8679,7 @@
           <p:cNvPr id="28" name="S1_FlowIcon_5">
             <a:extLst xmlns:a="http://schemas.openxmlformats.org/drawingml/2006/main">
               <a:ext uri="{FF2B5EF4-FFF2-40B4-BE49-F238E27FC236}">
-                <a16:creationId xmlns:a16="http://schemas.microsoft.com/office/drawing/2014/main" id="{D0C6E4F3-966D-4780-A971-E1669FB51EDE}"/>
+                <a16:creationId xmlns:a16="http://schemas.microsoft.com/office/drawing/2014/main" id="{8A7CEBB0-0E8A-47BF-B7BF-6299D381B47F}"/>
               </a:ext>
             </a:extLst>
           </p:cNvPr>
@@ -8840,7 +8840,7 @@
           <p:cNvPr id="29" name="S1_FlowLabel_5">
             <a:extLst xmlns:a="http://schemas.openxmlformats.org/drawingml/2006/main">
               <a:ext uri="{FF2B5EF4-FFF2-40B4-BE49-F238E27FC236}">
-                <a16:creationId xmlns:a16="http://schemas.microsoft.com/office/drawing/2014/main" id="{CE2DC8CA-3B45-4475-91EB-A3EA2E937C7C}"/>
+                <a16:creationId xmlns:a16="http://schemas.microsoft.com/office/drawing/2014/main" id="{3BA130D2-63EF-4AB5-82D8-4AED838B8587}"/>
               </a:ext>
             </a:extLst>
           </p:cNvPr>
@@ -8998,7 +8998,7 @@
           <p:cNvPr id="30" name="S1_FlowRule_5">
             <a:extLst xmlns:a="http://schemas.openxmlformats.org/drawingml/2006/main">
               <a:ext uri="{FF2B5EF4-FFF2-40B4-BE49-F238E27FC236}">
-                <a16:creationId xmlns:a16="http://schemas.microsoft.com/office/drawing/2014/main" id="{499211A5-C0A4-41D3-B0C3-01DDA4F076AB}"/>
+                <a16:creationId xmlns:a16="http://schemas.microsoft.com/office/drawing/2014/main" id="{6B0FAE70-6266-459B-848F-BF486DE3ADD5}"/>
               </a:ext>
             </a:extLst>
           </p:cNvPr>
@@ -9029,7 +9029,7 @@
           <p:cNvPr id="31" name="S1_FlowPain_5">
             <a:extLst xmlns:a="http://schemas.openxmlformats.org/drawingml/2006/main">
               <a:ext uri="{FF2B5EF4-FFF2-40B4-BE49-F238E27FC236}">
-                <a16:creationId xmlns:a16="http://schemas.microsoft.com/office/drawing/2014/main" id="{8E6CFB3A-A1A6-47CC-B188-63E417100482}"/>
+                <a16:creationId xmlns:a16="http://schemas.microsoft.com/office/drawing/2014/main" id="{089E4613-CC10-4FC8-96E8-58A194D8A32F}"/>
               </a:ext>
             </a:extLst>
           </p:cNvPr>
@@ -9187,7 +9187,7 @@
           <p:cNvPr id="32" name="S1_GapBand">
             <a:extLst xmlns:a="http://schemas.openxmlformats.org/drawingml/2006/main">
               <a:ext uri="{FF2B5EF4-FFF2-40B4-BE49-F238E27FC236}">
-                <a16:creationId xmlns:a16="http://schemas.microsoft.com/office/drawing/2014/main" id="{CE87BBCE-12EC-49FD-826C-55CE550E92A6}"/>
+                <a16:creationId xmlns:a16="http://schemas.microsoft.com/office/drawing/2014/main" id="{9EF873A6-B5E9-4B31-9F86-9B032C1B3D17}"/>
               </a:ext>
             </a:extLst>
           </p:cNvPr>
@@ -9222,7 +9222,7 @@
           <p:cNvPr id="33" name="S1_GapLabel">
             <a:extLst xmlns:a="http://schemas.openxmlformats.org/drawingml/2006/main">
               <a:ext uri="{FF2B5EF4-FFF2-40B4-BE49-F238E27FC236}">
-                <a16:creationId xmlns:a16="http://schemas.microsoft.com/office/drawing/2014/main" id="{9EAE55B7-1721-4A5E-BAEB-1B01350A6B73}"/>
+                <a16:creationId xmlns:a16="http://schemas.microsoft.com/office/drawing/2014/main" id="{C0F0419F-0C69-4839-86E5-FDD96F3A38A0}"/>
               </a:ext>
             </a:extLst>
           </p:cNvPr>
@@ -9380,7 +9380,7 @@
           <p:cNvPr id="34" name="S1_GapText">
             <a:extLst xmlns:a="http://schemas.openxmlformats.org/drawingml/2006/main">
               <a:ext uri="{FF2B5EF4-FFF2-40B4-BE49-F238E27FC236}">
-                <a16:creationId xmlns:a16="http://schemas.microsoft.com/office/drawing/2014/main" id="{7CDE11CC-881B-4E12-BFA3-E2B4D661854F}"/>
+                <a16:creationId xmlns:a16="http://schemas.microsoft.com/office/drawing/2014/main" id="{F6AB1E76-77EB-45CD-91DD-925E2DC91B5A}"/>
               </a:ext>
             </a:extLst>
           </p:cNvPr>
@@ -9538,7 +9538,7 @@
           <p:cNvPr id="35" name="S1_BridgeRule">
             <a:extLst xmlns:a="http://schemas.openxmlformats.org/drawingml/2006/main">
               <a:ext uri="{FF2B5EF4-FFF2-40B4-BE49-F238E27FC236}">
-                <a16:creationId xmlns:a16="http://schemas.microsoft.com/office/drawing/2014/main" id="{456EDC5B-CC00-409A-A533-EAABD707E047}"/>
+                <a16:creationId xmlns:a16="http://schemas.microsoft.com/office/drawing/2014/main" id="{A631CAB5-E5AD-4E5C-AD66-88BDFFDF6594}"/>
               </a:ext>
             </a:extLst>
           </p:cNvPr>
@@ -9569,7 +9569,7 @@
           <p:cNvPr id="36" name="S1_Bridge">
             <a:extLst xmlns:a="http://schemas.openxmlformats.org/drawingml/2006/main">
               <a:ext uri="{FF2B5EF4-FFF2-40B4-BE49-F238E27FC236}">
-                <a16:creationId xmlns:a16="http://schemas.microsoft.com/office/drawing/2014/main" id="{24EFD390-722E-4215-BB53-096402D0B255}"/>
+                <a16:creationId xmlns:a16="http://schemas.microsoft.com/office/drawing/2014/main" id="{33897FF2-48D6-4833-8BB0-900ACD77C403}"/>
               </a:ext>
             </a:extLst>
           </p:cNvPr>
@@ -9725,7 +9725,7 @@
     </p:spTree>
     <p:extLst>
       <p:ext uri="{BB962C8B-B14F-4D97-AF65-F5344CB8AC3E}">
-        <p14:creationId xmlns:p14="http://schemas.microsoft.com/office/powerpoint/2010/main" val="1861432515"/>
+        <p14:creationId xmlns:p14="http://schemas.microsoft.com/office/powerpoint/2010/main" val="1063306165"/>
       </p:ext>
     </p:extLst>
   </p:cSld>
@@ -9756,7 +9756,7 @@
           <p:cNvPr id="41" name="Slide_Title">
             <a:extLst xmlns:a="http://schemas.openxmlformats.org/drawingml/2006/main">
               <a:ext uri="{FF2B5EF4-FFF2-40B4-BE49-F238E27FC236}">
-                <a16:creationId xmlns:a16="http://schemas.microsoft.com/office/drawing/2014/main" id="{36F0B2B9-A6DE-47A6-A544-5A73E3743025}"/>
+                <a16:creationId xmlns:a16="http://schemas.microsoft.com/office/drawing/2014/main" id="{1FEE5C2C-DE41-427B-84B9-421E6250ABCE}"/>
               </a:ext>
             </a:extLst>
           </p:cNvPr>
@@ -9914,7 +9914,7 @@
           <p:cNvPr id="2" name="Slide_Subtitle">
             <a:extLst xmlns:a="http://schemas.openxmlformats.org/drawingml/2006/main">
               <a:ext uri="{FF2B5EF4-FFF2-40B4-BE49-F238E27FC236}">
-                <a16:creationId xmlns:a16="http://schemas.microsoft.com/office/drawing/2014/main" id="{903426CA-1F10-4880-A982-6B6CD1465F4D}"/>
+                <a16:creationId xmlns:a16="http://schemas.microsoft.com/office/drawing/2014/main" id="{684E8B2E-B54E-4117-B2B3-E8ADC6E99C5E}"/>
               </a:ext>
             </a:extLst>
           </p:cNvPr>
@@ -10072,7 +10072,7 @@
           <p:cNvPr id="3" name="S2_Column_1">
             <a:extLst xmlns:a="http://schemas.openxmlformats.org/drawingml/2006/main">
               <a:ext uri="{FF2B5EF4-FFF2-40B4-BE49-F238E27FC236}">
-                <a16:creationId xmlns:a16="http://schemas.microsoft.com/office/drawing/2014/main" id="{16223B2B-9B33-443A-BA10-692687B55F89}"/>
+                <a16:creationId xmlns:a16="http://schemas.microsoft.com/office/drawing/2014/main" id="{2F7637F2-03EC-4149-B35B-C648C9645F70}"/>
               </a:ext>
             </a:extLst>
           </p:cNvPr>
@@ -10230,7 +10230,7 @@
           <p:cNvPr id="4" name="S2_Column_2">
             <a:extLst xmlns:a="http://schemas.openxmlformats.org/drawingml/2006/main">
               <a:ext uri="{FF2B5EF4-FFF2-40B4-BE49-F238E27FC236}">
-                <a16:creationId xmlns:a16="http://schemas.microsoft.com/office/drawing/2014/main" id="{118146E4-5BD2-4896-844B-2806D79C8780}"/>
+                <a16:creationId xmlns:a16="http://schemas.microsoft.com/office/drawing/2014/main" id="{F8526BAD-7554-4B02-BE66-5E3CC008018B}"/>
               </a:ext>
             </a:extLst>
           </p:cNvPr>
@@ -10388,7 +10388,7 @@
           <p:cNvPr id="5" name="S2_Column_3">
             <a:extLst xmlns:a="http://schemas.openxmlformats.org/drawingml/2006/main">
               <a:ext uri="{FF2B5EF4-FFF2-40B4-BE49-F238E27FC236}">
-                <a16:creationId xmlns:a16="http://schemas.microsoft.com/office/drawing/2014/main" id="{785BB230-9756-48AF-B04A-107C39A05DD1}"/>
+                <a16:creationId xmlns:a16="http://schemas.microsoft.com/office/drawing/2014/main" id="{B39FDD47-CB89-46B5-B53E-3BF0C0B419F4}"/>
               </a:ext>
             </a:extLst>
           </p:cNvPr>
@@ -10546,7 +10546,7 @@
           <p:cNvPr id="6" name="S2_SystemLabel">
             <a:extLst xmlns:a="http://schemas.openxmlformats.org/drawingml/2006/main">
               <a:ext uri="{FF2B5EF4-FFF2-40B4-BE49-F238E27FC236}">
-                <a16:creationId xmlns:a16="http://schemas.microsoft.com/office/drawing/2014/main" id="{B90650C9-1254-439E-B3F1-98B31954F4E5}"/>
+                <a16:creationId xmlns:a16="http://schemas.microsoft.com/office/drawing/2014/main" id="{94229307-6F64-482C-81EC-B888E4CBBE5B}"/>
               </a:ext>
             </a:extLst>
           </p:cNvPr>
@@ -10581,7 +10581,7 @@
           <p:cNvPr id="7" name="S2_SystemLabelText">
             <a:extLst xmlns:a="http://schemas.openxmlformats.org/drawingml/2006/main">
               <a:ext uri="{FF2B5EF4-FFF2-40B4-BE49-F238E27FC236}">
-                <a16:creationId xmlns:a16="http://schemas.microsoft.com/office/drawing/2014/main" id="{EE33B16A-6CFF-446D-A71C-08CECB415D24}"/>
+                <a16:creationId xmlns:a16="http://schemas.microsoft.com/office/drawing/2014/main" id="{449FFE4F-85C8-4E28-9016-A0265A19766C}"/>
               </a:ext>
             </a:extLst>
           </p:cNvPr>
@@ -10739,7 +10739,7 @@
           <p:cNvPr id="8" name="S2_HumanLabel">
             <a:extLst xmlns:a="http://schemas.openxmlformats.org/drawingml/2006/main">
               <a:ext uri="{FF2B5EF4-FFF2-40B4-BE49-F238E27FC236}">
-                <a16:creationId xmlns:a16="http://schemas.microsoft.com/office/drawing/2014/main" id="{2B00F420-B267-413A-B551-9546C3474205}"/>
+                <a16:creationId xmlns:a16="http://schemas.microsoft.com/office/drawing/2014/main" id="{943AF5D2-3DDE-4165-B311-8CB63AE7BE2B}"/>
               </a:ext>
             </a:extLst>
           </p:cNvPr>
@@ -10774,7 +10774,7 @@
           <p:cNvPr id="9" name="S2_HumanLabelText">
             <a:extLst xmlns:a="http://schemas.openxmlformats.org/drawingml/2006/main">
               <a:ext uri="{FF2B5EF4-FFF2-40B4-BE49-F238E27FC236}">
-                <a16:creationId xmlns:a16="http://schemas.microsoft.com/office/drawing/2014/main" id="{A9DA4495-2F0E-488A-AD05-0546A891E1EF}"/>
+                <a16:creationId xmlns:a16="http://schemas.microsoft.com/office/drawing/2014/main" id="{59AEAD67-FC4B-40DE-BE29-4CB13CFF3BF1}"/>
               </a:ext>
             </a:extLst>
           </p:cNvPr>
@@ -10932,7 +10932,7 @@
           <p:cNvPr id="10" name="S2_InputSystem">
             <a:extLst xmlns:a="http://schemas.openxmlformats.org/drawingml/2006/main">
               <a:ext uri="{FF2B5EF4-FFF2-40B4-BE49-F238E27FC236}">
-                <a16:creationId xmlns:a16="http://schemas.microsoft.com/office/drawing/2014/main" id="{72823BD9-8D64-48A2-BDEF-DF91F0740CBA}"/>
+                <a16:creationId xmlns:a16="http://schemas.microsoft.com/office/drawing/2014/main" id="{780E35C4-03C8-431F-9809-DA8E099641F9}"/>
               </a:ext>
             </a:extLst>
           </p:cNvPr>
@@ -10967,7 +10967,7 @@
           <p:cNvPr id="11" name="S2_PhaseA">
             <a:extLst xmlns:a="http://schemas.openxmlformats.org/drawingml/2006/main">
               <a:ext uri="{FF2B5EF4-FFF2-40B4-BE49-F238E27FC236}">
-                <a16:creationId xmlns:a16="http://schemas.microsoft.com/office/drawing/2014/main" id="{2E37F353-45AE-4AC1-8D7A-2767F6616CE7}"/>
+                <a16:creationId xmlns:a16="http://schemas.microsoft.com/office/drawing/2014/main" id="{0EC9C1BE-58B6-419E-8C6A-70E647AF17C1}"/>
               </a:ext>
             </a:extLst>
           </p:cNvPr>
@@ -11132,7 +11132,7 @@
           <p:cNvPr id="12" name="S2_PhaseATitle">
             <a:extLst xmlns:a="http://schemas.openxmlformats.org/drawingml/2006/main">
               <a:ext uri="{FF2B5EF4-FFF2-40B4-BE49-F238E27FC236}">
-                <a16:creationId xmlns:a16="http://schemas.microsoft.com/office/drawing/2014/main" id="{10E31B67-5229-4451-AC9C-569CCE178CB1}"/>
+                <a16:creationId xmlns:a16="http://schemas.microsoft.com/office/drawing/2014/main" id="{34A012D9-0CA2-4C24-AAD6-8D95521FC1CB}"/>
               </a:ext>
             </a:extLst>
           </p:cNvPr>
@@ -11280,7 +11280,7 @@
                 <a:ea typeface="Segoe UI"/>
                 <a:cs typeface="Segoe UI"/>
               </a:rPr>
-              <a:t>Nhận batch và xếp hàng</a:t>
+              <a:t>Nhận nhiều ảnh và xếp hàng</a:t>
             </a:r>
           </a:p>
         </p:txBody>
@@ -11290,7 +11290,7 @@
           <p:cNvPr id="13" name="S2_PhaseADetail">
             <a:extLst xmlns:a="http://schemas.openxmlformats.org/drawingml/2006/main">
               <a:ext uri="{FF2B5EF4-FFF2-40B4-BE49-F238E27FC236}">
-                <a16:creationId xmlns:a16="http://schemas.microsoft.com/office/drawing/2014/main" id="{8DDF11CA-9932-406D-9A36-E64E0892E68F}"/>
+                <a16:creationId xmlns:a16="http://schemas.microsoft.com/office/drawing/2014/main" id="{69900313-D168-4123-BD5C-399802668E9E}"/>
               </a:ext>
             </a:extLst>
           </p:cNvPr>
@@ -11517,7 +11517,7 @@
           <p:cNvPr id="14" name="S2_ProcessSystem">
             <a:extLst xmlns:a="http://schemas.openxmlformats.org/drawingml/2006/main">
               <a:ext uri="{FF2B5EF4-FFF2-40B4-BE49-F238E27FC236}">
-                <a16:creationId xmlns:a16="http://schemas.microsoft.com/office/drawing/2014/main" id="{3E8576DB-C058-4659-836A-858D29C565F7}"/>
+                <a16:creationId xmlns:a16="http://schemas.microsoft.com/office/drawing/2014/main" id="{E7238EEB-4604-4E02-A567-A2D933F0F725}"/>
               </a:ext>
             </a:extLst>
           </p:cNvPr>
@@ -11552,7 +11552,7 @@
           <p:cNvPr id="15" name="S2_PhaseB">
             <a:extLst xmlns:a="http://schemas.openxmlformats.org/drawingml/2006/main">
               <a:ext uri="{FF2B5EF4-FFF2-40B4-BE49-F238E27FC236}">
-                <a16:creationId xmlns:a16="http://schemas.microsoft.com/office/drawing/2014/main" id="{B34DD479-F3FE-4F51-8AF2-90BE9891135C}"/>
+                <a16:creationId xmlns:a16="http://schemas.microsoft.com/office/drawing/2014/main" id="{054EAA77-D91C-4D53-944D-B623D200BF0B}"/>
               </a:ext>
             </a:extLst>
           </p:cNvPr>
@@ -11717,7 +11717,7 @@
           <p:cNvPr id="16" name="S2_PhaseBDetail">
             <a:extLst xmlns:a="http://schemas.openxmlformats.org/drawingml/2006/main">
               <a:ext uri="{FF2B5EF4-FFF2-40B4-BE49-F238E27FC236}">
-                <a16:creationId xmlns:a16="http://schemas.microsoft.com/office/drawing/2014/main" id="{52EA8E1C-9C97-4556-AF79-7CB56506C993}"/>
+                <a16:creationId xmlns:a16="http://schemas.microsoft.com/office/drawing/2014/main" id="{A565058E-0F17-4C7A-A922-329F13E576FF}"/>
               </a:ext>
             </a:extLst>
           </p:cNvPr>
@@ -11898,7 +11898,7 @@
           <p:cNvPr id="17" name="S2_ProcessDivider">
             <a:extLst xmlns:a="http://schemas.openxmlformats.org/drawingml/2006/main">
               <a:ext uri="{FF2B5EF4-FFF2-40B4-BE49-F238E27FC236}">
-                <a16:creationId xmlns:a16="http://schemas.microsoft.com/office/drawing/2014/main" id="{B26C74B8-1730-483B-89F9-29008AEE0005}"/>
+                <a16:creationId xmlns:a16="http://schemas.microsoft.com/office/drawing/2014/main" id="{32BECF5A-5657-4F51-A8FB-098738B0BA5C}"/>
               </a:ext>
             </a:extLst>
           </p:cNvPr>
@@ -11929,7 +11929,7 @@
           <p:cNvPr id="18" name="S2_PhaseC">
             <a:extLst xmlns:a="http://schemas.openxmlformats.org/drawingml/2006/main">
               <a:ext uri="{FF2B5EF4-FFF2-40B4-BE49-F238E27FC236}">
-                <a16:creationId xmlns:a16="http://schemas.microsoft.com/office/drawing/2014/main" id="{D56FE4AD-C1CE-497D-A833-FE13AE79F62E}"/>
+                <a16:creationId xmlns:a16="http://schemas.microsoft.com/office/drawing/2014/main" id="{8124DB43-D658-496F-A3BF-DC93F5BD6F1B}"/>
               </a:ext>
             </a:extLst>
           </p:cNvPr>
@@ -12094,7 +12094,7 @@
           <p:cNvPr id="19" name="S2_PhaseCDetail">
             <a:extLst xmlns:a="http://schemas.openxmlformats.org/drawingml/2006/main">
               <a:ext uri="{FF2B5EF4-FFF2-40B4-BE49-F238E27FC236}">
-                <a16:creationId xmlns:a16="http://schemas.microsoft.com/office/drawing/2014/main" id="{A086AE30-27ED-415E-8DC3-7F8A9EA1C10C}"/>
+                <a16:creationId xmlns:a16="http://schemas.microsoft.com/office/drawing/2014/main" id="{142254E3-5C78-4221-8B37-D211B5D3A869}"/>
               </a:ext>
             </a:extLst>
           </p:cNvPr>
@@ -12275,7 +12275,7 @@
           <p:cNvPr id="20" name="S2_OutputSystem">
             <a:extLst xmlns:a="http://schemas.openxmlformats.org/drawingml/2006/main">
               <a:ext uri="{FF2B5EF4-FFF2-40B4-BE49-F238E27FC236}">
-                <a16:creationId xmlns:a16="http://schemas.microsoft.com/office/drawing/2014/main" id="{C9B76217-E7FF-43D8-88B8-BFE91A7CE328}"/>
+                <a16:creationId xmlns:a16="http://schemas.microsoft.com/office/drawing/2014/main" id="{9C92A9C2-92DD-4448-BD7D-8AA8A9F7FAEE}"/>
               </a:ext>
             </a:extLst>
           </p:cNvPr>
@@ -12310,7 +12310,7 @@
           <p:cNvPr id="21" name="S2_PhaseD">
             <a:extLst xmlns:a="http://schemas.openxmlformats.org/drawingml/2006/main">
               <a:ext uri="{FF2B5EF4-FFF2-40B4-BE49-F238E27FC236}">
-                <a16:creationId xmlns:a16="http://schemas.microsoft.com/office/drawing/2014/main" id="{8F928CCF-B4F6-4B37-9AAE-6EEDF37378F8}"/>
+                <a16:creationId xmlns:a16="http://schemas.microsoft.com/office/drawing/2014/main" id="{D9CFFD06-6B1F-44E8-8F68-7369B007A89D}"/>
               </a:ext>
             </a:extLst>
           </p:cNvPr>
@@ -12475,7 +12475,7 @@
           <p:cNvPr id="22" name="S2_PhaseDTitle">
             <a:extLst xmlns:a="http://schemas.openxmlformats.org/drawingml/2006/main">
               <a:ext uri="{FF2B5EF4-FFF2-40B4-BE49-F238E27FC236}">
-                <a16:creationId xmlns:a16="http://schemas.microsoft.com/office/drawing/2014/main" id="{55305E1A-C28E-4B03-9CF1-207D1CE10E24}"/>
+                <a16:creationId xmlns:a16="http://schemas.microsoft.com/office/drawing/2014/main" id="{4FF904BB-3672-4336-BC48-3C55F2FA018A}"/>
               </a:ext>
             </a:extLst>
           </p:cNvPr>
@@ -12633,7 +12633,7 @@
           <p:cNvPr id="23" name="S2_PhaseDDetail">
             <a:extLst xmlns:a="http://schemas.openxmlformats.org/drawingml/2006/main">
               <a:ext uri="{FF2B5EF4-FFF2-40B4-BE49-F238E27FC236}">
-                <a16:creationId xmlns:a16="http://schemas.microsoft.com/office/drawing/2014/main" id="{E00B4647-1CB4-43AD-8FCE-6C644F448B60}"/>
+                <a16:creationId xmlns:a16="http://schemas.microsoft.com/office/drawing/2014/main" id="{A86687E0-1CF9-4ECF-A372-C249991EB026}"/>
               </a:ext>
             </a:extLst>
           </p:cNvPr>
@@ -12814,7 +12814,7 @@
           <p:cNvPr id="24" name="S2_AutoBranch">
             <a:extLst xmlns:a="http://schemas.openxmlformats.org/drawingml/2006/main">
               <a:ext uri="{FF2B5EF4-FFF2-40B4-BE49-F238E27FC236}">
-                <a16:creationId xmlns:a16="http://schemas.microsoft.com/office/drawing/2014/main" id="{10488FBE-E3AC-45A1-B52D-045908513230}"/>
+                <a16:creationId xmlns:a16="http://schemas.microsoft.com/office/drawing/2014/main" id="{CF48E7AE-8B20-45E6-A3E1-04DA7481431B}"/>
               </a:ext>
             </a:extLst>
           </p:cNvPr>
@@ -12849,7 +12849,7 @@
           <p:cNvPr id="25" name="S2_AutoBranchText">
             <a:extLst xmlns:a="http://schemas.openxmlformats.org/drawingml/2006/main">
               <a:ext uri="{FF2B5EF4-FFF2-40B4-BE49-F238E27FC236}">
-                <a16:creationId xmlns:a16="http://schemas.microsoft.com/office/drawing/2014/main" id="{6C3C8729-47DD-4EBB-9C61-634EFF01A612}"/>
+                <a16:creationId xmlns:a16="http://schemas.microsoft.com/office/drawing/2014/main" id="{96A01E4D-B22E-4E42-9597-992C12353FB0}"/>
               </a:ext>
             </a:extLst>
           </p:cNvPr>
@@ -13030,7 +13030,7 @@
           <p:cNvPr id="26" name="S2_EscalateBranch">
             <a:extLst xmlns:a="http://schemas.openxmlformats.org/drawingml/2006/main">
               <a:ext uri="{FF2B5EF4-FFF2-40B4-BE49-F238E27FC236}">
-                <a16:creationId xmlns:a16="http://schemas.microsoft.com/office/drawing/2014/main" id="{088D97AD-48C3-4339-B7D8-9C92E71D5FE7}"/>
+                <a16:creationId xmlns:a16="http://schemas.microsoft.com/office/drawing/2014/main" id="{34571E99-F4D3-44E0-BCA8-2CAECDBD8E41}"/>
               </a:ext>
             </a:extLst>
           </p:cNvPr>
@@ -13065,7 +13065,7 @@
           <p:cNvPr id="27" name="S2_EscalateBranchText">
             <a:extLst xmlns:a="http://schemas.openxmlformats.org/drawingml/2006/main">
               <a:ext uri="{FF2B5EF4-FFF2-40B4-BE49-F238E27FC236}">
-                <a16:creationId xmlns:a16="http://schemas.microsoft.com/office/drawing/2014/main" id="{CA0B717D-0257-41D5-92D2-0F20EA893337}"/>
+                <a16:creationId xmlns:a16="http://schemas.microsoft.com/office/drawing/2014/main" id="{E1A73DBC-EF77-4B89-97E0-4BAA2B7AE80F}"/>
               </a:ext>
             </a:extLst>
           </p:cNvPr>
@@ -13246,7 +13246,7 @@
           <p:cNvPr id="28" name="S2_InputHuman">
             <a:extLst xmlns:a="http://schemas.openxmlformats.org/drawingml/2006/main">
               <a:ext uri="{FF2B5EF4-FFF2-40B4-BE49-F238E27FC236}">
-                <a16:creationId xmlns:a16="http://schemas.microsoft.com/office/drawing/2014/main" id="{710E063A-4542-455A-8C4A-DFC01A5BBAB1}"/>
+                <a16:creationId xmlns:a16="http://schemas.microsoft.com/office/drawing/2014/main" id="{223533F5-D3DC-48F3-86A8-6746184DFCF7}"/>
               </a:ext>
             </a:extLst>
           </p:cNvPr>
@@ -13281,7 +13281,7 @@
           <p:cNvPr id="29" name="S2_InputHumanTitle">
             <a:extLst xmlns:a="http://schemas.openxmlformats.org/drawingml/2006/main">
               <a:ext uri="{FF2B5EF4-FFF2-40B4-BE49-F238E27FC236}">
-                <a16:creationId xmlns:a16="http://schemas.microsoft.com/office/drawing/2014/main" id="{50CCC464-9610-49C9-A784-407322A12CFB}"/>
+                <a16:creationId xmlns:a16="http://schemas.microsoft.com/office/drawing/2014/main" id="{36EA8625-4D1A-464D-975C-2B07EF648493}"/>
               </a:ext>
             </a:extLst>
           </p:cNvPr>
@@ -13439,7 +13439,7 @@
           <p:cNvPr id="30" name="S2_InputHumanDetail">
             <a:extLst xmlns:a="http://schemas.openxmlformats.org/drawingml/2006/main">
               <a:ext uri="{FF2B5EF4-FFF2-40B4-BE49-F238E27FC236}">
-                <a16:creationId xmlns:a16="http://schemas.microsoft.com/office/drawing/2014/main" id="{E0726FC9-96E2-4C47-A19C-E08767C22F3D}"/>
+                <a16:creationId xmlns:a16="http://schemas.microsoft.com/office/drawing/2014/main" id="{7FA2213D-3D49-4801-A494-46B384128744}"/>
               </a:ext>
             </a:extLst>
           </p:cNvPr>
@@ -13597,7 +13597,7 @@
           <p:cNvPr id="31" name="S2_ProcessHuman">
             <a:extLst xmlns:a="http://schemas.openxmlformats.org/drawingml/2006/main">
               <a:ext uri="{FF2B5EF4-FFF2-40B4-BE49-F238E27FC236}">
-                <a16:creationId xmlns:a16="http://schemas.microsoft.com/office/drawing/2014/main" id="{55CA918E-0989-4E16-9DB8-A258D5C8CB8A}"/>
+                <a16:creationId xmlns:a16="http://schemas.microsoft.com/office/drawing/2014/main" id="{2BAA5168-FDC6-41FA-9BAE-EC94A61D0F59}"/>
               </a:ext>
             </a:extLst>
           </p:cNvPr>
@@ -13632,7 +13632,7 @@
           <p:cNvPr id="32" name="S2_ProcessHumanTitle">
             <a:extLst xmlns:a="http://schemas.openxmlformats.org/drawingml/2006/main">
               <a:ext uri="{FF2B5EF4-FFF2-40B4-BE49-F238E27FC236}">
-                <a16:creationId xmlns:a16="http://schemas.microsoft.com/office/drawing/2014/main" id="{438F9B70-487A-4804-AAA6-DB9B7DCF1CAB}"/>
+                <a16:creationId xmlns:a16="http://schemas.microsoft.com/office/drawing/2014/main" id="{4EC9A57A-1741-48F1-8FE3-E050EBAE8E10}"/>
               </a:ext>
             </a:extLst>
           </p:cNvPr>
@@ -13790,7 +13790,7 @@
           <p:cNvPr id="33" name="S2_ProcessHumanDetail">
             <a:extLst xmlns:a="http://schemas.openxmlformats.org/drawingml/2006/main">
               <a:ext uri="{FF2B5EF4-FFF2-40B4-BE49-F238E27FC236}">
-                <a16:creationId xmlns:a16="http://schemas.microsoft.com/office/drawing/2014/main" id="{9E3A6ADD-59D0-4B2C-AD98-D55DCFB2B8AD}"/>
+                <a16:creationId xmlns:a16="http://schemas.microsoft.com/office/drawing/2014/main" id="{F7BED0B7-E350-45AD-88D4-7D8453A9D5AE}"/>
               </a:ext>
             </a:extLst>
           </p:cNvPr>
@@ -13948,7 +13948,7 @@
           <p:cNvPr id="34" name="S2_OutputHuman">
             <a:extLst xmlns:a="http://schemas.openxmlformats.org/drawingml/2006/main">
               <a:ext uri="{FF2B5EF4-FFF2-40B4-BE49-F238E27FC236}">
-                <a16:creationId xmlns:a16="http://schemas.microsoft.com/office/drawing/2014/main" id="{4B4D6EAE-AC00-413F-B304-03E1D8E74C2C}"/>
+                <a16:creationId xmlns:a16="http://schemas.microsoft.com/office/drawing/2014/main" id="{00C177E1-60FC-4E3D-99C6-BCA2C4D7F1D2}"/>
               </a:ext>
             </a:extLst>
           </p:cNvPr>
@@ -13983,7 +13983,7 @@
           <p:cNvPr id="35" name="S2_Gate9">
             <a:extLst xmlns:a="http://schemas.openxmlformats.org/drawingml/2006/main">
               <a:ext uri="{FF2B5EF4-FFF2-40B4-BE49-F238E27FC236}">
-                <a16:creationId xmlns:a16="http://schemas.microsoft.com/office/drawing/2014/main" id="{506FB873-A9CB-4239-9762-069F24E460AC}"/>
+                <a16:creationId xmlns:a16="http://schemas.microsoft.com/office/drawing/2014/main" id="{565AAF8B-83A5-44D5-AB0C-4C9AD7A8DE00}"/>
               </a:ext>
             </a:extLst>
           </p:cNvPr>
@@ -14148,7 +14148,7 @@
           <p:cNvPr id="36" name="S2_OutputHumanDetail">
             <a:extLst xmlns:a="http://schemas.openxmlformats.org/drawingml/2006/main">
               <a:ext uri="{FF2B5EF4-FFF2-40B4-BE49-F238E27FC236}">
-                <a16:creationId xmlns:a16="http://schemas.microsoft.com/office/drawing/2014/main" id="{B9A8D8B8-62E3-492F-A408-C0CA9CFC8655}"/>
+                <a16:creationId xmlns:a16="http://schemas.microsoft.com/office/drawing/2014/main" id="{B7D477F7-81EB-4037-B9B2-36545B35D802}"/>
               </a:ext>
             </a:extLst>
           </p:cNvPr>
@@ -14352,7 +14352,7 @@
           <p:cNvPr id="37" name="S2_AuthorityBand">
             <a:extLst xmlns:a="http://schemas.openxmlformats.org/drawingml/2006/main">
               <a:ext uri="{FF2B5EF4-FFF2-40B4-BE49-F238E27FC236}">
-                <a16:creationId xmlns:a16="http://schemas.microsoft.com/office/drawing/2014/main" id="{6DE28464-D325-4028-8E0B-0425FA55E433}"/>
+                <a16:creationId xmlns:a16="http://schemas.microsoft.com/office/drawing/2014/main" id="{74A5FD1D-4D42-4709-99E6-11B879E721ED}"/>
               </a:ext>
             </a:extLst>
           </p:cNvPr>
@@ -14387,7 +14387,7 @@
           <p:cNvPr id="38" name="S2_AuthorityAI">
             <a:extLst xmlns:a="http://schemas.openxmlformats.org/drawingml/2006/main">
               <a:ext uri="{FF2B5EF4-FFF2-40B4-BE49-F238E27FC236}">
-                <a16:creationId xmlns:a16="http://schemas.microsoft.com/office/drawing/2014/main" id="{681BA77E-B51C-47E0-9993-345128B14207}"/>
+                <a16:creationId xmlns:a16="http://schemas.microsoft.com/office/drawing/2014/main" id="{4CE849BC-5F6E-4990-B123-68AF546C4D70}"/>
               </a:ext>
             </a:extLst>
           </p:cNvPr>
@@ -14545,7 +14545,7 @@
           <p:cNvPr id="39" name="S2_AuthorityPolicy">
             <a:extLst xmlns:a="http://schemas.openxmlformats.org/drawingml/2006/main">
               <a:ext uri="{FF2B5EF4-FFF2-40B4-BE49-F238E27FC236}">
-                <a16:creationId xmlns:a16="http://schemas.microsoft.com/office/drawing/2014/main" id="{40145285-A3E6-4E83-B5E8-B8AD7D4C23DE}"/>
+                <a16:creationId xmlns:a16="http://schemas.microsoft.com/office/drawing/2014/main" id="{D3DF1E00-C4E9-4A3C-852B-236E5C090546}"/>
               </a:ext>
             </a:extLst>
           </p:cNvPr>
@@ -14703,7 +14703,7 @@
           <p:cNvPr id="40" name="S2_AuthorityHuman">
             <a:extLst xmlns:a="http://schemas.openxmlformats.org/drawingml/2006/main">
               <a:ext uri="{FF2B5EF4-FFF2-40B4-BE49-F238E27FC236}">
-                <a16:creationId xmlns:a16="http://schemas.microsoft.com/office/drawing/2014/main" id="{805FF806-6503-4B1E-8B49-10E7804F89D7}"/>
+                <a16:creationId xmlns:a16="http://schemas.microsoft.com/office/drawing/2014/main" id="{63CD4C41-8A24-490A-A523-720829877453}"/>
               </a:ext>
             </a:extLst>
           </p:cNvPr>
@@ -14859,7 +14859,7 @@
     </p:spTree>
     <p:extLst>
       <p:ext uri="{BB962C8B-B14F-4D97-AF65-F5344CB8AC3E}">
-        <p14:creationId xmlns:p14="http://schemas.microsoft.com/office/powerpoint/2010/main" val="1352367423"/>
+        <p14:creationId xmlns:p14="http://schemas.microsoft.com/office/powerpoint/2010/main" val="418220118"/>
       </p:ext>
     </p:extLst>
   </p:cSld>
@@ -14890,7 +14890,7 @@
           <p:cNvPr id="11" name="Slide_Title">
             <a:extLst xmlns:a="http://schemas.openxmlformats.org/drawingml/2006/main">
               <a:ext uri="{FF2B5EF4-FFF2-40B4-BE49-F238E27FC236}">
-                <a16:creationId xmlns:a16="http://schemas.microsoft.com/office/drawing/2014/main" id="{A43D64A0-EC21-452B-A5AF-0F58976AC168}"/>
+                <a16:creationId xmlns:a16="http://schemas.microsoft.com/office/drawing/2014/main" id="{37DAAEFE-8E0C-4B09-96E7-DE45FCE36048}"/>
               </a:ext>
             </a:extLst>
           </p:cNvPr>
@@ -15048,7 +15048,7 @@
           <p:cNvPr id="2" name="Slide_Subtitle">
             <a:extLst xmlns:a="http://schemas.openxmlformats.org/drawingml/2006/main">
               <a:ext uri="{FF2B5EF4-FFF2-40B4-BE49-F238E27FC236}">
-                <a16:creationId xmlns:a16="http://schemas.microsoft.com/office/drawing/2014/main" id="{DD597556-59BF-4CA7-9CC6-E330D21AEAE0}"/>
+                <a16:creationId xmlns:a16="http://schemas.microsoft.com/office/drawing/2014/main" id="{3784409E-1BA4-42C3-988D-47788E7A265E}"/>
               </a:ext>
             </a:extLst>
           </p:cNvPr>
@@ -15206,7 +15206,7 @@
           <p:cNvPr id="3" name="S3_BeforeAfterTable">
             <a:extLst xmlns:a="http://schemas.openxmlformats.org/drawingml/2006/main">
               <a:ext uri="{FF2B5EF4-FFF2-40B4-BE49-F238E27FC236}">
-                <a16:creationId xmlns:a16="http://schemas.microsoft.com/office/drawing/2014/main" id="{CB124A4D-0F21-4294-8DB8-0A51597DFC72}"/>
+                <a16:creationId xmlns:a16="http://schemas.microsoft.com/office/drawing/2014/main" id="{D8A2FC29-95A5-4E3C-A2F7-1CB698CBEE94}"/>
               </a:ext>
             </a:extLst>
           </p:cNvPr>
@@ -16460,7 +16460,7 @@
           <p:cNvPr id="4" name="S3_ProtocolBand">
             <a:extLst xmlns:a="http://schemas.openxmlformats.org/drawingml/2006/main">
               <a:ext uri="{FF2B5EF4-FFF2-40B4-BE49-F238E27FC236}">
-                <a16:creationId xmlns:a16="http://schemas.microsoft.com/office/drawing/2014/main" id="{B279F066-941A-4A8B-9918-7B356303F433}"/>
+                <a16:creationId xmlns:a16="http://schemas.microsoft.com/office/drawing/2014/main" id="{B2BA97A9-BDBA-41CF-89E9-13DD8155737A}"/>
               </a:ext>
             </a:extLst>
           </p:cNvPr>
@@ -16495,7 +16495,7 @@
           <p:cNvPr id="5" name="S3_ProtocolLabel">
             <a:extLst xmlns:a="http://schemas.openxmlformats.org/drawingml/2006/main">
               <a:ext uri="{FF2B5EF4-FFF2-40B4-BE49-F238E27FC236}">
-                <a16:creationId xmlns:a16="http://schemas.microsoft.com/office/drawing/2014/main" id="{858E3BCA-FFFE-4D08-BC4B-E34CC4C80FDE}"/>
+                <a16:creationId xmlns:a16="http://schemas.microsoft.com/office/drawing/2014/main" id="{F588462A-F981-4710-A900-98F3F8C5C489}"/>
               </a:ext>
             </a:extLst>
           </p:cNvPr>
@@ -16653,7 +16653,7 @@
           <p:cNvPr id="6" name="S3_ProtocolLine1">
             <a:extLst xmlns:a="http://schemas.openxmlformats.org/drawingml/2006/main">
               <a:ext uri="{FF2B5EF4-FFF2-40B4-BE49-F238E27FC236}">
-                <a16:creationId xmlns:a16="http://schemas.microsoft.com/office/drawing/2014/main" id="{5D38224F-A3A2-42D8-9561-55A354E74B3B}"/>
+                <a16:creationId xmlns:a16="http://schemas.microsoft.com/office/drawing/2014/main" id="{7D22816A-1B73-4B6E-9BBC-B04AC3179410}"/>
               </a:ext>
             </a:extLst>
           </p:cNvPr>
@@ -16811,7 +16811,7 @@
           <p:cNvPr id="7" name="S3_ProtocolLine2">
             <a:extLst xmlns:a="http://schemas.openxmlformats.org/drawingml/2006/main">
               <a:ext uri="{FF2B5EF4-FFF2-40B4-BE49-F238E27FC236}">
-                <a16:creationId xmlns:a16="http://schemas.microsoft.com/office/drawing/2014/main" id="{F2E0CFCB-B05A-4EC1-80E6-C864EB654DBE}"/>
+                <a16:creationId xmlns:a16="http://schemas.microsoft.com/office/drawing/2014/main" id="{0ED6FF9F-C85F-4C1B-867D-DA67BFEECA38}"/>
               </a:ext>
             </a:extLst>
           </p:cNvPr>
@@ -16969,7 +16969,7 @@
           <p:cNvPr id="8" name="S3_TechnicalStrip">
             <a:extLst xmlns:a="http://schemas.openxmlformats.org/drawingml/2006/main">
               <a:ext uri="{FF2B5EF4-FFF2-40B4-BE49-F238E27FC236}">
-                <a16:creationId xmlns:a16="http://schemas.microsoft.com/office/drawing/2014/main" id="{67E1FA13-218D-4950-A633-221C5BD4B7F7}"/>
+                <a16:creationId xmlns:a16="http://schemas.microsoft.com/office/drawing/2014/main" id="{349755DD-F525-4E8B-9433-21D82CD787C4}"/>
               </a:ext>
             </a:extLst>
           </p:cNvPr>
@@ -17004,7 +17004,7 @@
           <p:cNvPr id="9" name="S3_TechnicalLabel">
             <a:extLst xmlns:a="http://schemas.openxmlformats.org/drawingml/2006/main">
               <a:ext uri="{FF2B5EF4-FFF2-40B4-BE49-F238E27FC236}">
-                <a16:creationId xmlns:a16="http://schemas.microsoft.com/office/drawing/2014/main" id="{112EE53B-8C99-403F-922E-DC9D63FCE25A}"/>
+                <a16:creationId xmlns:a16="http://schemas.microsoft.com/office/drawing/2014/main" id="{4817EE45-0271-4204-875A-49688DD11500}"/>
               </a:ext>
             </a:extLst>
           </p:cNvPr>
@@ -17162,7 +17162,7 @@
           <p:cNvPr id="10" name="S3_TechnicalValues">
             <a:extLst xmlns:a="http://schemas.openxmlformats.org/drawingml/2006/main">
               <a:ext uri="{FF2B5EF4-FFF2-40B4-BE49-F238E27FC236}">
-                <a16:creationId xmlns:a16="http://schemas.microsoft.com/office/drawing/2014/main" id="{071BCBC4-DC00-4C07-96BB-8C5B33EEFC44}"/>
+                <a16:creationId xmlns:a16="http://schemas.microsoft.com/office/drawing/2014/main" id="{7BA87CA4-7B3B-4309-A3CD-ED1252B83994}"/>
               </a:ext>
             </a:extLst>
           </p:cNvPr>
@@ -17318,7 +17318,7 @@
     </p:spTree>
     <p:extLst>
       <p:ext uri="{BB962C8B-B14F-4D97-AF65-F5344CB8AC3E}">
-        <p14:creationId xmlns:p14="http://schemas.microsoft.com/office/powerpoint/2010/main" val="1309783520"/>
+        <p14:creationId xmlns:p14="http://schemas.microsoft.com/office/powerpoint/2010/main" val="2113376435"/>
       </p:ext>
     </p:extLst>
   </p:cSld>
@@ -17349,7 +17349,7 @@
           <p:cNvPr id="40" name="Slide_Title">
             <a:extLst xmlns:a="http://schemas.openxmlformats.org/drawingml/2006/main">
               <a:ext uri="{FF2B5EF4-FFF2-40B4-BE49-F238E27FC236}">
-                <a16:creationId xmlns:a16="http://schemas.microsoft.com/office/drawing/2014/main" id="{9F6356DC-52E8-48FF-BACE-AE92936E1EE7}"/>
+                <a16:creationId xmlns:a16="http://schemas.microsoft.com/office/drawing/2014/main" id="{69DF59A8-77AB-4DA5-A3A4-B2228E0DFE15}"/>
               </a:ext>
             </a:extLst>
           </p:cNvPr>
@@ -17507,7 +17507,7 @@
           <p:cNvPr id="2" name="Slide_Subtitle">
             <a:extLst xmlns:a="http://schemas.openxmlformats.org/drawingml/2006/main">
               <a:ext uri="{FF2B5EF4-FFF2-40B4-BE49-F238E27FC236}">
-                <a16:creationId xmlns:a16="http://schemas.microsoft.com/office/drawing/2014/main" id="{2D2F9F29-E73E-459C-8819-6D5F525CEA2A}"/>
+                <a16:creationId xmlns:a16="http://schemas.microsoft.com/office/drawing/2014/main" id="{8EF4FE24-83F6-40A9-9FEA-ABACADFC13E2}"/>
               </a:ext>
             </a:extLst>
           </p:cNvPr>
@@ -17665,7 +17665,7 @@
           <p:cNvPr id="3" name="S4_Layer_1">
             <a:extLst xmlns:a="http://schemas.openxmlformats.org/drawingml/2006/main">
               <a:ext uri="{FF2B5EF4-FFF2-40B4-BE49-F238E27FC236}">
-                <a16:creationId xmlns:a16="http://schemas.microsoft.com/office/drawing/2014/main" id="{4EA3F8B0-FB85-43C6-BE7F-2C9686CFDB40}"/>
+                <a16:creationId xmlns:a16="http://schemas.microsoft.com/office/drawing/2014/main" id="{D8624756-0ED0-4E0C-89E8-78F1C5F03506}"/>
               </a:ext>
             </a:extLst>
           </p:cNvPr>
@@ -17700,7 +17700,7 @@
           <p:cNvPr id="4" name="S4_LiveBadge_1">
             <a:extLst xmlns:a="http://schemas.openxmlformats.org/drawingml/2006/main">
               <a:ext uri="{FF2B5EF4-FFF2-40B4-BE49-F238E27FC236}">
-                <a16:creationId xmlns:a16="http://schemas.microsoft.com/office/drawing/2014/main" id="{F8EB217E-D5D8-4A3A-847E-6AA5CA8D5A45}"/>
+                <a16:creationId xmlns:a16="http://schemas.microsoft.com/office/drawing/2014/main" id="{9099078E-98F7-4F06-A026-70A91E69A808}"/>
               </a:ext>
             </a:extLst>
           </p:cNvPr>
@@ -17865,7 +17865,7 @@
           <p:cNvPr id="5" name="S4_LayerLabel_1">
             <a:extLst xmlns:a="http://schemas.openxmlformats.org/drawingml/2006/main">
               <a:ext uri="{FF2B5EF4-FFF2-40B4-BE49-F238E27FC236}">
-                <a16:creationId xmlns:a16="http://schemas.microsoft.com/office/drawing/2014/main" id="{B1CF26EE-88C8-40D5-A9B8-FE5C58055A29}"/>
+                <a16:creationId xmlns:a16="http://schemas.microsoft.com/office/drawing/2014/main" id="{6243E529-72FF-4B15-A453-95796C0FE7B3}"/>
               </a:ext>
             </a:extLst>
           </p:cNvPr>
@@ -18023,7 +18023,7 @@
           <p:cNvPr id="6" name="S4_LayerText_1">
             <a:extLst xmlns:a="http://schemas.openxmlformats.org/drawingml/2006/main">
               <a:ext uri="{FF2B5EF4-FFF2-40B4-BE49-F238E27FC236}">
-                <a16:creationId xmlns:a16="http://schemas.microsoft.com/office/drawing/2014/main" id="{857788E4-984E-4822-A33C-3BDE2F227DF8}"/>
+                <a16:creationId xmlns:a16="http://schemas.microsoft.com/office/drawing/2014/main" id="{8837AF7F-1367-49CF-A0E6-9E4D2B0F7460}"/>
               </a:ext>
             </a:extLst>
           </p:cNvPr>
@@ -18171,7 +18171,7 @@
                 <a:ea typeface="Segoe UI"/>
                 <a:cs typeface="Segoe UI"/>
               </a:rPr>
-              <a:t>Batch 1–10 • amount tùy chọn • HTTP 202/poll • dashboard + CSV tháng</a:t>
+              <a:t>Lượt 1–10 ảnh • amount tùy chọn • HTTP 202/poll • dashboard + CSV tháng</a:t>
             </a:r>
           </a:p>
         </p:txBody>
@@ -18181,7 +18181,7 @@
           <p:cNvPr id="7" name="S4_LayerConnector_1">
             <a:extLst xmlns:a="http://schemas.openxmlformats.org/drawingml/2006/main">
               <a:ext uri="{FF2B5EF4-FFF2-40B4-BE49-F238E27FC236}">
-                <a16:creationId xmlns:a16="http://schemas.microsoft.com/office/drawing/2014/main" id="{4599CFF7-1381-4F33-8DB5-F7CB0315B69E}"/>
+                <a16:creationId xmlns:a16="http://schemas.microsoft.com/office/drawing/2014/main" id="{BD711228-C9AE-4408-B4EA-02C8B4B1468C}"/>
               </a:ext>
             </a:extLst>
           </p:cNvPr>
@@ -18212,7 +18212,7 @@
           <p:cNvPr id="8" name="S4_Layer_2">
             <a:extLst xmlns:a="http://schemas.openxmlformats.org/drawingml/2006/main">
               <a:ext uri="{FF2B5EF4-FFF2-40B4-BE49-F238E27FC236}">
-                <a16:creationId xmlns:a16="http://schemas.microsoft.com/office/drawing/2014/main" id="{973C82B0-BC9B-46F3-97E8-38DAC3B682AC}"/>
+                <a16:creationId xmlns:a16="http://schemas.microsoft.com/office/drawing/2014/main" id="{6BA611F6-E621-44F3-9C1E-EA2083D4BBA2}"/>
               </a:ext>
             </a:extLst>
           </p:cNvPr>
@@ -18247,7 +18247,7 @@
           <p:cNvPr id="9" name="S4_LiveBadge_2">
             <a:extLst xmlns:a="http://schemas.openxmlformats.org/drawingml/2006/main">
               <a:ext uri="{FF2B5EF4-FFF2-40B4-BE49-F238E27FC236}">
-                <a16:creationId xmlns:a16="http://schemas.microsoft.com/office/drawing/2014/main" id="{AE16DB60-0467-4291-9382-8851CD17B8D3}"/>
+                <a16:creationId xmlns:a16="http://schemas.microsoft.com/office/drawing/2014/main" id="{E99A87CB-1A1F-428E-BDF9-921431636716}"/>
               </a:ext>
             </a:extLst>
           </p:cNvPr>
@@ -18412,7 +18412,7 @@
           <p:cNvPr id="10" name="S4_LayerLabel_2">
             <a:extLst xmlns:a="http://schemas.openxmlformats.org/drawingml/2006/main">
               <a:ext uri="{FF2B5EF4-FFF2-40B4-BE49-F238E27FC236}">
-                <a16:creationId xmlns:a16="http://schemas.microsoft.com/office/drawing/2014/main" id="{41232226-9E0E-45CF-83A8-6208CF3C946B}"/>
+                <a16:creationId xmlns:a16="http://schemas.microsoft.com/office/drawing/2014/main" id="{84066D6A-6C6D-4FD9-926C-28F2D3C354C0}"/>
               </a:ext>
             </a:extLst>
           </p:cNvPr>
@@ -18570,7 +18570,7 @@
           <p:cNvPr id="11" name="S4_LayerText_2">
             <a:extLst xmlns:a="http://schemas.openxmlformats.org/drawingml/2006/main">
               <a:ext uri="{FF2B5EF4-FFF2-40B4-BE49-F238E27FC236}">
-                <a16:creationId xmlns:a16="http://schemas.microsoft.com/office/drawing/2014/main" id="{E4873748-D1F1-42BD-864D-A20ED24D8E12}"/>
+                <a16:creationId xmlns:a16="http://schemas.microsoft.com/office/drawing/2014/main" id="{301E749B-4A25-40DD-9F91-8C5DC02841D1}"/>
               </a:ext>
             </a:extLst>
           </p:cNvPr>
@@ -18728,7 +18728,7 @@
           <p:cNvPr id="12" name="S4_LayerConnector_2">
             <a:extLst xmlns:a="http://schemas.openxmlformats.org/drawingml/2006/main">
               <a:ext uri="{FF2B5EF4-FFF2-40B4-BE49-F238E27FC236}">
-                <a16:creationId xmlns:a16="http://schemas.microsoft.com/office/drawing/2014/main" id="{65C85C71-D41B-4ADC-9C20-60E18DF8FB89}"/>
+                <a16:creationId xmlns:a16="http://schemas.microsoft.com/office/drawing/2014/main" id="{443FFFC9-E29D-496C-87B0-A70AD92B70D6}"/>
               </a:ext>
             </a:extLst>
           </p:cNvPr>
@@ -18759,7 +18759,7 @@
           <p:cNvPr id="13" name="S4_Layer_3">
             <a:extLst xmlns:a="http://schemas.openxmlformats.org/drawingml/2006/main">
               <a:ext uri="{FF2B5EF4-FFF2-40B4-BE49-F238E27FC236}">
-                <a16:creationId xmlns:a16="http://schemas.microsoft.com/office/drawing/2014/main" id="{254C8C0D-CEBE-47E3-A401-0BC840F89E8E}"/>
+                <a16:creationId xmlns:a16="http://schemas.microsoft.com/office/drawing/2014/main" id="{33488666-2246-4284-A6EB-22CDBD279681}"/>
               </a:ext>
             </a:extLst>
           </p:cNvPr>
@@ -18794,7 +18794,7 @@
           <p:cNvPr id="14" name="S4_LiveBadge_3">
             <a:extLst xmlns:a="http://schemas.openxmlformats.org/drawingml/2006/main">
               <a:ext uri="{FF2B5EF4-FFF2-40B4-BE49-F238E27FC236}">
-                <a16:creationId xmlns:a16="http://schemas.microsoft.com/office/drawing/2014/main" id="{6BE8AC63-D5D2-4EA0-B085-82BC5BDB14E9}"/>
+                <a16:creationId xmlns:a16="http://schemas.microsoft.com/office/drawing/2014/main" id="{A3841BE8-041F-44EB-842B-F150D00D803B}"/>
               </a:ext>
             </a:extLst>
           </p:cNvPr>
@@ -18959,7 +18959,7 @@
           <p:cNvPr id="15" name="S4_LayerLabel_3">
             <a:extLst xmlns:a="http://schemas.openxmlformats.org/drawingml/2006/main">
               <a:ext uri="{FF2B5EF4-FFF2-40B4-BE49-F238E27FC236}">
-                <a16:creationId xmlns:a16="http://schemas.microsoft.com/office/drawing/2014/main" id="{89D75009-CE1F-4507-AD0A-0CE765ABD253}"/>
+                <a16:creationId xmlns:a16="http://schemas.microsoft.com/office/drawing/2014/main" id="{8B8C0444-DE0E-447E-A907-CEB306E68ACD}"/>
               </a:ext>
             </a:extLst>
           </p:cNvPr>
@@ -19117,7 +19117,7 @@
           <p:cNvPr id="16" name="S4_LayerText_3">
             <a:extLst xmlns:a="http://schemas.openxmlformats.org/drawingml/2006/main">
               <a:ext uri="{FF2B5EF4-FFF2-40B4-BE49-F238E27FC236}">
-                <a16:creationId xmlns:a16="http://schemas.microsoft.com/office/drawing/2014/main" id="{9BF37964-6E82-4413-88E1-C6D4FC2C430C}"/>
+                <a16:creationId xmlns:a16="http://schemas.microsoft.com/office/drawing/2014/main" id="{2BDFEAFA-3299-467A-A9BB-C7B7393DB721}"/>
               </a:ext>
             </a:extLst>
           </p:cNvPr>
@@ -19288,7 +19288,7 @@
                 <a:ea typeface="Segoe UI"/>
                 <a:cs typeface="Segoe UI"/>
               </a:rPr>
-              <a:t>semantic repair ≤ 1 • amount provenance • privacy category</a:t>
+              <a:t>semantic repair ≤ 1 • amount provenance • privacy triage sau inference</a:t>
             </a:r>
           </a:p>
         </p:txBody>
@@ -19298,7 +19298,7 @@
           <p:cNvPr id="17" name="S4_LayerConnector_3">
             <a:extLst xmlns:a="http://schemas.openxmlformats.org/drawingml/2006/main">
               <a:ext uri="{FF2B5EF4-FFF2-40B4-BE49-F238E27FC236}">
-                <a16:creationId xmlns:a16="http://schemas.microsoft.com/office/drawing/2014/main" id="{586DF847-A65D-481F-AF65-807435792194}"/>
+                <a16:creationId xmlns:a16="http://schemas.microsoft.com/office/drawing/2014/main" id="{ECD9B9E1-1585-4147-B524-D86C99827AB7}"/>
               </a:ext>
             </a:extLst>
           </p:cNvPr>
@@ -19329,7 +19329,7 @@
           <p:cNvPr id="18" name="S4_Layer_4">
             <a:extLst xmlns:a="http://schemas.openxmlformats.org/drawingml/2006/main">
               <a:ext uri="{FF2B5EF4-FFF2-40B4-BE49-F238E27FC236}">
-                <a16:creationId xmlns:a16="http://schemas.microsoft.com/office/drawing/2014/main" id="{C05E8445-6932-411C-81D9-DA91F554056F}"/>
+                <a16:creationId xmlns:a16="http://schemas.microsoft.com/office/drawing/2014/main" id="{4B441ECE-B981-452F-8F23-003164CAD9ED}"/>
               </a:ext>
             </a:extLst>
           </p:cNvPr>
@@ -19364,7 +19364,7 @@
           <p:cNvPr id="19" name="S4_LiveBadge_4">
             <a:extLst xmlns:a="http://schemas.openxmlformats.org/drawingml/2006/main">
               <a:ext uri="{FF2B5EF4-FFF2-40B4-BE49-F238E27FC236}">
-                <a16:creationId xmlns:a16="http://schemas.microsoft.com/office/drawing/2014/main" id="{574AE3FA-7D6B-467F-9F42-8752736F1E20}"/>
+                <a16:creationId xmlns:a16="http://schemas.microsoft.com/office/drawing/2014/main" id="{4D0ED180-4360-4160-BC20-58193F582A82}"/>
               </a:ext>
             </a:extLst>
           </p:cNvPr>
@@ -19529,7 +19529,7 @@
           <p:cNvPr id="20" name="S4_LayerLabel_4">
             <a:extLst xmlns:a="http://schemas.openxmlformats.org/drawingml/2006/main">
               <a:ext uri="{FF2B5EF4-FFF2-40B4-BE49-F238E27FC236}">
-                <a16:creationId xmlns:a16="http://schemas.microsoft.com/office/drawing/2014/main" id="{D88D497B-019D-41C2-8BDE-A4715847E1E7}"/>
+                <a16:creationId xmlns:a16="http://schemas.microsoft.com/office/drawing/2014/main" id="{AEDBD96F-F194-429D-BAAF-A11A3851035B}"/>
               </a:ext>
             </a:extLst>
           </p:cNvPr>
@@ -19687,7 +19687,7 @@
           <p:cNvPr id="21" name="S4_LayerText_4">
             <a:extLst xmlns:a="http://schemas.openxmlformats.org/drawingml/2006/main">
               <a:ext uri="{FF2B5EF4-FFF2-40B4-BE49-F238E27FC236}">
-                <a16:creationId xmlns:a16="http://schemas.microsoft.com/office/drawing/2014/main" id="{42096C4F-678C-4F6F-9008-72FE9815DA94}"/>
+                <a16:creationId xmlns:a16="http://schemas.microsoft.com/office/drawing/2014/main" id="{F69EC45E-9419-4795-B633-06BDB514762A}"/>
               </a:ext>
             </a:extLst>
           </p:cNvPr>
@@ -19845,7 +19845,7 @@
           <p:cNvPr id="22" name="S4_TestBoundary">
             <a:extLst xmlns:a="http://schemas.openxmlformats.org/drawingml/2006/main">
               <a:ext uri="{FF2B5EF4-FFF2-40B4-BE49-F238E27FC236}">
-                <a16:creationId xmlns:a16="http://schemas.microsoft.com/office/drawing/2014/main" id="{2616B9D8-199A-4A52-A4F3-1543EDC8F366}"/>
+                <a16:creationId xmlns:a16="http://schemas.microsoft.com/office/drawing/2014/main" id="{E10BE5BF-42B1-4B39-8D6B-81DD8204DF90}"/>
               </a:ext>
             </a:extLst>
           </p:cNvPr>
@@ -19880,7 +19880,7 @@
           <p:cNvPr id="23" name="S4_TestTitle">
             <a:extLst xmlns:a="http://schemas.openxmlformats.org/drawingml/2006/main">
               <a:ext uri="{FF2B5EF4-FFF2-40B4-BE49-F238E27FC236}">
-                <a16:creationId xmlns:a16="http://schemas.microsoft.com/office/drawing/2014/main" id="{A40B7875-12D0-4071-A144-901C516CE5CA}"/>
+                <a16:creationId xmlns:a16="http://schemas.microsoft.com/office/drawing/2014/main" id="{6DF9CCBD-9AD1-4A89-9739-DC62842EF512}"/>
               </a:ext>
             </a:extLst>
           </p:cNvPr>
@@ -20038,7 +20038,7 @@
           <p:cNvPr id="24" name="S4_TestItem_1">
             <a:extLst xmlns:a="http://schemas.openxmlformats.org/drawingml/2006/main">
               <a:ext uri="{FF2B5EF4-FFF2-40B4-BE49-F238E27FC236}">
-                <a16:creationId xmlns:a16="http://schemas.microsoft.com/office/drawing/2014/main" id="{1082CC31-3266-497E-A3CC-C2CE69FF22F3}"/>
+                <a16:creationId xmlns:a16="http://schemas.microsoft.com/office/drawing/2014/main" id="{56BCB6ED-C455-4B48-8E68-F02ABF2DB37C}"/>
               </a:ext>
             </a:extLst>
           </p:cNvPr>
@@ -20073,7 +20073,7 @@
           <p:cNvPr id="25" name="S4_TestBadge_1">
             <a:extLst xmlns:a="http://schemas.openxmlformats.org/drawingml/2006/main">
               <a:ext uri="{FF2B5EF4-FFF2-40B4-BE49-F238E27FC236}">
-                <a16:creationId xmlns:a16="http://schemas.microsoft.com/office/drawing/2014/main" id="{0318518F-C0DA-4EFF-B363-42B9C02C121F}"/>
+                <a16:creationId xmlns:a16="http://schemas.microsoft.com/office/drawing/2014/main" id="{A70F1755-63E1-49DD-8166-623112D0967A}"/>
               </a:ext>
             </a:extLst>
           </p:cNvPr>
@@ -20238,7 +20238,7 @@
           <p:cNvPr id="26" name="S4_TestLabel_1">
             <a:extLst xmlns:a="http://schemas.openxmlformats.org/drawingml/2006/main">
               <a:ext uri="{FF2B5EF4-FFF2-40B4-BE49-F238E27FC236}">
-                <a16:creationId xmlns:a16="http://schemas.microsoft.com/office/drawing/2014/main" id="{22E5AAD4-2148-424A-B729-0531269DA088}"/>
+                <a16:creationId xmlns:a16="http://schemas.microsoft.com/office/drawing/2014/main" id="{3166A8B3-CE41-4D44-9001-0677BE36CBB4}"/>
               </a:ext>
             </a:extLst>
           </p:cNvPr>
@@ -20396,7 +20396,7 @@
           <p:cNvPr id="27" name="S4_TestDetail_1">
             <a:extLst xmlns:a="http://schemas.openxmlformats.org/drawingml/2006/main">
               <a:ext uri="{FF2B5EF4-FFF2-40B4-BE49-F238E27FC236}">
-                <a16:creationId xmlns:a16="http://schemas.microsoft.com/office/drawing/2014/main" id="{0870DA34-7E6C-401C-9A18-E6FF4CF39C0F}"/>
+                <a16:creationId xmlns:a16="http://schemas.microsoft.com/office/drawing/2014/main" id="{CA13CA22-57B9-4C7B-97BD-72F2B68979E9}"/>
               </a:ext>
             </a:extLst>
           </p:cNvPr>
@@ -20554,7 +20554,7 @@
           <p:cNvPr id="28" name="S4_TestItem_2">
             <a:extLst xmlns:a="http://schemas.openxmlformats.org/drawingml/2006/main">
               <a:ext uri="{FF2B5EF4-FFF2-40B4-BE49-F238E27FC236}">
-                <a16:creationId xmlns:a16="http://schemas.microsoft.com/office/drawing/2014/main" id="{D6AC8D53-AD80-4650-BA5E-271B27A2B071}"/>
+                <a16:creationId xmlns:a16="http://schemas.microsoft.com/office/drawing/2014/main" id="{F35DD2C4-00CA-4AAD-8169-B7AF5F0861EF}"/>
               </a:ext>
             </a:extLst>
           </p:cNvPr>
@@ -20589,7 +20589,7 @@
           <p:cNvPr id="29" name="S4_TestBadge_2">
             <a:extLst xmlns:a="http://schemas.openxmlformats.org/drawingml/2006/main">
               <a:ext uri="{FF2B5EF4-FFF2-40B4-BE49-F238E27FC236}">
-                <a16:creationId xmlns:a16="http://schemas.microsoft.com/office/drawing/2014/main" id="{DA7BE342-59A3-4E52-8E84-0D4EB9A86F64}"/>
+                <a16:creationId xmlns:a16="http://schemas.microsoft.com/office/drawing/2014/main" id="{E32FEDA9-EA7C-4012-8DE4-C13CD2D4BD1D}"/>
               </a:ext>
             </a:extLst>
           </p:cNvPr>
@@ -20754,7 +20754,7 @@
           <p:cNvPr id="30" name="S4_TestLabel_2">
             <a:extLst xmlns:a="http://schemas.openxmlformats.org/drawingml/2006/main">
               <a:ext uri="{FF2B5EF4-FFF2-40B4-BE49-F238E27FC236}">
-                <a16:creationId xmlns:a16="http://schemas.microsoft.com/office/drawing/2014/main" id="{CD8B7339-0F28-48D2-A00C-D42A726FFBD9}"/>
+                <a16:creationId xmlns:a16="http://schemas.microsoft.com/office/drawing/2014/main" id="{DE58F198-90FB-4F54-B7F2-88ADCCA743E1}"/>
               </a:ext>
             </a:extLst>
           </p:cNvPr>
@@ -20912,7 +20912,7 @@
           <p:cNvPr id="31" name="S4_TestDetail_2">
             <a:extLst xmlns:a="http://schemas.openxmlformats.org/drawingml/2006/main">
               <a:ext uri="{FF2B5EF4-FFF2-40B4-BE49-F238E27FC236}">
-                <a16:creationId xmlns:a16="http://schemas.microsoft.com/office/drawing/2014/main" id="{054AE0BD-526E-407F-A046-9C3DBF06F6D4}"/>
+                <a16:creationId xmlns:a16="http://schemas.microsoft.com/office/drawing/2014/main" id="{621A29DE-D649-4147-AC1A-41365EAB6DC5}"/>
               </a:ext>
             </a:extLst>
           </p:cNvPr>
@@ -21070,7 +21070,7 @@
           <p:cNvPr id="32" name="S4_TestItem_3">
             <a:extLst xmlns:a="http://schemas.openxmlformats.org/drawingml/2006/main">
               <a:ext uri="{FF2B5EF4-FFF2-40B4-BE49-F238E27FC236}">
-                <a16:creationId xmlns:a16="http://schemas.microsoft.com/office/drawing/2014/main" id="{2C744605-5841-4859-B984-565E63432204}"/>
+                <a16:creationId xmlns:a16="http://schemas.microsoft.com/office/drawing/2014/main" id="{B7DB3D90-10E9-4E51-9F5F-272B0405F9CF}"/>
               </a:ext>
             </a:extLst>
           </p:cNvPr>
@@ -21105,7 +21105,7 @@
           <p:cNvPr id="33" name="S4_TestBadge_3">
             <a:extLst xmlns:a="http://schemas.openxmlformats.org/drawingml/2006/main">
               <a:ext uri="{FF2B5EF4-FFF2-40B4-BE49-F238E27FC236}">
-                <a16:creationId xmlns:a16="http://schemas.microsoft.com/office/drawing/2014/main" id="{3860E053-00C0-4970-AD93-84F447BB273B}"/>
+                <a16:creationId xmlns:a16="http://schemas.microsoft.com/office/drawing/2014/main" id="{9C705A86-790A-45C7-89B0-4E296BA407B2}"/>
               </a:ext>
             </a:extLst>
           </p:cNvPr>
@@ -21270,7 +21270,7 @@
           <p:cNvPr id="34" name="S4_TestLabel_3">
             <a:extLst xmlns:a="http://schemas.openxmlformats.org/drawingml/2006/main">
               <a:ext uri="{FF2B5EF4-FFF2-40B4-BE49-F238E27FC236}">
-                <a16:creationId xmlns:a16="http://schemas.microsoft.com/office/drawing/2014/main" id="{09E7FB96-802E-4A73-9EA5-35A504A1F202}"/>
+                <a16:creationId xmlns:a16="http://schemas.microsoft.com/office/drawing/2014/main" id="{C14532F9-9FF6-41DE-8725-7994367FE605}"/>
               </a:ext>
             </a:extLst>
           </p:cNvPr>
@@ -21428,7 +21428,7 @@
           <p:cNvPr id="35" name="S4_TestDetail_3">
             <a:extLst xmlns:a="http://schemas.openxmlformats.org/drawingml/2006/main">
               <a:ext uri="{FF2B5EF4-FFF2-40B4-BE49-F238E27FC236}">
-                <a16:creationId xmlns:a16="http://schemas.microsoft.com/office/drawing/2014/main" id="{B9DF6C34-81B6-449D-9981-4092BB861F70}"/>
+                <a16:creationId xmlns:a16="http://schemas.microsoft.com/office/drawing/2014/main" id="{B708A1EF-19F0-4540-9996-64B82B05041B}"/>
               </a:ext>
             </a:extLst>
           </p:cNvPr>
@@ -21586,7 +21586,7 @@
           <p:cNvPr id="36" name="S4_DeploymentBand">
             <a:extLst xmlns:a="http://schemas.openxmlformats.org/drawingml/2006/main">
               <a:ext uri="{FF2B5EF4-FFF2-40B4-BE49-F238E27FC236}">
-                <a16:creationId xmlns:a16="http://schemas.microsoft.com/office/drawing/2014/main" id="{C1B0C87D-57D2-4830-8FD0-72518A358C23}"/>
+                <a16:creationId xmlns:a16="http://schemas.microsoft.com/office/drawing/2014/main" id="{0BB14100-0ED1-461C-8466-1719698402FA}"/>
               </a:ext>
             </a:extLst>
           </p:cNvPr>
@@ -21621,7 +21621,7 @@
           <p:cNvPr id="37" name="S4_DeploymentLabel">
             <a:extLst xmlns:a="http://schemas.openxmlformats.org/drawingml/2006/main">
               <a:ext uri="{FF2B5EF4-FFF2-40B4-BE49-F238E27FC236}">
-                <a16:creationId xmlns:a16="http://schemas.microsoft.com/office/drawing/2014/main" id="{829CBC95-3804-47F5-A0EB-3E1722F19932}"/>
+                <a16:creationId xmlns:a16="http://schemas.microsoft.com/office/drawing/2014/main" id="{A0ABFF2C-95CA-4EE3-A3FD-97083893B32D}"/>
               </a:ext>
             </a:extLst>
           </p:cNvPr>
@@ -21779,7 +21779,7 @@
           <p:cNvPr id="38" name="S4_DeploymentText">
             <a:extLst xmlns:a="http://schemas.openxmlformats.org/drawingml/2006/main">
               <a:ext uri="{FF2B5EF4-FFF2-40B4-BE49-F238E27FC236}">
-                <a16:creationId xmlns:a16="http://schemas.microsoft.com/office/drawing/2014/main" id="{DF182CB2-A11E-401E-807D-3F5C16E8BB06}"/>
+                <a16:creationId xmlns:a16="http://schemas.microsoft.com/office/drawing/2014/main" id="{62B01F37-DFE2-4470-894A-0F8567F1774F}"/>
               </a:ext>
             </a:extLst>
           </p:cNvPr>
@@ -21937,7 +21937,7 @@
           <p:cNvPr id="39" name="S4_SecurityBoundaryText">
             <a:extLst xmlns:a="http://schemas.openxmlformats.org/drawingml/2006/main">
               <a:ext uri="{FF2B5EF4-FFF2-40B4-BE49-F238E27FC236}">
-                <a16:creationId xmlns:a16="http://schemas.microsoft.com/office/drawing/2014/main" id="{D65CAF29-EF49-4EF0-9ED8-5B8B78F7284B}"/>
+                <a16:creationId xmlns:a16="http://schemas.microsoft.com/office/drawing/2014/main" id="{3ABF1DF3-B894-49B0-A734-99BF3EECBC90}"/>
               </a:ext>
             </a:extLst>
           </p:cNvPr>
@@ -22093,7 +22093,7 @@
     </p:spTree>
     <p:extLst>
       <p:ext uri="{BB962C8B-B14F-4D97-AF65-F5344CB8AC3E}">
-        <p14:creationId xmlns:p14="http://schemas.microsoft.com/office/powerpoint/2010/main" val="543680125"/>
+        <p14:creationId xmlns:p14="http://schemas.microsoft.com/office/powerpoint/2010/main" val="1762637079"/>
       </p:ext>
     </p:extLst>
   </p:cSld>
@@ -22124,7 +22124,7 @@
           <p:cNvPr id="9" name="Slide_Title">
             <a:extLst xmlns:a="http://schemas.openxmlformats.org/drawingml/2006/main">
               <a:ext uri="{FF2B5EF4-FFF2-40B4-BE49-F238E27FC236}">
-                <a16:creationId xmlns:a16="http://schemas.microsoft.com/office/drawing/2014/main" id="{249F154B-E8D3-4821-8FCF-C0546A8AFFA3}"/>
+                <a16:creationId xmlns:a16="http://schemas.microsoft.com/office/drawing/2014/main" id="{A13FA6FB-4586-436F-9213-8685AB67BBBA}"/>
               </a:ext>
             </a:extLst>
           </p:cNvPr>
@@ -22282,7 +22282,7 @@
           <p:cNvPr id="2" name="Slide_Subtitle">
             <a:extLst xmlns:a="http://schemas.openxmlformats.org/drawingml/2006/main">
               <a:ext uri="{FF2B5EF4-FFF2-40B4-BE49-F238E27FC236}">
-                <a16:creationId xmlns:a16="http://schemas.microsoft.com/office/drawing/2014/main" id="{E652108F-D704-44DE-9605-A6F13B0083FE}"/>
+                <a16:creationId xmlns:a16="http://schemas.microsoft.com/office/drawing/2014/main" id="{CA35BC4F-372F-4AE3-B8D0-50B66F0B2C04}"/>
               </a:ext>
             </a:extLst>
           </p:cNvPr>
@@ -22440,7 +22440,7 @@
           <p:cNvPr id="3" name="S5_ObservedHeading">
             <a:extLst xmlns:a="http://schemas.openxmlformats.org/drawingml/2006/main">
               <a:ext uri="{FF2B5EF4-FFF2-40B4-BE49-F238E27FC236}">
-                <a16:creationId xmlns:a16="http://schemas.microsoft.com/office/drawing/2014/main" id="{C1537B49-ACAD-4F78-919E-061CC66EE63D}"/>
+                <a16:creationId xmlns:a16="http://schemas.microsoft.com/office/drawing/2014/main" id="{B03073D2-9B01-4BCC-B5CF-4DA87481E0EB}"/>
               </a:ext>
             </a:extLst>
           </p:cNvPr>
@@ -22598,7 +22598,7 @@
           <p:cNvPr id="4" name="S5_RoadmapHeading">
             <a:extLst xmlns:a="http://schemas.openxmlformats.org/drawingml/2006/main">
               <a:ext uri="{FF2B5EF4-FFF2-40B4-BE49-F238E27FC236}">
-                <a16:creationId xmlns:a16="http://schemas.microsoft.com/office/drawing/2014/main" id="{B10DFC59-A615-478C-867C-FC0E0A2A95FD}"/>
+                <a16:creationId xmlns:a16="http://schemas.microsoft.com/office/drawing/2014/main" id="{1998C943-2DEA-426B-AC68-BA6E4EC650BA}"/>
               </a:ext>
             </a:extLst>
           </p:cNvPr>
@@ -22756,7 +22756,7 @@
           <p:cNvPr id="5" name="S5_ObservedErrorsTable">
             <a:extLst xmlns:a="http://schemas.openxmlformats.org/drawingml/2006/main">
               <a:ext uri="{FF2B5EF4-FFF2-40B4-BE49-F238E27FC236}">
-                <a16:creationId xmlns:a16="http://schemas.microsoft.com/office/drawing/2014/main" id="{A64BAAD0-6060-4CBB-A0EF-B5748AE2ADC9}"/>
+                <a16:creationId xmlns:a16="http://schemas.microsoft.com/office/drawing/2014/main" id="{FD8DFCCD-B856-489A-9952-24700A49E4AF}"/>
               </a:ext>
             </a:extLst>
           </p:cNvPr>
@@ -23155,7 +23155,7 @@
           <p:cNvPr id="6" name="S5_RoadmapTable">
             <a:extLst xmlns:a="http://schemas.openxmlformats.org/drawingml/2006/main">
               <a:ext uri="{FF2B5EF4-FFF2-40B4-BE49-F238E27FC236}">
-                <a16:creationId xmlns:a16="http://schemas.microsoft.com/office/drawing/2014/main" id="{42CC93ED-2BCC-41EB-B2BF-2B5F6C9F9303}"/>
+                <a16:creationId xmlns:a16="http://schemas.microsoft.com/office/drawing/2014/main" id="{E97B22D1-9997-401C-BE75-8BF4928E841A}"/>
               </a:ext>
             </a:extLst>
           </p:cNvPr>
@@ -23323,7 +23323,7 @@
                           <a:ea typeface="Segoe UI"/>
                           <a:cs typeface="Segoe UI"/>
                         </a:rPr>
-                        <a:t>Publish/recycle; health 200; single + batch + privacy synthetic smoke. Không dùng baseline cũ để claim UI mới.</a:t>
+                        <a:t>Publish/recycle; health 200; single + multi-file + privacy synthetic smoke. Không dùng baseline cũ để claim UI mới.</a:t>
                       </a:r>
                     </a:p>
                   </a:txBody>
@@ -23403,7 +23403,7 @@
                           <a:ea typeface="Segoe UI"/>
                           <a:cs typeface="Segoe UI"/>
                         </a:rPr>
-                        <a:t>OIDC/SSO + RBAC + retention + object storage + legal review. Gate: sai quyền bị chặn và có audit.</a:t>
+                        <a:t>Demo dùng dữ liệu tổng hợp hoặc đã ẩn danh. Production thêm pre-inference control, OIDC/RBAC, retention và legal review.</a:t>
                       </a:r>
                     </a:p>
                   </a:txBody>
@@ -23675,7 +23675,7 @@
           <p:cNvPr id="7" name="S5_PrincipleBand">
             <a:extLst xmlns:a="http://schemas.openxmlformats.org/drawingml/2006/main">
               <a:ext uri="{FF2B5EF4-FFF2-40B4-BE49-F238E27FC236}">
-                <a16:creationId xmlns:a16="http://schemas.microsoft.com/office/drawing/2014/main" id="{C86074D3-1826-4511-B3BE-332A67E988C1}"/>
+                <a16:creationId xmlns:a16="http://schemas.microsoft.com/office/drawing/2014/main" id="{10EB2F53-E75E-4844-9238-5BB300CD8FA6}"/>
               </a:ext>
             </a:extLst>
           </p:cNvPr>
@@ -23710,7 +23710,7 @@
           <p:cNvPr id="8" name="S5_PrincipleText">
             <a:extLst xmlns:a="http://schemas.openxmlformats.org/drawingml/2006/main">
               <a:ext uri="{FF2B5EF4-FFF2-40B4-BE49-F238E27FC236}">
-                <a16:creationId xmlns:a16="http://schemas.microsoft.com/office/drawing/2014/main" id="{1D23A398-0414-48CE-A112-3574128C8189}"/>
+                <a16:creationId xmlns:a16="http://schemas.microsoft.com/office/drawing/2014/main" id="{8196BA33-2C02-42B0-B18F-8986F67B88DD}"/>
               </a:ext>
             </a:extLst>
           </p:cNvPr>
@@ -23858,7 +23858,7 @@
                 <a:ea typeface="Segoe UI"/>
                 <a:cs typeface="Segoe UI"/>
               </a:rPr>
-              <a:t>ĐÃ LÀM: batch • AI amount • privacy triage • dashboard + CSV | CHƯA CLAIM LIVE: publish + smoke</a:t>
+              <a:t>ĐÃ LÀM: multi-file • AI amount • privacy triage • dashboard + CSV | CHƯA CLAIM LIVE: publish + smoke</a:t>
             </a:r>
           </a:p>
         </p:txBody>
@@ -23866,7 +23866,7 @@
     </p:spTree>
     <p:extLst>
       <p:ext uri="{BB962C8B-B14F-4D97-AF65-F5344CB8AC3E}">
-        <p14:creationId xmlns:p14="http://schemas.microsoft.com/office/powerpoint/2010/main" val="2036011309"/>
+        <p14:creationId xmlns:p14="http://schemas.microsoft.com/office/powerpoint/2010/main" val="250379316"/>
       </p:ext>
     </p:extLst>
   </p:cSld>

</xml_diff>

<commit_message>
feat: let AI derive receipt amount
</commit_message>
<xml_diff>
--- a/AURA/submission/AURA_5_SLIDES_AFTER_FEEDBACK_FINAL.pptx
+++ b/AURA/submission/AURA_5_SLIDES_AFTER_FEEDBACK_FINAL.pptx
@@ -2,17 +2,17 @@
 <file path=ppt/presentation.xml><?xml version="1.0" encoding="utf-8"?>
 <p:presentation xmlns:p="http://schemas.openxmlformats.org/presentationml/2006/main">
   <p:sldMasterIdLst>
-    <p:sldMasterId xmlns:r="http://schemas.openxmlformats.org/officeDocument/2006/relationships" id="2147483648" r:id="R04c3212187524e4c"/>
+    <p:sldMasterId xmlns:r="http://schemas.openxmlformats.org/officeDocument/2006/relationships" id="2147483648" r:id="R2888a2824c4f4f32"/>
   </p:sldMasterIdLst>
   <p:notesMasterIdLst>
-    <p:notesMasterId xmlns:r="http://schemas.openxmlformats.org/officeDocument/2006/relationships" r:id="R4e986cc36a9e44b6"/>
+    <p:notesMasterId xmlns:r="http://schemas.openxmlformats.org/officeDocument/2006/relationships" r:id="Rf361537d17464ae9"/>
   </p:notesMasterIdLst>
   <p:sldIdLst>
-    <p:sldId xmlns:r="http://schemas.openxmlformats.org/officeDocument/2006/relationships" id="256" r:id="R66b82ea9162d47a7"/>
-    <p:sldId xmlns:r="http://schemas.openxmlformats.org/officeDocument/2006/relationships" id="257" r:id="R39d326d226a1477b"/>
-    <p:sldId xmlns:r="http://schemas.openxmlformats.org/officeDocument/2006/relationships" id="258" r:id="Rf3c6a0e818b14552"/>
-    <p:sldId xmlns:r="http://schemas.openxmlformats.org/officeDocument/2006/relationships" id="259" r:id="R3154f74726d34146"/>
-    <p:sldId xmlns:r="http://schemas.openxmlformats.org/officeDocument/2006/relationships" id="260" r:id="R92c006bf2dc54d67"/>
+    <p:sldId xmlns:r="http://schemas.openxmlformats.org/officeDocument/2006/relationships" id="256" r:id="R07656533628f4da6"/>
+    <p:sldId xmlns:r="http://schemas.openxmlformats.org/officeDocument/2006/relationships" id="257" r:id="R0c6517c15f4441f5"/>
+    <p:sldId xmlns:r="http://schemas.openxmlformats.org/officeDocument/2006/relationships" id="258" r:id="R237c3232ce014720"/>
+    <p:sldId xmlns:r="http://schemas.openxmlformats.org/officeDocument/2006/relationships" id="259" r:id="Rcdbc3bd5c43b4dcb"/>
+    <p:sldId xmlns:r="http://schemas.openxmlformats.org/officeDocument/2006/relationships" id="260" r:id="R6113cc9641fb4b7c"/>
   </p:sldIdLst>
   <p:sldSz cx="12192000" cy="6858000"/>
   <p:notesSz cx="6858000" cy="9144000"/>
@@ -586,7 +586,7 @@
           </a:p>
           <a:p xmlns:a="http://schemas.openxmlformats.org/drawingml/2006/main">
             <a:r>
-              <a:t>Số tiền là tùy chọn. Nếu để trống, worker chỉ dùng final total do AI trả về sau JSON Schema và semantic validation; nguồn USER_PROVIDED, AI_EXTRACTED hoặc UNAVAILABLE được audit.</a:t>
+              <a:t>UI đã bỏ ô nhập số tiền và không gửi claimedAmount. Worker chỉ dùng final total do AI trả về sau JSON Schema và semantic validation; nguồn của luồng demo là AI_EXTRACTED hoặc UNAVAILABLE. Nhánh USER_PROVIDED chỉ được giữ để tương thích test kit và API lịch sử.</a:t>
             </a:r>
           </a:p>
           <a:p xmlns:a="http://schemas.openxmlformats.org/drawingml/2006/main">
@@ -996,7 +996,7 @@
           </a:p>
           <a:p xmlns:a="http://schemas.openxmlformats.org/drawingml/2006/main">
             <a:r>
-              <a:t>Sau feedback, source đã có lượt chọn nhiều ảnh, AI-derived amount có provenance, privacy triage, dashboard ngày tháng năm và CSV report. Mỗi ảnh là một hồ sơ độc lập; chưa có InvoiceBatch hoặc batchId phía server. Release build sạch, 181 trên 181 test; report không sửa database model.</a:t>
+              <a:t>Sau feedback, source đã có lượt chọn nhiều ảnh, UI bỏ nhập amount để AI đọc final total, privacy triage, dashboard ngày tháng năm và CSV report. Mỗi ảnh là một hồ sơ độc lập; chưa có InvoiceBatch hoặc batchId phía server. Release build sạch, 181 trên 181 test; report không sửa database model.</a:t>
             </a:r>
           </a:p>
           <a:p xmlns:a="http://schemas.openxmlformats.org/drawingml/2006/main">
@@ -1006,7 +1006,7 @@
           </a:p>
           <a:p xmlns:a="http://schemas.openxmlformats.org/drawingml/2006/main">
             <a:r>
-              <a:t>Gate trước demo chiều nay là publish/recycle, health 200, rồi một single upload không nhập amount, một lượt nhiều ảnh nhỏ, một privacy synthetic case và tải CSV tháng. Không rerun holdout cũ để tạo claim accuracy mới.</a:t>
+              <a:t>Gate trước demo chiều nay là publish/recycle, health 200, rồi một single upload để xác nhận AI_EXTRACTED, một lượt nhiều ảnh nhỏ, một privacy synthetic case và tải CSV tháng. Không rerun holdout cũ để tạo claim accuracy mới.</a:t>
             </a:r>
           </a:p>
           <a:p xmlns:a="http://schemas.openxmlformats.org/drawingml/2006/main">
@@ -1093,7 +1093,7 @@
           <p:cNvPr id="3" name="Title">
             <a:extLst xmlns:a="http://schemas.openxmlformats.org/drawingml/2006/main">
               <a:ext uri="{FF2B5EF4-FFF2-40B4-BE49-F238E27FC236}">
-                <a16:creationId xmlns:a16="http://schemas.microsoft.com/office/drawing/2014/main" id="{12187CDD-AB00-4A11-948A-EE9170FC0A51}"/>
+                <a16:creationId xmlns:a16="http://schemas.microsoft.com/office/drawing/2014/main" id="{B8A2D079-7BFA-4EAF-A58D-BDCF602D8D14}"/>
               </a:ext>
             </a:extLst>
           </p:cNvPr>
@@ -1322,7 +1322,7 @@
           <p:cNvPr id="2" name="Subtitle">
             <a:extLst xmlns:a="http://schemas.openxmlformats.org/drawingml/2006/main">
               <a:ext uri="{FF2B5EF4-FFF2-40B4-BE49-F238E27FC236}">
-                <a16:creationId xmlns:a16="http://schemas.microsoft.com/office/drawing/2014/main" id="{3D7A2B52-CDE7-48C5-93B1-42FDF454C4C8}"/>
+                <a16:creationId xmlns:a16="http://schemas.microsoft.com/office/drawing/2014/main" id="{D3FEA917-7F52-443D-A9B4-5A384913B7C7}"/>
               </a:ext>
             </a:extLst>
           </p:cNvPr>
@@ -1568,7 +1568,7 @@
           <p:cNvPr id="4" name="Layout_Divider">
             <a:extLst xmlns:a="http://schemas.openxmlformats.org/drawingml/2006/main">
               <a:ext uri="{FF2B5EF4-FFF2-40B4-BE49-F238E27FC236}">
-                <a16:creationId xmlns:a16="http://schemas.microsoft.com/office/drawing/2014/main" id="{4F6CD396-A6E0-4DF3-B4C9-06F680ADE270}"/>
+                <a16:creationId xmlns:a16="http://schemas.microsoft.com/office/drawing/2014/main" id="{F8F0B1FC-68B0-46B6-A5E9-5C274CE98A1A}"/>
               </a:ext>
             </a:extLst>
           </p:cNvPr>
@@ -1599,7 +1599,7 @@
           <p:cNvPr id="2" name="Layout_Footer">
             <a:extLst xmlns:a="http://schemas.openxmlformats.org/drawingml/2006/main">
               <a:ext uri="{FF2B5EF4-FFF2-40B4-BE49-F238E27FC236}">
-                <a16:creationId xmlns:a16="http://schemas.microsoft.com/office/drawing/2014/main" id="{2DB0A4AB-7C16-473F-8FEE-A9531F10F6A7}"/>
+                <a16:creationId xmlns:a16="http://schemas.microsoft.com/office/drawing/2014/main" id="{AE859D08-E137-4A8D-8069-17DF34D6484F}"/>
               </a:ext>
             </a:extLst>
           </p:cNvPr>
@@ -1757,7 +1757,7 @@
           <p:cNvPr id="3" name="Layout_PageNumber">
             <a:extLst xmlns:a="http://schemas.openxmlformats.org/drawingml/2006/main">
               <a:ext uri="{FF2B5EF4-FFF2-40B4-BE49-F238E27FC236}">
-                <a16:creationId xmlns:a16="http://schemas.microsoft.com/office/drawing/2014/main" id="{9D7711FE-6762-4AB2-89F2-14F47AFB43B3}"/>
+                <a16:creationId xmlns:a16="http://schemas.microsoft.com/office/drawing/2014/main" id="{D54BD146-950B-4244-A2BE-A35E1490BC5D}"/>
               </a:ext>
             </a:extLst>
           </p:cNvPr>
@@ -1932,7 +1932,7 @@
           <p:cNvPr id="5" name="Layout_Divider">
             <a:extLst xmlns:a="http://schemas.openxmlformats.org/drawingml/2006/main">
               <a:ext uri="{FF2B5EF4-FFF2-40B4-BE49-F238E27FC236}">
-                <a16:creationId xmlns:a16="http://schemas.microsoft.com/office/drawing/2014/main" id="{3CDB3A81-D278-45BA-BC8D-5190E8E4B439}"/>
+                <a16:creationId xmlns:a16="http://schemas.microsoft.com/office/drawing/2014/main" id="{15B5785B-D64B-4D6C-9086-22A9B28BFA70}"/>
               </a:ext>
             </a:extLst>
           </p:cNvPr>
@@ -1963,7 +1963,7 @@
           <p:cNvPr id="2" name="Layout_Footer">
             <a:extLst xmlns:a="http://schemas.openxmlformats.org/drawingml/2006/main">
               <a:ext uri="{FF2B5EF4-FFF2-40B4-BE49-F238E27FC236}">
-                <a16:creationId xmlns:a16="http://schemas.microsoft.com/office/drawing/2014/main" id="{4E0F32BF-BE4A-4C88-8E59-144FF1847C9C}"/>
+                <a16:creationId xmlns:a16="http://schemas.microsoft.com/office/drawing/2014/main" id="{336ABC70-BC75-4ADA-9275-CB6035427CBA}"/>
               </a:ext>
             </a:extLst>
           </p:cNvPr>
@@ -2121,7 +2121,7 @@
           <p:cNvPr id="3" name="Layout_LimitFooter">
             <a:extLst xmlns:a="http://schemas.openxmlformats.org/drawingml/2006/main">
               <a:ext uri="{FF2B5EF4-FFF2-40B4-BE49-F238E27FC236}">
-                <a16:creationId xmlns:a16="http://schemas.microsoft.com/office/drawing/2014/main" id="{AD559905-2F7C-48AC-BA96-6E5D83A1BBE8}"/>
+                <a16:creationId xmlns:a16="http://schemas.microsoft.com/office/drawing/2014/main" id="{696D3179-540F-4198-8D66-5E73F1C9911E}"/>
               </a:ext>
             </a:extLst>
           </p:cNvPr>
@@ -2279,7 +2279,7 @@
           <p:cNvPr id="4" name="Layout_PageNumber">
             <a:extLst xmlns:a="http://schemas.openxmlformats.org/drawingml/2006/main">
               <a:ext uri="{FF2B5EF4-FFF2-40B4-BE49-F238E27FC236}">
-                <a16:creationId xmlns:a16="http://schemas.microsoft.com/office/drawing/2014/main" id="{E4BFB60F-F1C6-4C20-838C-42C0D9954AB1}"/>
+                <a16:creationId xmlns:a16="http://schemas.microsoft.com/office/drawing/2014/main" id="{54F2C894-F68D-43E5-A4E8-D8FBB695D7A4}"/>
               </a:ext>
             </a:extLst>
           </p:cNvPr>
@@ -2454,7 +2454,7 @@
           <p:cNvPr id="2" name="Section title">
             <a:extLst xmlns:a="http://schemas.openxmlformats.org/drawingml/2006/main">
               <a:ext uri="{FF2B5EF4-FFF2-40B4-BE49-F238E27FC236}">
-                <a16:creationId xmlns:a16="http://schemas.microsoft.com/office/drawing/2014/main" id="{9ACA76B6-0198-4BB3-B529-552017A07788}"/>
+                <a16:creationId xmlns:a16="http://schemas.microsoft.com/office/drawing/2014/main" id="{CE013FF0-5E45-4CB0-9113-52BCAB15E74D}"/>
               </a:ext>
             </a:extLst>
           </p:cNvPr>
@@ -2700,7 +2700,7 @@
           <p:cNvPr id="3" name="Title">
             <a:extLst xmlns:a="http://schemas.openxmlformats.org/drawingml/2006/main">
               <a:ext uri="{FF2B5EF4-FFF2-40B4-BE49-F238E27FC236}">
-                <a16:creationId xmlns:a16="http://schemas.microsoft.com/office/drawing/2014/main" id="{3B0B8DBC-60BC-4ACD-9113-FC1C283B5ED4}"/>
+                <a16:creationId xmlns:a16="http://schemas.microsoft.com/office/drawing/2014/main" id="{8E71B22A-EF6C-4A84-9C9B-469948DFB7F6}"/>
               </a:ext>
             </a:extLst>
           </p:cNvPr>
@@ -2929,7 +2929,7 @@
           <p:cNvPr id="2" name="Body">
             <a:extLst xmlns:a="http://schemas.openxmlformats.org/drawingml/2006/main">
               <a:ext uri="{FF2B5EF4-FFF2-40B4-BE49-F238E27FC236}">
-                <a16:creationId xmlns:a16="http://schemas.microsoft.com/office/drawing/2014/main" id="{150BA3C5-1FF3-4AE9-8FCC-6AC82BA03940}"/>
+                <a16:creationId xmlns:a16="http://schemas.microsoft.com/office/drawing/2014/main" id="{165D93C3-D2A6-48C5-9B02-4BE37AAA8490}"/>
               </a:ext>
             </a:extLst>
           </p:cNvPr>
@@ -3175,7 +3175,7 @@
           <p:cNvPr id="4" name="Title">
             <a:extLst xmlns:a="http://schemas.openxmlformats.org/drawingml/2006/main">
               <a:ext uri="{FF2B5EF4-FFF2-40B4-BE49-F238E27FC236}">
-                <a16:creationId xmlns:a16="http://schemas.microsoft.com/office/drawing/2014/main" id="{F40BBE38-006C-4341-BA75-10BF98CA96E0}"/>
+                <a16:creationId xmlns:a16="http://schemas.microsoft.com/office/drawing/2014/main" id="{81501B23-3C9D-4833-8E3D-981E0AD46F08}"/>
               </a:ext>
             </a:extLst>
           </p:cNvPr>
@@ -3404,7 +3404,7 @@
           <p:cNvPr id="2" name="Left column">
             <a:extLst xmlns:a="http://schemas.openxmlformats.org/drawingml/2006/main">
               <a:ext uri="{FF2B5EF4-FFF2-40B4-BE49-F238E27FC236}">
-                <a16:creationId xmlns:a16="http://schemas.microsoft.com/office/drawing/2014/main" id="{5E55D2F9-1BA3-4279-BE8E-7DEFF22F0072}"/>
+                <a16:creationId xmlns:a16="http://schemas.microsoft.com/office/drawing/2014/main" id="{CD4E58C3-E208-4990-8F7F-28C0F3EAA301}"/>
               </a:ext>
             </a:extLst>
           </p:cNvPr>
@@ -3633,7 +3633,7 @@
           <p:cNvPr id="3" name="Right column">
             <a:extLst xmlns:a="http://schemas.openxmlformats.org/drawingml/2006/main">
               <a:ext uri="{FF2B5EF4-FFF2-40B4-BE49-F238E27FC236}">
-                <a16:creationId xmlns:a16="http://schemas.microsoft.com/office/drawing/2014/main" id="{D6C7A842-9506-406B-9BEE-EA5F1E98CB39}"/>
+                <a16:creationId xmlns:a16="http://schemas.microsoft.com/office/drawing/2014/main" id="{E2863794-BE26-4388-A99C-904414C9A846}"/>
               </a:ext>
             </a:extLst>
           </p:cNvPr>
@@ -3879,7 +3879,7 @@
           <p:cNvPr id="3" name="Title">
             <a:extLst xmlns:a="http://schemas.openxmlformats.org/drawingml/2006/main">
               <a:ext uri="{FF2B5EF4-FFF2-40B4-BE49-F238E27FC236}">
-                <a16:creationId xmlns:a16="http://schemas.microsoft.com/office/drawing/2014/main" id="{D27DD856-9362-4401-90BF-92BD234B8A08}"/>
+                <a16:creationId xmlns:a16="http://schemas.microsoft.com/office/drawing/2014/main" id="{1C6E91C4-CD7D-4C80-8E04-9C998A949F30}"/>
               </a:ext>
             </a:extLst>
           </p:cNvPr>
@@ -4108,7 +4108,7 @@
           <p:cNvPr id="2" name="Left column">
             <a:extLst xmlns:a="http://schemas.openxmlformats.org/drawingml/2006/main">
               <a:ext uri="{FF2B5EF4-FFF2-40B4-BE49-F238E27FC236}">
-                <a16:creationId xmlns:a16="http://schemas.microsoft.com/office/drawing/2014/main" id="{4616AB63-A8C7-491E-866A-796CA56CED9C}"/>
+                <a16:creationId xmlns:a16="http://schemas.microsoft.com/office/drawing/2014/main" id="{A39946C1-D088-46B1-8ADD-FCE469B78F62}"/>
               </a:ext>
             </a:extLst>
           </p:cNvPr>
@@ -4371,7 +4371,7 @@
           <p:cNvPr id="4" name="Layout_Divider">
             <a:extLst xmlns:a="http://schemas.openxmlformats.org/drawingml/2006/main">
               <a:ext uri="{FF2B5EF4-FFF2-40B4-BE49-F238E27FC236}">
-                <a16:creationId xmlns:a16="http://schemas.microsoft.com/office/drawing/2014/main" id="{F4EB696E-DA16-4BEE-9776-C450DED76939}"/>
+                <a16:creationId xmlns:a16="http://schemas.microsoft.com/office/drawing/2014/main" id="{E38C51A9-E662-4205-970F-E418518214A0}"/>
               </a:ext>
             </a:extLst>
           </p:cNvPr>
@@ -4402,7 +4402,7 @@
           <p:cNvPr id="2" name="Layout_Footer">
             <a:extLst xmlns:a="http://schemas.openxmlformats.org/drawingml/2006/main">
               <a:ext uri="{FF2B5EF4-FFF2-40B4-BE49-F238E27FC236}">
-                <a16:creationId xmlns:a16="http://schemas.microsoft.com/office/drawing/2014/main" id="{D85B752C-1C49-49AF-9BE8-6ED5363E1C66}"/>
+                <a16:creationId xmlns:a16="http://schemas.microsoft.com/office/drawing/2014/main" id="{6290BE7D-F9DE-4BE4-9D32-DAA7CA8F6228}"/>
               </a:ext>
             </a:extLst>
           </p:cNvPr>
@@ -4560,7 +4560,7 @@
           <p:cNvPr id="3" name="Layout_PageNumber">
             <a:extLst xmlns:a="http://schemas.openxmlformats.org/drawingml/2006/main">
               <a:ext uri="{FF2B5EF4-FFF2-40B4-BE49-F238E27FC236}">
-                <a16:creationId xmlns:a16="http://schemas.microsoft.com/office/drawing/2014/main" id="{80447396-91CC-4C0A-9658-9D32CCEF2EE3}"/>
+                <a16:creationId xmlns:a16="http://schemas.microsoft.com/office/drawing/2014/main" id="{38BCA413-8F95-49C9-92E4-A9540D04FC8F}"/>
               </a:ext>
             </a:extLst>
           </p:cNvPr>
@@ -4735,7 +4735,7 @@
           <p:cNvPr id="4" name="Layout_Divider">
             <a:extLst xmlns:a="http://schemas.openxmlformats.org/drawingml/2006/main">
               <a:ext uri="{FF2B5EF4-FFF2-40B4-BE49-F238E27FC236}">
-                <a16:creationId xmlns:a16="http://schemas.microsoft.com/office/drawing/2014/main" id="{C154E09E-C726-4E6C-8C00-7CFE91DBAB6B}"/>
+                <a16:creationId xmlns:a16="http://schemas.microsoft.com/office/drawing/2014/main" id="{95350D48-E5CF-4E40-83D6-4900BF25B50A}"/>
               </a:ext>
             </a:extLst>
           </p:cNvPr>
@@ -4766,7 +4766,7 @@
           <p:cNvPr id="2" name="Layout_Footer">
             <a:extLst xmlns:a="http://schemas.openxmlformats.org/drawingml/2006/main">
               <a:ext uri="{FF2B5EF4-FFF2-40B4-BE49-F238E27FC236}">
-                <a16:creationId xmlns:a16="http://schemas.microsoft.com/office/drawing/2014/main" id="{3AAECE1E-FAB6-4257-9657-06793EB8A7D4}"/>
+                <a16:creationId xmlns:a16="http://schemas.microsoft.com/office/drawing/2014/main" id="{93016E4F-677F-4AD5-BD2C-23481BF5FD8E}"/>
               </a:ext>
             </a:extLst>
           </p:cNvPr>
@@ -4924,7 +4924,7 @@
           <p:cNvPr id="3" name="Layout_PageNumber">
             <a:extLst xmlns:a="http://schemas.openxmlformats.org/drawingml/2006/main">
               <a:ext uri="{FF2B5EF4-FFF2-40B4-BE49-F238E27FC236}">
-                <a16:creationId xmlns:a16="http://schemas.microsoft.com/office/drawing/2014/main" id="{5E33C388-7DEA-4FC2-B651-1AC5AA952EE0}"/>
+                <a16:creationId xmlns:a16="http://schemas.microsoft.com/office/drawing/2014/main" id="{E702E901-161A-47AC-982F-267DE7B1AA76}"/>
               </a:ext>
             </a:extLst>
           </p:cNvPr>
@@ -5099,7 +5099,7 @@
           <p:cNvPr id="4" name="Layout_Divider">
             <a:extLst xmlns:a="http://schemas.openxmlformats.org/drawingml/2006/main">
               <a:ext uri="{FF2B5EF4-FFF2-40B4-BE49-F238E27FC236}">
-                <a16:creationId xmlns:a16="http://schemas.microsoft.com/office/drawing/2014/main" id="{E4210654-9DC0-4397-B117-3631BA1A9C25}"/>
+                <a16:creationId xmlns:a16="http://schemas.microsoft.com/office/drawing/2014/main" id="{18C52F32-29E9-40B3-A5EC-3FFFAA5E858D}"/>
               </a:ext>
             </a:extLst>
           </p:cNvPr>
@@ -5130,7 +5130,7 @@
           <p:cNvPr id="2" name="Layout_Footer">
             <a:extLst xmlns:a="http://schemas.openxmlformats.org/drawingml/2006/main">
               <a:ext uri="{FF2B5EF4-FFF2-40B4-BE49-F238E27FC236}">
-                <a16:creationId xmlns:a16="http://schemas.microsoft.com/office/drawing/2014/main" id="{6CAA744C-49CA-4A19-A6C2-6BF541179923}"/>
+                <a16:creationId xmlns:a16="http://schemas.microsoft.com/office/drawing/2014/main" id="{745A452D-14F3-4A1B-A605-1ADF9E64A6BD}"/>
               </a:ext>
             </a:extLst>
           </p:cNvPr>
@@ -5288,7 +5288,7 @@
           <p:cNvPr id="3" name="Layout_PageNumber">
             <a:extLst xmlns:a="http://schemas.openxmlformats.org/drawingml/2006/main">
               <a:ext uri="{FF2B5EF4-FFF2-40B4-BE49-F238E27FC236}">
-                <a16:creationId xmlns:a16="http://schemas.microsoft.com/office/drawing/2014/main" id="{E1C782D8-D54C-4984-B039-CBBB396CC34F}"/>
+                <a16:creationId xmlns:a16="http://schemas.microsoft.com/office/drawing/2014/main" id="{FC3456E1-09C0-48F1-A498-D080A66A1FDA}"/>
               </a:ext>
             </a:extLst>
           </p:cNvPr>
@@ -5467,17 +5467,17 @@
   </p:cSld>
   <p:clrMap bg1="lt1" tx1="dk1" bg2="lt2" tx2="dk2" accent1="accent1" accent2="accent2" accent3="accent3" accent4="accent4" accent5="accent5" accent6="accent6" hlink="hlink" folHlink="folHlink"/>
   <p:sldLayoutIdLst>
-    <p:sldLayoutId xmlns:r="http://schemas.openxmlformats.org/officeDocument/2006/relationships" id="2147483649" r:id="Rc5fd84240dfc455c"/>
-    <p:sldLayoutId xmlns:r="http://schemas.openxmlformats.org/officeDocument/2006/relationships" id="2147483650" r:id="Rcdc4ed1303aa45ce"/>
-    <p:sldLayoutId xmlns:r="http://schemas.openxmlformats.org/officeDocument/2006/relationships" id="2147483651" r:id="R047d3afa2d9740a0"/>
-    <p:sldLayoutId xmlns:r="http://schemas.openxmlformats.org/officeDocument/2006/relationships" id="2147483652" r:id="Ra302de8f63394927"/>
-    <p:sldLayoutId xmlns:r="http://schemas.openxmlformats.org/officeDocument/2006/relationships" id="2147483653" r:id="R0cfc28b2a0384f72"/>
-    <p:sldLayoutId xmlns:r="http://schemas.openxmlformats.org/officeDocument/2006/relationships" id="2147483654" r:id="R5a168920aaf941c7"/>
-    <p:sldLayoutId xmlns:r="http://schemas.openxmlformats.org/officeDocument/2006/relationships" id="2147483655" r:id="Rd374b80323f44307"/>
-    <p:sldLayoutId xmlns:r="http://schemas.openxmlformats.org/officeDocument/2006/relationships" id="2147483656" r:id="R05453e16e1eb46f1"/>
-    <p:sldLayoutId xmlns:r="http://schemas.openxmlformats.org/officeDocument/2006/relationships" id="2147483657" r:id="R2dd8180ff3a3441b"/>
-    <p:sldLayoutId xmlns:r="http://schemas.openxmlformats.org/officeDocument/2006/relationships" id="2147483658" r:id="R48e4e4396ee140b9"/>
-    <p:sldLayoutId xmlns:r="http://schemas.openxmlformats.org/officeDocument/2006/relationships" id="2147483659" r:id="R6656a7a73b3b4b42"/>
+    <p:sldLayoutId xmlns:r="http://schemas.openxmlformats.org/officeDocument/2006/relationships" id="2147483649" r:id="Rbfbba6b1a4704953"/>
+    <p:sldLayoutId xmlns:r="http://schemas.openxmlformats.org/officeDocument/2006/relationships" id="2147483650" r:id="R29017e5fc9ee4ce3"/>
+    <p:sldLayoutId xmlns:r="http://schemas.openxmlformats.org/officeDocument/2006/relationships" id="2147483651" r:id="Ra2e3cf2a6960491b"/>
+    <p:sldLayoutId xmlns:r="http://schemas.openxmlformats.org/officeDocument/2006/relationships" id="2147483652" r:id="R5351d881558449a1"/>
+    <p:sldLayoutId xmlns:r="http://schemas.openxmlformats.org/officeDocument/2006/relationships" id="2147483653" r:id="R4fce10f220fa41c2"/>
+    <p:sldLayoutId xmlns:r="http://schemas.openxmlformats.org/officeDocument/2006/relationships" id="2147483654" r:id="R689c5f74740745d8"/>
+    <p:sldLayoutId xmlns:r="http://schemas.openxmlformats.org/officeDocument/2006/relationships" id="2147483655" r:id="Rb2645d3aefde4c43"/>
+    <p:sldLayoutId xmlns:r="http://schemas.openxmlformats.org/officeDocument/2006/relationships" id="2147483656" r:id="Rb2c9d0a31e934b4d"/>
+    <p:sldLayoutId xmlns:r="http://schemas.openxmlformats.org/officeDocument/2006/relationships" id="2147483657" r:id="R9cee0f6fa79b45de"/>
+    <p:sldLayoutId xmlns:r="http://schemas.openxmlformats.org/officeDocument/2006/relationships" id="2147483658" r:id="R7bd0a6baf2e74147"/>
+    <p:sldLayoutId xmlns:r="http://schemas.openxmlformats.org/officeDocument/2006/relationships" id="2147483659" r:id="R26b8c758e7764c5f"/>
   </p:sldLayoutIdLst>
   <p:txStyles>
     <p:titleStyle>
@@ -6028,7 +6028,7 @@
           <p:cNvPr id="37" name="Slide_Title">
             <a:extLst xmlns:a="http://schemas.openxmlformats.org/drawingml/2006/main">
               <a:ext uri="{FF2B5EF4-FFF2-40B4-BE49-F238E27FC236}">
-                <a16:creationId xmlns:a16="http://schemas.microsoft.com/office/drawing/2014/main" id="{6B318F80-3727-4069-8DFF-7D97771F56EA}"/>
+                <a16:creationId xmlns:a16="http://schemas.microsoft.com/office/drawing/2014/main" id="{9D4403B6-8446-4D4B-A03E-AA7B9BA2303A}"/>
               </a:ext>
             </a:extLst>
           </p:cNvPr>
@@ -6186,7 +6186,7 @@
           <p:cNvPr id="2" name="Slide_Subtitle">
             <a:extLst xmlns:a="http://schemas.openxmlformats.org/drawingml/2006/main">
               <a:ext uri="{FF2B5EF4-FFF2-40B4-BE49-F238E27FC236}">
-                <a16:creationId xmlns:a16="http://schemas.microsoft.com/office/drawing/2014/main" id="{920B0482-9D3C-4892-BC16-0AF2EC3100CD}"/>
+                <a16:creationId xmlns:a16="http://schemas.microsoft.com/office/drawing/2014/main" id="{71B21D65-E571-48AC-BE46-DC469D1A0DBF}"/>
               </a:ext>
             </a:extLst>
           </p:cNvPr>
@@ -6344,7 +6344,7 @@
           <p:cNvPr id="3" name="S1_Flow_1">
             <a:extLst xmlns:a="http://schemas.openxmlformats.org/drawingml/2006/main">
               <a:ext uri="{FF2B5EF4-FFF2-40B4-BE49-F238E27FC236}">
-                <a16:creationId xmlns:a16="http://schemas.microsoft.com/office/drawing/2014/main" id="{788952B1-871F-4485-902C-AA8FF5B4143B}"/>
+                <a16:creationId xmlns:a16="http://schemas.microsoft.com/office/drawing/2014/main" id="{81043EE4-2892-4608-857D-FBED564B4841}"/>
               </a:ext>
             </a:extLst>
           </p:cNvPr>
@@ -6379,7 +6379,7 @@
           <p:cNvPr id="4" name="S1_FlowIcon_1">
             <a:extLst xmlns:a="http://schemas.openxmlformats.org/drawingml/2006/main">
               <a:ext uri="{FF2B5EF4-FFF2-40B4-BE49-F238E27FC236}">
-                <a16:creationId xmlns:a16="http://schemas.microsoft.com/office/drawing/2014/main" id="{DD7BF85B-1616-4E23-8EA9-9EEF497BD4D6}"/>
+                <a16:creationId xmlns:a16="http://schemas.microsoft.com/office/drawing/2014/main" id="{D42178FA-A632-4253-87B5-79DC2053F9D1}"/>
               </a:ext>
             </a:extLst>
           </p:cNvPr>
@@ -6540,7 +6540,7 @@
           <p:cNvPr id="5" name="S1_FlowLabel_1">
             <a:extLst xmlns:a="http://schemas.openxmlformats.org/drawingml/2006/main">
               <a:ext uri="{FF2B5EF4-FFF2-40B4-BE49-F238E27FC236}">
-                <a16:creationId xmlns:a16="http://schemas.microsoft.com/office/drawing/2014/main" id="{D4723D74-B9F8-4DE2-86A2-F55A2E3A6002}"/>
+                <a16:creationId xmlns:a16="http://schemas.microsoft.com/office/drawing/2014/main" id="{509BE57E-977D-4D2A-8905-0475B2847F2F}"/>
               </a:ext>
             </a:extLst>
           </p:cNvPr>
@@ -6698,7 +6698,7 @@
           <p:cNvPr id="6" name="S1_FlowRule_1">
             <a:extLst xmlns:a="http://schemas.openxmlformats.org/drawingml/2006/main">
               <a:ext uri="{FF2B5EF4-FFF2-40B4-BE49-F238E27FC236}">
-                <a16:creationId xmlns:a16="http://schemas.microsoft.com/office/drawing/2014/main" id="{05873335-0B70-4FC2-A0E4-9C09519B2C6D}"/>
+                <a16:creationId xmlns:a16="http://schemas.microsoft.com/office/drawing/2014/main" id="{30C12228-C8D7-494D-B620-307CDE137EDA}"/>
               </a:ext>
             </a:extLst>
           </p:cNvPr>
@@ -6729,7 +6729,7 @@
           <p:cNvPr id="7" name="S1_FlowPain_1">
             <a:extLst xmlns:a="http://schemas.openxmlformats.org/drawingml/2006/main">
               <a:ext uri="{FF2B5EF4-FFF2-40B4-BE49-F238E27FC236}">
-                <a16:creationId xmlns:a16="http://schemas.microsoft.com/office/drawing/2014/main" id="{94B71277-974C-41B7-8DF1-8518E0BDE82A}"/>
+                <a16:creationId xmlns:a16="http://schemas.microsoft.com/office/drawing/2014/main" id="{577D23D1-3261-4C82-A3FE-37745143FDFD}"/>
               </a:ext>
             </a:extLst>
           </p:cNvPr>
@@ -6887,7 +6887,7 @@
           <p:cNvPr id="8" name="S1_Arrow_1">
             <a:extLst xmlns:a="http://schemas.openxmlformats.org/drawingml/2006/main">
               <a:ext uri="{FF2B5EF4-FFF2-40B4-BE49-F238E27FC236}">
-                <a16:creationId xmlns:a16="http://schemas.microsoft.com/office/drawing/2014/main" id="{7E8C1DEF-34DB-49DF-851E-FD193A1AF765}"/>
+                <a16:creationId xmlns:a16="http://schemas.microsoft.com/office/drawing/2014/main" id="{9F07E40E-B69F-45D2-B5F7-59181C32EAEE}"/>
               </a:ext>
             </a:extLst>
           </p:cNvPr>
@@ -6919,7 +6919,7 @@
           <p:cNvPr id="9" name="S1_Flow_2">
             <a:extLst xmlns:a="http://schemas.openxmlformats.org/drawingml/2006/main">
               <a:ext uri="{FF2B5EF4-FFF2-40B4-BE49-F238E27FC236}">
-                <a16:creationId xmlns:a16="http://schemas.microsoft.com/office/drawing/2014/main" id="{FE28981B-7ECE-4829-A483-C2EE4EA94082}"/>
+                <a16:creationId xmlns:a16="http://schemas.microsoft.com/office/drawing/2014/main" id="{DC4F098E-DDCC-46BF-B89E-451F7EE2BF13}"/>
               </a:ext>
             </a:extLst>
           </p:cNvPr>
@@ -6954,7 +6954,7 @@
           <p:cNvPr id="10" name="S1_FlowIcon_2">
             <a:extLst xmlns:a="http://schemas.openxmlformats.org/drawingml/2006/main">
               <a:ext uri="{FF2B5EF4-FFF2-40B4-BE49-F238E27FC236}">
-                <a16:creationId xmlns:a16="http://schemas.microsoft.com/office/drawing/2014/main" id="{5984069F-1E90-47E2-846B-93C67139673C}"/>
+                <a16:creationId xmlns:a16="http://schemas.microsoft.com/office/drawing/2014/main" id="{C273D4CE-E281-43A3-9BDF-9EA060DF6EA2}"/>
               </a:ext>
             </a:extLst>
           </p:cNvPr>
@@ -7115,7 +7115,7 @@
           <p:cNvPr id="11" name="S1_FlowLabel_2">
             <a:extLst xmlns:a="http://schemas.openxmlformats.org/drawingml/2006/main">
               <a:ext uri="{FF2B5EF4-FFF2-40B4-BE49-F238E27FC236}">
-                <a16:creationId xmlns:a16="http://schemas.microsoft.com/office/drawing/2014/main" id="{FFDB831D-A42B-4AF8-A552-ED9C62D86326}"/>
+                <a16:creationId xmlns:a16="http://schemas.microsoft.com/office/drawing/2014/main" id="{8DD03603-C4A4-4F64-A03F-6A6340B45E14}"/>
               </a:ext>
             </a:extLst>
           </p:cNvPr>
@@ -7273,7 +7273,7 @@
           <p:cNvPr id="12" name="S1_FlowRule_2">
             <a:extLst xmlns:a="http://schemas.openxmlformats.org/drawingml/2006/main">
               <a:ext uri="{FF2B5EF4-FFF2-40B4-BE49-F238E27FC236}">
-                <a16:creationId xmlns:a16="http://schemas.microsoft.com/office/drawing/2014/main" id="{D3F8D3BC-123B-4D9C-B065-ACB881967BF5}"/>
+                <a16:creationId xmlns:a16="http://schemas.microsoft.com/office/drawing/2014/main" id="{F21EDEA0-6CB2-4A88-B22A-7C4679E9C839}"/>
               </a:ext>
             </a:extLst>
           </p:cNvPr>
@@ -7304,7 +7304,7 @@
           <p:cNvPr id="13" name="S1_FlowPain_2">
             <a:extLst xmlns:a="http://schemas.openxmlformats.org/drawingml/2006/main">
               <a:ext uri="{FF2B5EF4-FFF2-40B4-BE49-F238E27FC236}">
-                <a16:creationId xmlns:a16="http://schemas.microsoft.com/office/drawing/2014/main" id="{F9B69E6C-61EB-4F1A-BDFC-3845787EC0BF}"/>
+                <a16:creationId xmlns:a16="http://schemas.microsoft.com/office/drawing/2014/main" id="{697C63D6-3252-48E7-AABE-CA09A3877DA4}"/>
               </a:ext>
             </a:extLst>
           </p:cNvPr>
@@ -7462,7 +7462,7 @@
           <p:cNvPr id="14" name="S1_Arrow_2">
             <a:extLst xmlns:a="http://schemas.openxmlformats.org/drawingml/2006/main">
               <a:ext uri="{FF2B5EF4-FFF2-40B4-BE49-F238E27FC236}">
-                <a16:creationId xmlns:a16="http://schemas.microsoft.com/office/drawing/2014/main" id="{8211CD97-CD12-4ED5-8818-4B385377070A}"/>
+                <a16:creationId xmlns:a16="http://schemas.microsoft.com/office/drawing/2014/main" id="{7B3F51F3-6590-4850-AE0D-A65BD23B0DDA}"/>
               </a:ext>
             </a:extLst>
           </p:cNvPr>
@@ -7494,7 +7494,7 @@
           <p:cNvPr id="15" name="S1_Flow_3">
             <a:extLst xmlns:a="http://schemas.openxmlformats.org/drawingml/2006/main">
               <a:ext uri="{FF2B5EF4-FFF2-40B4-BE49-F238E27FC236}">
-                <a16:creationId xmlns:a16="http://schemas.microsoft.com/office/drawing/2014/main" id="{A8F7D0EB-3965-4151-A5BF-1BBD4E969882}"/>
+                <a16:creationId xmlns:a16="http://schemas.microsoft.com/office/drawing/2014/main" id="{E0479D31-1B0B-44CD-896C-A9F2B35E9A9B}"/>
               </a:ext>
             </a:extLst>
           </p:cNvPr>
@@ -7529,7 +7529,7 @@
           <p:cNvPr id="16" name="S1_FlowIcon_3">
             <a:extLst xmlns:a="http://schemas.openxmlformats.org/drawingml/2006/main">
               <a:ext uri="{FF2B5EF4-FFF2-40B4-BE49-F238E27FC236}">
-                <a16:creationId xmlns:a16="http://schemas.microsoft.com/office/drawing/2014/main" id="{F6C2DC5A-0970-4565-8E35-0AA4FEA250A4}"/>
+                <a16:creationId xmlns:a16="http://schemas.microsoft.com/office/drawing/2014/main" id="{75E70BCB-904E-4021-A80E-0A2617730602}"/>
               </a:ext>
             </a:extLst>
           </p:cNvPr>
@@ -7690,7 +7690,7 @@
           <p:cNvPr id="17" name="S1_FlowLabel_3">
             <a:extLst xmlns:a="http://schemas.openxmlformats.org/drawingml/2006/main">
               <a:ext uri="{FF2B5EF4-FFF2-40B4-BE49-F238E27FC236}">
-                <a16:creationId xmlns:a16="http://schemas.microsoft.com/office/drawing/2014/main" id="{D23BC839-36C0-4F5C-8AAE-EDC4D7247295}"/>
+                <a16:creationId xmlns:a16="http://schemas.microsoft.com/office/drawing/2014/main" id="{557B76E7-7A11-4D8F-9F7C-B225B1747744}"/>
               </a:ext>
             </a:extLst>
           </p:cNvPr>
@@ -7848,7 +7848,7 @@
           <p:cNvPr id="18" name="S1_FlowRule_3">
             <a:extLst xmlns:a="http://schemas.openxmlformats.org/drawingml/2006/main">
               <a:ext uri="{FF2B5EF4-FFF2-40B4-BE49-F238E27FC236}">
-                <a16:creationId xmlns:a16="http://schemas.microsoft.com/office/drawing/2014/main" id="{9C3E96EA-5D05-41CB-8DB1-F1DF19B80670}"/>
+                <a16:creationId xmlns:a16="http://schemas.microsoft.com/office/drawing/2014/main" id="{23BFB661-8520-49C7-BC30-C9E327A5C626}"/>
               </a:ext>
             </a:extLst>
           </p:cNvPr>
@@ -7879,7 +7879,7 @@
           <p:cNvPr id="19" name="S1_FlowPain_3">
             <a:extLst xmlns:a="http://schemas.openxmlformats.org/drawingml/2006/main">
               <a:ext uri="{FF2B5EF4-FFF2-40B4-BE49-F238E27FC236}">
-                <a16:creationId xmlns:a16="http://schemas.microsoft.com/office/drawing/2014/main" id="{183D64BC-635C-4948-8CEB-AD81A539D5BC}"/>
+                <a16:creationId xmlns:a16="http://schemas.microsoft.com/office/drawing/2014/main" id="{6B26C4B8-01E5-441B-AFE1-60DA7A366853}"/>
               </a:ext>
             </a:extLst>
           </p:cNvPr>
@@ -8037,7 +8037,7 @@
           <p:cNvPr id="20" name="S1_Arrow_3">
             <a:extLst xmlns:a="http://schemas.openxmlformats.org/drawingml/2006/main">
               <a:ext uri="{FF2B5EF4-FFF2-40B4-BE49-F238E27FC236}">
-                <a16:creationId xmlns:a16="http://schemas.microsoft.com/office/drawing/2014/main" id="{D8BB2769-E250-4D78-BA53-F4ACDD9C1C56}"/>
+                <a16:creationId xmlns:a16="http://schemas.microsoft.com/office/drawing/2014/main" id="{85A7C027-F6EE-4686-93EE-ED696F45EE9A}"/>
               </a:ext>
             </a:extLst>
           </p:cNvPr>
@@ -8069,7 +8069,7 @@
           <p:cNvPr id="21" name="S1_Flow_4">
             <a:extLst xmlns:a="http://schemas.openxmlformats.org/drawingml/2006/main">
               <a:ext uri="{FF2B5EF4-FFF2-40B4-BE49-F238E27FC236}">
-                <a16:creationId xmlns:a16="http://schemas.microsoft.com/office/drawing/2014/main" id="{E38574FB-DCA3-4F42-8DDA-C0239ED1F0C1}"/>
+                <a16:creationId xmlns:a16="http://schemas.microsoft.com/office/drawing/2014/main" id="{F81DB411-DB39-4599-B24B-63FFCA766BF0}"/>
               </a:ext>
             </a:extLst>
           </p:cNvPr>
@@ -8104,7 +8104,7 @@
           <p:cNvPr id="22" name="S1_FlowIcon_4">
             <a:extLst xmlns:a="http://schemas.openxmlformats.org/drawingml/2006/main">
               <a:ext uri="{FF2B5EF4-FFF2-40B4-BE49-F238E27FC236}">
-                <a16:creationId xmlns:a16="http://schemas.microsoft.com/office/drawing/2014/main" id="{EF5FDA22-31E3-4304-9852-0EA59F643B9C}"/>
+                <a16:creationId xmlns:a16="http://schemas.microsoft.com/office/drawing/2014/main" id="{C03606CC-0AFA-4783-9434-367B9F0138A3}"/>
               </a:ext>
             </a:extLst>
           </p:cNvPr>
@@ -8265,7 +8265,7 @@
           <p:cNvPr id="23" name="S1_FlowLabel_4">
             <a:extLst xmlns:a="http://schemas.openxmlformats.org/drawingml/2006/main">
               <a:ext uri="{FF2B5EF4-FFF2-40B4-BE49-F238E27FC236}">
-                <a16:creationId xmlns:a16="http://schemas.microsoft.com/office/drawing/2014/main" id="{3D2DDEBB-6070-4B7B-969E-6C6BF3228C9E}"/>
+                <a16:creationId xmlns:a16="http://schemas.microsoft.com/office/drawing/2014/main" id="{4636F89F-E859-418D-BF05-FD4D84645BB2}"/>
               </a:ext>
             </a:extLst>
           </p:cNvPr>
@@ -8423,7 +8423,7 @@
           <p:cNvPr id="24" name="S1_FlowRule_4">
             <a:extLst xmlns:a="http://schemas.openxmlformats.org/drawingml/2006/main">
               <a:ext uri="{FF2B5EF4-FFF2-40B4-BE49-F238E27FC236}">
-                <a16:creationId xmlns:a16="http://schemas.microsoft.com/office/drawing/2014/main" id="{76599961-8AA8-43D4-822B-EC6858C49BEA}"/>
+                <a16:creationId xmlns:a16="http://schemas.microsoft.com/office/drawing/2014/main" id="{D1B273C3-FAE2-4574-AB83-BDB6112D81C1}"/>
               </a:ext>
             </a:extLst>
           </p:cNvPr>
@@ -8454,7 +8454,7 @@
           <p:cNvPr id="25" name="S1_FlowPain_4">
             <a:extLst xmlns:a="http://schemas.openxmlformats.org/drawingml/2006/main">
               <a:ext uri="{FF2B5EF4-FFF2-40B4-BE49-F238E27FC236}">
-                <a16:creationId xmlns:a16="http://schemas.microsoft.com/office/drawing/2014/main" id="{BC640636-2919-4A3F-A830-2EEC9516286C}"/>
+                <a16:creationId xmlns:a16="http://schemas.microsoft.com/office/drawing/2014/main" id="{C74C3320-FC16-4DEE-AB5A-5C7D604EA695}"/>
               </a:ext>
             </a:extLst>
           </p:cNvPr>
@@ -8612,7 +8612,7 @@
           <p:cNvPr id="26" name="S1_Arrow_4">
             <a:extLst xmlns:a="http://schemas.openxmlformats.org/drawingml/2006/main">
               <a:ext uri="{FF2B5EF4-FFF2-40B4-BE49-F238E27FC236}">
-                <a16:creationId xmlns:a16="http://schemas.microsoft.com/office/drawing/2014/main" id="{86F9A40E-25B7-4334-9245-23DB38AD40DD}"/>
+                <a16:creationId xmlns:a16="http://schemas.microsoft.com/office/drawing/2014/main" id="{C5A5A3A4-2398-4F6B-96E9-2E500BAAD1AF}"/>
               </a:ext>
             </a:extLst>
           </p:cNvPr>
@@ -8644,7 +8644,7 @@
           <p:cNvPr id="27" name="S1_Flow_5">
             <a:extLst xmlns:a="http://schemas.openxmlformats.org/drawingml/2006/main">
               <a:ext uri="{FF2B5EF4-FFF2-40B4-BE49-F238E27FC236}">
-                <a16:creationId xmlns:a16="http://schemas.microsoft.com/office/drawing/2014/main" id="{659EC34B-9826-4B9D-9E08-FF62A6DF25D5}"/>
+                <a16:creationId xmlns:a16="http://schemas.microsoft.com/office/drawing/2014/main" id="{B0C8FDF7-9018-4A30-BBA2-6F98CACBC02A}"/>
               </a:ext>
             </a:extLst>
           </p:cNvPr>
@@ -8679,7 +8679,7 @@
           <p:cNvPr id="28" name="S1_FlowIcon_5">
             <a:extLst xmlns:a="http://schemas.openxmlformats.org/drawingml/2006/main">
               <a:ext uri="{FF2B5EF4-FFF2-40B4-BE49-F238E27FC236}">
-                <a16:creationId xmlns:a16="http://schemas.microsoft.com/office/drawing/2014/main" id="{8A7CEBB0-0E8A-47BF-B7BF-6299D381B47F}"/>
+                <a16:creationId xmlns:a16="http://schemas.microsoft.com/office/drawing/2014/main" id="{9AF5EB28-F010-4DFB-8138-A980F8E64C2F}"/>
               </a:ext>
             </a:extLst>
           </p:cNvPr>
@@ -8840,7 +8840,7 @@
           <p:cNvPr id="29" name="S1_FlowLabel_5">
             <a:extLst xmlns:a="http://schemas.openxmlformats.org/drawingml/2006/main">
               <a:ext uri="{FF2B5EF4-FFF2-40B4-BE49-F238E27FC236}">
-                <a16:creationId xmlns:a16="http://schemas.microsoft.com/office/drawing/2014/main" id="{3BA130D2-63EF-4AB5-82D8-4AED838B8587}"/>
+                <a16:creationId xmlns:a16="http://schemas.microsoft.com/office/drawing/2014/main" id="{D016B837-1451-4D84-AFD3-E68B3A3A530C}"/>
               </a:ext>
             </a:extLst>
           </p:cNvPr>
@@ -8998,7 +8998,7 @@
           <p:cNvPr id="30" name="S1_FlowRule_5">
             <a:extLst xmlns:a="http://schemas.openxmlformats.org/drawingml/2006/main">
               <a:ext uri="{FF2B5EF4-FFF2-40B4-BE49-F238E27FC236}">
-                <a16:creationId xmlns:a16="http://schemas.microsoft.com/office/drawing/2014/main" id="{6B0FAE70-6266-459B-848F-BF486DE3ADD5}"/>
+                <a16:creationId xmlns:a16="http://schemas.microsoft.com/office/drawing/2014/main" id="{54A7AB5B-5D68-4AFC-AED5-956386298D6E}"/>
               </a:ext>
             </a:extLst>
           </p:cNvPr>
@@ -9029,7 +9029,7 @@
           <p:cNvPr id="31" name="S1_FlowPain_5">
             <a:extLst xmlns:a="http://schemas.openxmlformats.org/drawingml/2006/main">
               <a:ext uri="{FF2B5EF4-FFF2-40B4-BE49-F238E27FC236}">
-                <a16:creationId xmlns:a16="http://schemas.microsoft.com/office/drawing/2014/main" id="{089E4613-CC10-4FC8-96E8-58A194D8A32F}"/>
+                <a16:creationId xmlns:a16="http://schemas.microsoft.com/office/drawing/2014/main" id="{FDA98A27-2E88-4163-8ACA-980CD7616E1A}"/>
               </a:ext>
             </a:extLst>
           </p:cNvPr>
@@ -9187,7 +9187,7 @@
           <p:cNvPr id="32" name="S1_GapBand">
             <a:extLst xmlns:a="http://schemas.openxmlformats.org/drawingml/2006/main">
               <a:ext uri="{FF2B5EF4-FFF2-40B4-BE49-F238E27FC236}">
-                <a16:creationId xmlns:a16="http://schemas.microsoft.com/office/drawing/2014/main" id="{9EF873A6-B5E9-4B31-9F86-9B032C1B3D17}"/>
+                <a16:creationId xmlns:a16="http://schemas.microsoft.com/office/drawing/2014/main" id="{796FEE5D-1C1E-4B10-8F0F-0B1E518D72CE}"/>
               </a:ext>
             </a:extLst>
           </p:cNvPr>
@@ -9222,7 +9222,7 @@
           <p:cNvPr id="33" name="S1_GapLabel">
             <a:extLst xmlns:a="http://schemas.openxmlformats.org/drawingml/2006/main">
               <a:ext uri="{FF2B5EF4-FFF2-40B4-BE49-F238E27FC236}">
-                <a16:creationId xmlns:a16="http://schemas.microsoft.com/office/drawing/2014/main" id="{C0F0419F-0C69-4839-86E5-FDD96F3A38A0}"/>
+                <a16:creationId xmlns:a16="http://schemas.microsoft.com/office/drawing/2014/main" id="{BB61C3C0-048D-4914-BC8C-DAAAD22697D5}"/>
               </a:ext>
             </a:extLst>
           </p:cNvPr>
@@ -9380,7 +9380,7 @@
           <p:cNvPr id="34" name="S1_GapText">
             <a:extLst xmlns:a="http://schemas.openxmlformats.org/drawingml/2006/main">
               <a:ext uri="{FF2B5EF4-FFF2-40B4-BE49-F238E27FC236}">
-                <a16:creationId xmlns:a16="http://schemas.microsoft.com/office/drawing/2014/main" id="{F6AB1E76-77EB-45CD-91DD-925E2DC91B5A}"/>
+                <a16:creationId xmlns:a16="http://schemas.microsoft.com/office/drawing/2014/main" id="{E5DF9B13-D807-4172-8F19-FFD291ABC5F2}"/>
               </a:ext>
             </a:extLst>
           </p:cNvPr>
@@ -9538,7 +9538,7 @@
           <p:cNvPr id="35" name="S1_BridgeRule">
             <a:extLst xmlns:a="http://schemas.openxmlformats.org/drawingml/2006/main">
               <a:ext uri="{FF2B5EF4-FFF2-40B4-BE49-F238E27FC236}">
-                <a16:creationId xmlns:a16="http://schemas.microsoft.com/office/drawing/2014/main" id="{A631CAB5-E5AD-4E5C-AD66-88BDFFDF6594}"/>
+                <a16:creationId xmlns:a16="http://schemas.microsoft.com/office/drawing/2014/main" id="{43FE1C30-E9CE-4F44-B694-1237BEFDD10E}"/>
               </a:ext>
             </a:extLst>
           </p:cNvPr>
@@ -9569,7 +9569,7 @@
           <p:cNvPr id="36" name="S1_Bridge">
             <a:extLst xmlns:a="http://schemas.openxmlformats.org/drawingml/2006/main">
               <a:ext uri="{FF2B5EF4-FFF2-40B4-BE49-F238E27FC236}">
-                <a16:creationId xmlns:a16="http://schemas.microsoft.com/office/drawing/2014/main" id="{33897FF2-48D6-4833-8BB0-900ACD77C403}"/>
+                <a16:creationId xmlns:a16="http://schemas.microsoft.com/office/drawing/2014/main" id="{19187BEF-7F67-41EF-A5A9-D87CBBAB67DE}"/>
               </a:ext>
             </a:extLst>
           </p:cNvPr>
@@ -9725,7 +9725,7 @@
     </p:spTree>
     <p:extLst>
       <p:ext uri="{BB962C8B-B14F-4D97-AF65-F5344CB8AC3E}">
-        <p14:creationId xmlns:p14="http://schemas.microsoft.com/office/powerpoint/2010/main" val="1063306165"/>
+        <p14:creationId xmlns:p14="http://schemas.microsoft.com/office/powerpoint/2010/main" val="1121353204"/>
       </p:ext>
     </p:extLst>
   </p:cSld>
@@ -9756,7 +9756,7 @@
           <p:cNvPr id="41" name="Slide_Title">
             <a:extLst xmlns:a="http://schemas.openxmlformats.org/drawingml/2006/main">
               <a:ext uri="{FF2B5EF4-FFF2-40B4-BE49-F238E27FC236}">
-                <a16:creationId xmlns:a16="http://schemas.microsoft.com/office/drawing/2014/main" id="{1FEE5C2C-DE41-427B-84B9-421E6250ABCE}"/>
+                <a16:creationId xmlns:a16="http://schemas.microsoft.com/office/drawing/2014/main" id="{3253602A-5553-49B4-A79C-5E5E0FE9D6A2}"/>
               </a:ext>
             </a:extLst>
           </p:cNvPr>
@@ -9914,7 +9914,7 @@
           <p:cNvPr id="2" name="Slide_Subtitle">
             <a:extLst xmlns:a="http://schemas.openxmlformats.org/drawingml/2006/main">
               <a:ext uri="{FF2B5EF4-FFF2-40B4-BE49-F238E27FC236}">
-                <a16:creationId xmlns:a16="http://schemas.microsoft.com/office/drawing/2014/main" id="{684E8B2E-B54E-4117-B2B3-E8ADC6E99C5E}"/>
+                <a16:creationId xmlns:a16="http://schemas.microsoft.com/office/drawing/2014/main" id="{7F74FED2-AFE4-4E53-9B4B-A4CD1AA0BEF7}"/>
               </a:ext>
             </a:extLst>
           </p:cNvPr>
@@ -10072,7 +10072,7 @@
           <p:cNvPr id="3" name="S2_Column_1">
             <a:extLst xmlns:a="http://schemas.openxmlformats.org/drawingml/2006/main">
               <a:ext uri="{FF2B5EF4-FFF2-40B4-BE49-F238E27FC236}">
-                <a16:creationId xmlns:a16="http://schemas.microsoft.com/office/drawing/2014/main" id="{2F7637F2-03EC-4149-B35B-C648C9645F70}"/>
+                <a16:creationId xmlns:a16="http://schemas.microsoft.com/office/drawing/2014/main" id="{6B6BA362-638B-4F29-8B7F-C93868FC45BE}"/>
               </a:ext>
             </a:extLst>
           </p:cNvPr>
@@ -10230,7 +10230,7 @@
           <p:cNvPr id="4" name="S2_Column_2">
             <a:extLst xmlns:a="http://schemas.openxmlformats.org/drawingml/2006/main">
               <a:ext uri="{FF2B5EF4-FFF2-40B4-BE49-F238E27FC236}">
-                <a16:creationId xmlns:a16="http://schemas.microsoft.com/office/drawing/2014/main" id="{F8526BAD-7554-4B02-BE66-5E3CC008018B}"/>
+                <a16:creationId xmlns:a16="http://schemas.microsoft.com/office/drawing/2014/main" id="{7E36E1A0-4CB9-4749-ACCD-384EABA85CE5}"/>
               </a:ext>
             </a:extLst>
           </p:cNvPr>
@@ -10388,7 +10388,7 @@
           <p:cNvPr id="5" name="S2_Column_3">
             <a:extLst xmlns:a="http://schemas.openxmlformats.org/drawingml/2006/main">
               <a:ext uri="{FF2B5EF4-FFF2-40B4-BE49-F238E27FC236}">
-                <a16:creationId xmlns:a16="http://schemas.microsoft.com/office/drawing/2014/main" id="{B39FDD47-CB89-46B5-B53E-3BF0C0B419F4}"/>
+                <a16:creationId xmlns:a16="http://schemas.microsoft.com/office/drawing/2014/main" id="{5235429C-304F-4EEB-90FE-E02FC5EAD362}"/>
               </a:ext>
             </a:extLst>
           </p:cNvPr>
@@ -10546,7 +10546,7 @@
           <p:cNvPr id="6" name="S2_SystemLabel">
             <a:extLst xmlns:a="http://schemas.openxmlformats.org/drawingml/2006/main">
               <a:ext uri="{FF2B5EF4-FFF2-40B4-BE49-F238E27FC236}">
-                <a16:creationId xmlns:a16="http://schemas.microsoft.com/office/drawing/2014/main" id="{94229307-6F64-482C-81EC-B888E4CBBE5B}"/>
+                <a16:creationId xmlns:a16="http://schemas.microsoft.com/office/drawing/2014/main" id="{25B8D7E1-D125-487E-AF7E-0F267AEEF0BD}"/>
               </a:ext>
             </a:extLst>
           </p:cNvPr>
@@ -10581,7 +10581,7 @@
           <p:cNvPr id="7" name="S2_SystemLabelText">
             <a:extLst xmlns:a="http://schemas.openxmlformats.org/drawingml/2006/main">
               <a:ext uri="{FF2B5EF4-FFF2-40B4-BE49-F238E27FC236}">
-                <a16:creationId xmlns:a16="http://schemas.microsoft.com/office/drawing/2014/main" id="{449FFE4F-85C8-4E28-9016-A0265A19766C}"/>
+                <a16:creationId xmlns:a16="http://schemas.microsoft.com/office/drawing/2014/main" id="{50D53075-8D86-4AD5-A1F5-FD82F0D98E91}"/>
               </a:ext>
             </a:extLst>
           </p:cNvPr>
@@ -10739,7 +10739,7 @@
           <p:cNvPr id="8" name="S2_HumanLabel">
             <a:extLst xmlns:a="http://schemas.openxmlformats.org/drawingml/2006/main">
               <a:ext uri="{FF2B5EF4-FFF2-40B4-BE49-F238E27FC236}">
-                <a16:creationId xmlns:a16="http://schemas.microsoft.com/office/drawing/2014/main" id="{943AF5D2-3DDE-4165-B311-8CB63AE7BE2B}"/>
+                <a16:creationId xmlns:a16="http://schemas.microsoft.com/office/drawing/2014/main" id="{2181EC7A-0638-487D-8514-1B9136889F5A}"/>
               </a:ext>
             </a:extLst>
           </p:cNvPr>
@@ -10774,7 +10774,7 @@
           <p:cNvPr id="9" name="S2_HumanLabelText">
             <a:extLst xmlns:a="http://schemas.openxmlformats.org/drawingml/2006/main">
               <a:ext uri="{FF2B5EF4-FFF2-40B4-BE49-F238E27FC236}">
-                <a16:creationId xmlns:a16="http://schemas.microsoft.com/office/drawing/2014/main" id="{59AEAD67-FC4B-40DE-BE29-4CB13CFF3BF1}"/>
+                <a16:creationId xmlns:a16="http://schemas.microsoft.com/office/drawing/2014/main" id="{C562E3C1-95C3-4B2D-945C-C81968A9EE05}"/>
               </a:ext>
             </a:extLst>
           </p:cNvPr>
@@ -10932,7 +10932,7 @@
           <p:cNvPr id="10" name="S2_InputSystem">
             <a:extLst xmlns:a="http://schemas.openxmlformats.org/drawingml/2006/main">
               <a:ext uri="{FF2B5EF4-FFF2-40B4-BE49-F238E27FC236}">
-                <a16:creationId xmlns:a16="http://schemas.microsoft.com/office/drawing/2014/main" id="{780E35C4-03C8-431F-9809-DA8E099641F9}"/>
+                <a16:creationId xmlns:a16="http://schemas.microsoft.com/office/drawing/2014/main" id="{A97D1263-ABE4-4B81-9037-59CE8E62F1F0}"/>
               </a:ext>
             </a:extLst>
           </p:cNvPr>
@@ -10967,7 +10967,7 @@
           <p:cNvPr id="11" name="S2_PhaseA">
             <a:extLst xmlns:a="http://schemas.openxmlformats.org/drawingml/2006/main">
               <a:ext uri="{FF2B5EF4-FFF2-40B4-BE49-F238E27FC236}">
-                <a16:creationId xmlns:a16="http://schemas.microsoft.com/office/drawing/2014/main" id="{0EC9C1BE-58B6-419E-8C6A-70E647AF17C1}"/>
+                <a16:creationId xmlns:a16="http://schemas.microsoft.com/office/drawing/2014/main" id="{DC451991-5E9F-4DF0-9E6D-925BA21800EB}"/>
               </a:ext>
             </a:extLst>
           </p:cNvPr>
@@ -11132,7 +11132,7 @@
           <p:cNvPr id="12" name="S2_PhaseATitle">
             <a:extLst xmlns:a="http://schemas.openxmlformats.org/drawingml/2006/main">
               <a:ext uri="{FF2B5EF4-FFF2-40B4-BE49-F238E27FC236}">
-                <a16:creationId xmlns:a16="http://schemas.microsoft.com/office/drawing/2014/main" id="{34A012D9-0CA2-4C24-AAD6-8D95521FC1CB}"/>
+                <a16:creationId xmlns:a16="http://schemas.microsoft.com/office/drawing/2014/main" id="{C41792F4-EAA1-49AB-8DBB-DD0B82BA55F7}"/>
               </a:ext>
             </a:extLst>
           </p:cNvPr>
@@ -11290,7 +11290,7 @@
           <p:cNvPr id="13" name="S2_PhaseADetail">
             <a:extLst xmlns:a="http://schemas.openxmlformats.org/drawingml/2006/main">
               <a:ext uri="{FF2B5EF4-FFF2-40B4-BE49-F238E27FC236}">
-                <a16:creationId xmlns:a16="http://schemas.microsoft.com/office/drawing/2014/main" id="{69900313-D168-4123-BD5C-399802668E9E}"/>
+                <a16:creationId xmlns:a16="http://schemas.microsoft.com/office/drawing/2014/main" id="{C8C3461D-2851-4844-84B3-AB73F5A4412B}"/>
               </a:ext>
             </a:extLst>
           </p:cNvPr>
@@ -11517,7 +11517,7 @@
           <p:cNvPr id="14" name="S2_ProcessSystem">
             <a:extLst xmlns:a="http://schemas.openxmlformats.org/drawingml/2006/main">
               <a:ext uri="{FF2B5EF4-FFF2-40B4-BE49-F238E27FC236}">
-                <a16:creationId xmlns:a16="http://schemas.microsoft.com/office/drawing/2014/main" id="{E7238EEB-4604-4E02-A567-A2D933F0F725}"/>
+                <a16:creationId xmlns:a16="http://schemas.microsoft.com/office/drawing/2014/main" id="{EFCB608E-CD0C-4FE4-AD77-7F583DD5D281}"/>
               </a:ext>
             </a:extLst>
           </p:cNvPr>
@@ -11552,7 +11552,7 @@
           <p:cNvPr id="15" name="S2_PhaseB">
             <a:extLst xmlns:a="http://schemas.openxmlformats.org/drawingml/2006/main">
               <a:ext uri="{FF2B5EF4-FFF2-40B4-BE49-F238E27FC236}">
-                <a16:creationId xmlns:a16="http://schemas.microsoft.com/office/drawing/2014/main" id="{054EAA77-D91C-4D53-944D-B623D200BF0B}"/>
+                <a16:creationId xmlns:a16="http://schemas.microsoft.com/office/drawing/2014/main" id="{52DCAF2C-B986-4FF2-8EE3-17D29AD9EADA}"/>
               </a:ext>
             </a:extLst>
           </p:cNvPr>
@@ -11717,7 +11717,7 @@
           <p:cNvPr id="16" name="S2_PhaseBDetail">
             <a:extLst xmlns:a="http://schemas.openxmlformats.org/drawingml/2006/main">
               <a:ext uri="{FF2B5EF4-FFF2-40B4-BE49-F238E27FC236}">
-                <a16:creationId xmlns:a16="http://schemas.microsoft.com/office/drawing/2014/main" id="{A565058E-0F17-4C7A-A922-329F13E576FF}"/>
+                <a16:creationId xmlns:a16="http://schemas.microsoft.com/office/drawing/2014/main" id="{C7B4DC97-0124-449C-88EE-55BAB22AA4DE}"/>
               </a:ext>
             </a:extLst>
           </p:cNvPr>
@@ -11898,7 +11898,7 @@
           <p:cNvPr id="17" name="S2_ProcessDivider">
             <a:extLst xmlns:a="http://schemas.openxmlformats.org/drawingml/2006/main">
               <a:ext uri="{FF2B5EF4-FFF2-40B4-BE49-F238E27FC236}">
-                <a16:creationId xmlns:a16="http://schemas.microsoft.com/office/drawing/2014/main" id="{32BECF5A-5657-4F51-A8FB-098738B0BA5C}"/>
+                <a16:creationId xmlns:a16="http://schemas.microsoft.com/office/drawing/2014/main" id="{8537EDD2-E07D-4C88-AD0C-D3DDB10B8787}"/>
               </a:ext>
             </a:extLst>
           </p:cNvPr>
@@ -11929,7 +11929,7 @@
           <p:cNvPr id="18" name="S2_PhaseC">
             <a:extLst xmlns:a="http://schemas.openxmlformats.org/drawingml/2006/main">
               <a:ext uri="{FF2B5EF4-FFF2-40B4-BE49-F238E27FC236}">
-                <a16:creationId xmlns:a16="http://schemas.microsoft.com/office/drawing/2014/main" id="{8124DB43-D658-496F-A3BF-DC93F5BD6F1B}"/>
+                <a16:creationId xmlns:a16="http://schemas.microsoft.com/office/drawing/2014/main" id="{C3079388-8C41-4956-8933-9FA387AE8BAE}"/>
               </a:ext>
             </a:extLst>
           </p:cNvPr>
@@ -12094,7 +12094,7 @@
           <p:cNvPr id="19" name="S2_PhaseCDetail">
             <a:extLst xmlns:a="http://schemas.openxmlformats.org/drawingml/2006/main">
               <a:ext uri="{FF2B5EF4-FFF2-40B4-BE49-F238E27FC236}">
-                <a16:creationId xmlns:a16="http://schemas.microsoft.com/office/drawing/2014/main" id="{142254E3-5C78-4221-8B37-D211B5D3A869}"/>
+                <a16:creationId xmlns:a16="http://schemas.microsoft.com/office/drawing/2014/main" id="{A34DB0F1-CDDC-4B4C-AA7F-8642BBD2508B}"/>
               </a:ext>
             </a:extLst>
           </p:cNvPr>
@@ -12275,7 +12275,7 @@
           <p:cNvPr id="20" name="S2_OutputSystem">
             <a:extLst xmlns:a="http://schemas.openxmlformats.org/drawingml/2006/main">
               <a:ext uri="{FF2B5EF4-FFF2-40B4-BE49-F238E27FC236}">
-                <a16:creationId xmlns:a16="http://schemas.microsoft.com/office/drawing/2014/main" id="{9C92A9C2-92DD-4448-BD7D-8AA8A9F7FAEE}"/>
+                <a16:creationId xmlns:a16="http://schemas.microsoft.com/office/drawing/2014/main" id="{7EC65169-DE6A-4584-804A-ED9D120FF133}"/>
               </a:ext>
             </a:extLst>
           </p:cNvPr>
@@ -12310,7 +12310,7 @@
           <p:cNvPr id="21" name="S2_PhaseD">
             <a:extLst xmlns:a="http://schemas.openxmlformats.org/drawingml/2006/main">
               <a:ext uri="{FF2B5EF4-FFF2-40B4-BE49-F238E27FC236}">
-                <a16:creationId xmlns:a16="http://schemas.microsoft.com/office/drawing/2014/main" id="{D9CFFD06-6B1F-44E8-8F68-7369B007A89D}"/>
+                <a16:creationId xmlns:a16="http://schemas.microsoft.com/office/drawing/2014/main" id="{9EA9E86F-3347-4457-A3F0-351B81DA1DC1}"/>
               </a:ext>
             </a:extLst>
           </p:cNvPr>
@@ -12475,7 +12475,7 @@
           <p:cNvPr id="22" name="S2_PhaseDTitle">
             <a:extLst xmlns:a="http://schemas.openxmlformats.org/drawingml/2006/main">
               <a:ext uri="{FF2B5EF4-FFF2-40B4-BE49-F238E27FC236}">
-                <a16:creationId xmlns:a16="http://schemas.microsoft.com/office/drawing/2014/main" id="{4FF904BB-3672-4336-BC48-3C55F2FA018A}"/>
+                <a16:creationId xmlns:a16="http://schemas.microsoft.com/office/drawing/2014/main" id="{0B85CE87-D53C-44B9-B913-9A169140AACA}"/>
               </a:ext>
             </a:extLst>
           </p:cNvPr>
@@ -12633,7 +12633,7 @@
           <p:cNvPr id="23" name="S2_PhaseDDetail">
             <a:extLst xmlns:a="http://schemas.openxmlformats.org/drawingml/2006/main">
               <a:ext uri="{FF2B5EF4-FFF2-40B4-BE49-F238E27FC236}">
-                <a16:creationId xmlns:a16="http://schemas.microsoft.com/office/drawing/2014/main" id="{A86687E0-1CF9-4ECF-A372-C249991EB026}"/>
+                <a16:creationId xmlns:a16="http://schemas.microsoft.com/office/drawing/2014/main" id="{1B703CDA-5685-4E47-92C9-0B9D4E5196BE}"/>
               </a:ext>
             </a:extLst>
           </p:cNvPr>
@@ -12814,7 +12814,7 @@
           <p:cNvPr id="24" name="S2_AutoBranch">
             <a:extLst xmlns:a="http://schemas.openxmlformats.org/drawingml/2006/main">
               <a:ext uri="{FF2B5EF4-FFF2-40B4-BE49-F238E27FC236}">
-                <a16:creationId xmlns:a16="http://schemas.microsoft.com/office/drawing/2014/main" id="{CF48E7AE-8B20-45E6-A3E1-04DA7481431B}"/>
+                <a16:creationId xmlns:a16="http://schemas.microsoft.com/office/drawing/2014/main" id="{11655E5E-2CEB-46EC-8889-965182DE7DAC}"/>
               </a:ext>
             </a:extLst>
           </p:cNvPr>
@@ -12849,7 +12849,7 @@
           <p:cNvPr id="25" name="S2_AutoBranchText">
             <a:extLst xmlns:a="http://schemas.openxmlformats.org/drawingml/2006/main">
               <a:ext uri="{FF2B5EF4-FFF2-40B4-BE49-F238E27FC236}">
-                <a16:creationId xmlns:a16="http://schemas.microsoft.com/office/drawing/2014/main" id="{96A01E4D-B22E-4E42-9597-992C12353FB0}"/>
+                <a16:creationId xmlns:a16="http://schemas.microsoft.com/office/drawing/2014/main" id="{5003CAC6-5986-4450-8954-243DF05FD7AD}"/>
               </a:ext>
             </a:extLst>
           </p:cNvPr>
@@ -13030,7 +13030,7 @@
           <p:cNvPr id="26" name="S2_EscalateBranch">
             <a:extLst xmlns:a="http://schemas.openxmlformats.org/drawingml/2006/main">
               <a:ext uri="{FF2B5EF4-FFF2-40B4-BE49-F238E27FC236}">
-                <a16:creationId xmlns:a16="http://schemas.microsoft.com/office/drawing/2014/main" id="{34571E99-F4D3-44E0-BCA8-2CAECDBD8E41}"/>
+                <a16:creationId xmlns:a16="http://schemas.microsoft.com/office/drawing/2014/main" id="{3E961AC0-8333-4055-8820-FB8783FE8308}"/>
               </a:ext>
             </a:extLst>
           </p:cNvPr>
@@ -13065,7 +13065,7 @@
           <p:cNvPr id="27" name="S2_EscalateBranchText">
             <a:extLst xmlns:a="http://schemas.openxmlformats.org/drawingml/2006/main">
               <a:ext uri="{FF2B5EF4-FFF2-40B4-BE49-F238E27FC236}">
-                <a16:creationId xmlns:a16="http://schemas.microsoft.com/office/drawing/2014/main" id="{E1A73DBC-EF77-4B89-97E0-4BAA2B7AE80F}"/>
+                <a16:creationId xmlns:a16="http://schemas.microsoft.com/office/drawing/2014/main" id="{9BC7E730-840A-46D3-88DF-7570A6E475E4}"/>
               </a:ext>
             </a:extLst>
           </p:cNvPr>
@@ -13246,7 +13246,7 @@
           <p:cNvPr id="28" name="S2_InputHuman">
             <a:extLst xmlns:a="http://schemas.openxmlformats.org/drawingml/2006/main">
               <a:ext uri="{FF2B5EF4-FFF2-40B4-BE49-F238E27FC236}">
-                <a16:creationId xmlns:a16="http://schemas.microsoft.com/office/drawing/2014/main" id="{223533F5-D3DC-48F3-86A8-6746184DFCF7}"/>
+                <a16:creationId xmlns:a16="http://schemas.microsoft.com/office/drawing/2014/main" id="{50522264-2677-4060-8060-9BCE44906819}"/>
               </a:ext>
             </a:extLst>
           </p:cNvPr>
@@ -13281,7 +13281,7 @@
           <p:cNvPr id="29" name="S2_InputHumanTitle">
             <a:extLst xmlns:a="http://schemas.openxmlformats.org/drawingml/2006/main">
               <a:ext uri="{FF2B5EF4-FFF2-40B4-BE49-F238E27FC236}">
-                <a16:creationId xmlns:a16="http://schemas.microsoft.com/office/drawing/2014/main" id="{36EA8625-4D1A-464D-975C-2B07EF648493}"/>
+                <a16:creationId xmlns:a16="http://schemas.microsoft.com/office/drawing/2014/main" id="{9A3E2EBE-AFDC-4CA0-8B81-75A3F7897F55}"/>
               </a:ext>
             </a:extLst>
           </p:cNvPr>
@@ -13439,7 +13439,7 @@
           <p:cNvPr id="30" name="S2_InputHumanDetail">
             <a:extLst xmlns:a="http://schemas.openxmlformats.org/drawingml/2006/main">
               <a:ext uri="{FF2B5EF4-FFF2-40B4-BE49-F238E27FC236}">
-                <a16:creationId xmlns:a16="http://schemas.microsoft.com/office/drawing/2014/main" id="{7FA2213D-3D49-4801-A494-46B384128744}"/>
+                <a16:creationId xmlns:a16="http://schemas.microsoft.com/office/drawing/2014/main" id="{035D5879-4DBD-40BA-9DD0-B5C349AFC3A2}"/>
               </a:ext>
             </a:extLst>
           </p:cNvPr>
@@ -13587,7 +13587,7 @@
                 <a:ea typeface="Segoe UI"/>
                 <a:cs typeface="Segoe UI"/>
               </a:rPr>
-              <a:t>Chọn tối đa 10 ảnh và metadata. Số tiền là tùy chọn.</a:t>
+              <a:t>Chọn tối đa 10 ảnh và metadata. AI tự đọc tổng tiền.</a:t>
             </a:r>
           </a:p>
         </p:txBody>
@@ -13597,7 +13597,7 @@
           <p:cNvPr id="31" name="S2_ProcessHuman">
             <a:extLst xmlns:a="http://schemas.openxmlformats.org/drawingml/2006/main">
               <a:ext uri="{FF2B5EF4-FFF2-40B4-BE49-F238E27FC236}">
-                <a16:creationId xmlns:a16="http://schemas.microsoft.com/office/drawing/2014/main" id="{2BAA5168-FDC6-41FA-9BAE-EC94A61D0F59}"/>
+                <a16:creationId xmlns:a16="http://schemas.microsoft.com/office/drawing/2014/main" id="{CA12F2BB-00E2-4050-91A6-2DE1F38803ED}"/>
               </a:ext>
             </a:extLst>
           </p:cNvPr>
@@ -13632,7 +13632,7 @@
           <p:cNvPr id="32" name="S2_ProcessHumanTitle">
             <a:extLst xmlns:a="http://schemas.openxmlformats.org/drawingml/2006/main">
               <a:ext uri="{FF2B5EF4-FFF2-40B4-BE49-F238E27FC236}">
-                <a16:creationId xmlns:a16="http://schemas.microsoft.com/office/drawing/2014/main" id="{4EC9A57A-1741-48F1-8FE3-E050EBAE8E10}"/>
+                <a16:creationId xmlns:a16="http://schemas.microsoft.com/office/drawing/2014/main" id="{8C359099-B493-4B08-8394-2CFF8B7B5AD3}"/>
               </a:ext>
             </a:extLst>
           </p:cNvPr>
@@ -13790,7 +13790,7 @@
           <p:cNvPr id="33" name="S2_ProcessHumanDetail">
             <a:extLst xmlns:a="http://schemas.openxmlformats.org/drawingml/2006/main">
               <a:ext uri="{FF2B5EF4-FFF2-40B4-BE49-F238E27FC236}">
-                <a16:creationId xmlns:a16="http://schemas.microsoft.com/office/drawing/2014/main" id="{F7BED0B7-E350-45AD-88D4-7D8453A9D5AE}"/>
+                <a16:creationId xmlns:a16="http://schemas.microsoft.com/office/drawing/2014/main" id="{24DA397A-7507-489F-AA14-85EF471E859B}"/>
               </a:ext>
             </a:extLst>
           </p:cNvPr>
@@ -13948,7 +13948,7 @@
           <p:cNvPr id="34" name="S2_OutputHuman">
             <a:extLst xmlns:a="http://schemas.openxmlformats.org/drawingml/2006/main">
               <a:ext uri="{FF2B5EF4-FFF2-40B4-BE49-F238E27FC236}">
-                <a16:creationId xmlns:a16="http://schemas.microsoft.com/office/drawing/2014/main" id="{00C177E1-60FC-4E3D-99C6-BCA2C4D7F1D2}"/>
+                <a16:creationId xmlns:a16="http://schemas.microsoft.com/office/drawing/2014/main" id="{45365347-695E-4833-8E60-EF8DCEA143FD}"/>
               </a:ext>
             </a:extLst>
           </p:cNvPr>
@@ -13983,7 +13983,7 @@
           <p:cNvPr id="35" name="S2_Gate9">
             <a:extLst xmlns:a="http://schemas.openxmlformats.org/drawingml/2006/main">
               <a:ext uri="{FF2B5EF4-FFF2-40B4-BE49-F238E27FC236}">
-                <a16:creationId xmlns:a16="http://schemas.microsoft.com/office/drawing/2014/main" id="{565AAF8B-83A5-44D5-AB0C-4C9AD7A8DE00}"/>
+                <a16:creationId xmlns:a16="http://schemas.microsoft.com/office/drawing/2014/main" id="{0D693BAC-12EC-4654-8BF7-EC794CF6F08E}"/>
               </a:ext>
             </a:extLst>
           </p:cNvPr>
@@ -14148,7 +14148,7 @@
           <p:cNvPr id="36" name="S2_OutputHumanDetail">
             <a:extLst xmlns:a="http://schemas.openxmlformats.org/drawingml/2006/main">
               <a:ext uri="{FF2B5EF4-FFF2-40B4-BE49-F238E27FC236}">
-                <a16:creationId xmlns:a16="http://schemas.microsoft.com/office/drawing/2014/main" id="{B7D477F7-81EB-4037-B9B2-36545B35D802}"/>
+                <a16:creationId xmlns:a16="http://schemas.microsoft.com/office/drawing/2014/main" id="{ED5C122B-030A-4F8E-8DB2-718FB79C3593}"/>
               </a:ext>
             </a:extLst>
           </p:cNvPr>
@@ -14352,7 +14352,7 @@
           <p:cNvPr id="37" name="S2_AuthorityBand">
             <a:extLst xmlns:a="http://schemas.openxmlformats.org/drawingml/2006/main">
               <a:ext uri="{FF2B5EF4-FFF2-40B4-BE49-F238E27FC236}">
-                <a16:creationId xmlns:a16="http://schemas.microsoft.com/office/drawing/2014/main" id="{74A5FD1D-4D42-4709-99E6-11B879E721ED}"/>
+                <a16:creationId xmlns:a16="http://schemas.microsoft.com/office/drawing/2014/main" id="{B5EDBC34-D16B-4671-8966-3496D0426003}"/>
               </a:ext>
             </a:extLst>
           </p:cNvPr>
@@ -14387,7 +14387,7 @@
           <p:cNvPr id="38" name="S2_AuthorityAI">
             <a:extLst xmlns:a="http://schemas.openxmlformats.org/drawingml/2006/main">
               <a:ext uri="{FF2B5EF4-FFF2-40B4-BE49-F238E27FC236}">
-                <a16:creationId xmlns:a16="http://schemas.microsoft.com/office/drawing/2014/main" id="{4CE849BC-5F6E-4990-B123-68AF546C4D70}"/>
+                <a16:creationId xmlns:a16="http://schemas.microsoft.com/office/drawing/2014/main" id="{E1D44016-C52B-4EE9-85A3-74FCDBBB2C33}"/>
               </a:ext>
             </a:extLst>
           </p:cNvPr>
@@ -14545,7 +14545,7 @@
           <p:cNvPr id="39" name="S2_AuthorityPolicy">
             <a:extLst xmlns:a="http://schemas.openxmlformats.org/drawingml/2006/main">
               <a:ext uri="{FF2B5EF4-FFF2-40B4-BE49-F238E27FC236}">
-                <a16:creationId xmlns:a16="http://schemas.microsoft.com/office/drawing/2014/main" id="{D3DF1E00-C4E9-4A3C-852B-236E5C090546}"/>
+                <a16:creationId xmlns:a16="http://schemas.microsoft.com/office/drawing/2014/main" id="{B360EB12-6634-4AD0-97DE-8C417D43F40B}"/>
               </a:ext>
             </a:extLst>
           </p:cNvPr>
@@ -14703,7 +14703,7 @@
           <p:cNvPr id="40" name="S2_AuthorityHuman">
             <a:extLst xmlns:a="http://schemas.openxmlformats.org/drawingml/2006/main">
               <a:ext uri="{FF2B5EF4-FFF2-40B4-BE49-F238E27FC236}">
-                <a16:creationId xmlns:a16="http://schemas.microsoft.com/office/drawing/2014/main" id="{63CD4C41-8A24-490A-A523-720829877453}"/>
+                <a16:creationId xmlns:a16="http://schemas.microsoft.com/office/drawing/2014/main" id="{3C30545B-22CB-4DF5-B1CA-C7CFB9A493F5}"/>
               </a:ext>
             </a:extLst>
           </p:cNvPr>
@@ -14859,7 +14859,7 @@
     </p:spTree>
     <p:extLst>
       <p:ext uri="{BB962C8B-B14F-4D97-AF65-F5344CB8AC3E}">
-        <p14:creationId xmlns:p14="http://schemas.microsoft.com/office/powerpoint/2010/main" val="418220118"/>
+        <p14:creationId xmlns:p14="http://schemas.microsoft.com/office/powerpoint/2010/main" val="1770337829"/>
       </p:ext>
     </p:extLst>
   </p:cSld>
@@ -14890,7 +14890,7 @@
           <p:cNvPr id="11" name="Slide_Title">
             <a:extLst xmlns:a="http://schemas.openxmlformats.org/drawingml/2006/main">
               <a:ext uri="{FF2B5EF4-FFF2-40B4-BE49-F238E27FC236}">
-                <a16:creationId xmlns:a16="http://schemas.microsoft.com/office/drawing/2014/main" id="{37DAAEFE-8E0C-4B09-96E7-DE45FCE36048}"/>
+                <a16:creationId xmlns:a16="http://schemas.microsoft.com/office/drawing/2014/main" id="{4E3C818C-3A04-46AE-9437-C7D40B97AF4B}"/>
               </a:ext>
             </a:extLst>
           </p:cNvPr>
@@ -15048,7 +15048,7 @@
           <p:cNvPr id="2" name="Slide_Subtitle">
             <a:extLst xmlns:a="http://schemas.openxmlformats.org/drawingml/2006/main">
               <a:ext uri="{FF2B5EF4-FFF2-40B4-BE49-F238E27FC236}">
-                <a16:creationId xmlns:a16="http://schemas.microsoft.com/office/drawing/2014/main" id="{3784409E-1BA4-42C3-988D-47788E7A265E}"/>
+                <a16:creationId xmlns:a16="http://schemas.microsoft.com/office/drawing/2014/main" id="{4CFD16D4-250F-4BCE-89CD-9403A4E75FAC}"/>
               </a:ext>
             </a:extLst>
           </p:cNvPr>
@@ -15206,7 +15206,7 @@
           <p:cNvPr id="3" name="S3_BeforeAfterTable">
             <a:extLst xmlns:a="http://schemas.openxmlformats.org/drawingml/2006/main">
               <a:ext uri="{FF2B5EF4-FFF2-40B4-BE49-F238E27FC236}">
-                <a16:creationId xmlns:a16="http://schemas.microsoft.com/office/drawing/2014/main" id="{D8A2FC29-95A5-4E3C-A2F7-1CB698CBEE94}"/>
+                <a16:creationId xmlns:a16="http://schemas.microsoft.com/office/drawing/2014/main" id="{45EB7623-3A33-472B-A842-81324C0B00C8}"/>
               </a:ext>
             </a:extLst>
           </p:cNvPr>
@@ -16460,7 +16460,7 @@
           <p:cNvPr id="4" name="S3_ProtocolBand">
             <a:extLst xmlns:a="http://schemas.openxmlformats.org/drawingml/2006/main">
               <a:ext uri="{FF2B5EF4-FFF2-40B4-BE49-F238E27FC236}">
-                <a16:creationId xmlns:a16="http://schemas.microsoft.com/office/drawing/2014/main" id="{B2BA97A9-BDBA-41CF-89E9-13DD8155737A}"/>
+                <a16:creationId xmlns:a16="http://schemas.microsoft.com/office/drawing/2014/main" id="{55543FC8-575D-40FA-8416-7AB49049FF5A}"/>
               </a:ext>
             </a:extLst>
           </p:cNvPr>
@@ -16495,7 +16495,7 @@
           <p:cNvPr id="5" name="S3_ProtocolLabel">
             <a:extLst xmlns:a="http://schemas.openxmlformats.org/drawingml/2006/main">
               <a:ext uri="{FF2B5EF4-FFF2-40B4-BE49-F238E27FC236}">
-                <a16:creationId xmlns:a16="http://schemas.microsoft.com/office/drawing/2014/main" id="{F588462A-F981-4710-A900-98F3F8C5C489}"/>
+                <a16:creationId xmlns:a16="http://schemas.microsoft.com/office/drawing/2014/main" id="{AEC78CE6-0572-4673-8277-142B8809814D}"/>
               </a:ext>
             </a:extLst>
           </p:cNvPr>
@@ -16653,7 +16653,7 @@
           <p:cNvPr id="6" name="S3_ProtocolLine1">
             <a:extLst xmlns:a="http://schemas.openxmlformats.org/drawingml/2006/main">
               <a:ext uri="{FF2B5EF4-FFF2-40B4-BE49-F238E27FC236}">
-                <a16:creationId xmlns:a16="http://schemas.microsoft.com/office/drawing/2014/main" id="{7D22816A-1B73-4B6E-9BBC-B04AC3179410}"/>
+                <a16:creationId xmlns:a16="http://schemas.microsoft.com/office/drawing/2014/main" id="{AF50CFEE-B925-4035-A8FB-634544874EFA}"/>
               </a:ext>
             </a:extLst>
           </p:cNvPr>
@@ -16811,7 +16811,7 @@
           <p:cNvPr id="7" name="S3_ProtocolLine2">
             <a:extLst xmlns:a="http://schemas.openxmlformats.org/drawingml/2006/main">
               <a:ext uri="{FF2B5EF4-FFF2-40B4-BE49-F238E27FC236}">
-                <a16:creationId xmlns:a16="http://schemas.microsoft.com/office/drawing/2014/main" id="{0ED6FF9F-C85F-4C1B-867D-DA67BFEECA38}"/>
+                <a16:creationId xmlns:a16="http://schemas.microsoft.com/office/drawing/2014/main" id="{850C733A-802D-4C16-ADC3-0FCBAFBCECA9}"/>
               </a:ext>
             </a:extLst>
           </p:cNvPr>
@@ -16969,7 +16969,7 @@
           <p:cNvPr id="8" name="S3_TechnicalStrip">
             <a:extLst xmlns:a="http://schemas.openxmlformats.org/drawingml/2006/main">
               <a:ext uri="{FF2B5EF4-FFF2-40B4-BE49-F238E27FC236}">
-                <a16:creationId xmlns:a16="http://schemas.microsoft.com/office/drawing/2014/main" id="{349755DD-F525-4E8B-9433-21D82CD787C4}"/>
+                <a16:creationId xmlns:a16="http://schemas.microsoft.com/office/drawing/2014/main" id="{C7CC8726-7AAE-458D-8C80-C4C0E35392EF}"/>
               </a:ext>
             </a:extLst>
           </p:cNvPr>
@@ -17004,7 +17004,7 @@
           <p:cNvPr id="9" name="S3_TechnicalLabel">
             <a:extLst xmlns:a="http://schemas.openxmlformats.org/drawingml/2006/main">
               <a:ext uri="{FF2B5EF4-FFF2-40B4-BE49-F238E27FC236}">
-                <a16:creationId xmlns:a16="http://schemas.microsoft.com/office/drawing/2014/main" id="{4817EE45-0271-4204-875A-49688DD11500}"/>
+                <a16:creationId xmlns:a16="http://schemas.microsoft.com/office/drawing/2014/main" id="{5BC9E6F4-81E4-40D7-BAAF-98F2D1E2B46E}"/>
               </a:ext>
             </a:extLst>
           </p:cNvPr>
@@ -17162,7 +17162,7 @@
           <p:cNvPr id="10" name="S3_TechnicalValues">
             <a:extLst xmlns:a="http://schemas.openxmlformats.org/drawingml/2006/main">
               <a:ext uri="{FF2B5EF4-FFF2-40B4-BE49-F238E27FC236}">
-                <a16:creationId xmlns:a16="http://schemas.microsoft.com/office/drawing/2014/main" id="{7BA87CA4-7B3B-4309-A3CD-ED1252B83994}"/>
+                <a16:creationId xmlns:a16="http://schemas.microsoft.com/office/drawing/2014/main" id="{D54A35B2-F81A-4B83-8A2F-429BCFB151F6}"/>
               </a:ext>
             </a:extLst>
           </p:cNvPr>
@@ -17318,7 +17318,7 @@
     </p:spTree>
     <p:extLst>
       <p:ext uri="{BB962C8B-B14F-4D97-AF65-F5344CB8AC3E}">
-        <p14:creationId xmlns:p14="http://schemas.microsoft.com/office/powerpoint/2010/main" val="2113376435"/>
+        <p14:creationId xmlns:p14="http://schemas.microsoft.com/office/powerpoint/2010/main" val="2122380714"/>
       </p:ext>
     </p:extLst>
   </p:cSld>
@@ -17349,7 +17349,7 @@
           <p:cNvPr id="40" name="Slide_Title">
             <a:extLst xmlns:a="http://schemas.openxmlformats.org/drawingml/2006/main">
               <a:ext uri="{FF2B5EF4-FFF2-40B4-BE49-F238E27FC236}">
-                <a16:creationId xmlns:a16="http://schemas.microsoft.com/office/drawing/2014/main" id="{69DF59A8-77AB-4DA5-A3A4-B2228E0DFE15}"/>
+                <a16:creationId xmlns:a16="http://schemas.microsoft.com/office/drawing/2014/main" id="{B60B4C0E-764A-4A31-BD12-37DE6612A2A4}"/>
               </a:ext>
             </a:extLst>
           </p:cNvPr>
@@ -17507,7 +17507,7 @@
           <p:cNvPr id="2" name="Slide_Subtitle">
             <a:extLst xmlns:a="http://schemas.openxmlformats.org/drawingml/2006/main">
               <a:ext uri="{FF2B5EF4-FFF2-40B4-BE49-F238E27FC236}">
-                <a16:creationId xmlns:a16="http://schemas.microsoft.com/office/drawing/2014/main" id="{8EF4FE24-83F6-40A9-9FEA-ABACADFC13E2}"/>
+                <a16:creationId xmlns:a16="http://schemas.microsoft.com/office/drawing/2014/main" id="{1E8E7707-E0E1-4F5B-98CF-7C14D771510A}"/>
               </a:ext>
             </a:extLst>
           </p:cNvPr>
@@ -17665,7 +17665,7 @@
           <p:cNvPr id="3" name="S4_Layer_1">
             <a:extLst xmlns:a="http://schemas.openxmlformats.org/drawingml/2006/main">
               <a:ext uri="{FF2B5EF4-FFF2-40B4-BE49-F238E27FC236}">
-                <a16:creationId xmlns:a16="http://schemas.microsoft.com/office/drawing/2014/main" id="{D8624756-0ED0-4E0C-89E8-78F1C5F03506}"/>
+                <a16:creationId xmlns:a16="http://schemas.microsoft.com/office/drawing/2014/main" id="{D7B28FA9-156B-43B8-B8B8-72B5CB79CC31}"/>
               </a:ext>
             </a:extLst>
           </p:cNvPr>
@@ -17700,7 +17700,7 @@
           <p:cNvPr id="4" name="S4_LiveBadge_1">
             <a:extLst xmlns:a="http://schemas.openxmlformats.org/drawingml/2006/main">
               <a:ext uri="{FF2B5EF4-FFF2-40B4-BE49-F238E27FC236}">
-                <a16:creationId xmlns:a16="http://schemas.microsoft.com/office/drawing/2014/main" id="{9099078E-98F7-4F06-A026-70A91E69A808}"/>
+                <a16:creationId xmlns:a16="http://schemas.microsoft.com/office/drawing/2014/main" id="{A056FF1E-D373-4A01-963B-C5BFF6415EB2}"/>
               </a:ext>
             </a:extLst>
           </p:cNvPr>
@@ -17865,7 +17865,7 @@
           <p:cNvPr id="5" name="S4_LayerLabel_1">
             <a:extLst xmlns:a="http://schemas.openxmlformats.org/drawingml/2006/main">
               <a:ext uri="{FF2B5EF4-FFF2-40B4-BE49-F238E27FC236}">
-                <a16:creationId xmlns:a16="http://schemas.microsoft.com/office/drawing/2014/main" id="{6243E529-72FF-4B15-A453-95796C0FE7B3}"/>
+                <a16:creationId xmlns:a16="http://schemas.microsoft.com/office/drawing/2014/main" id="{EE97DDF8-3249-4ABA-B2C4-769181CA6507}"/>
               </a:ext>
             </a:extLst>
           </p:cNvPr>
@@ -18023,7 +18023,7 @@
           <p:cNvPr id="6" name="S4_LayerText_1">
             <a:extLst xmlns:a="http://schemas.openxmlformats.org/drawingml/2006/main">
               <a:ext uri="{FF2B5EF4-FFF2-40B4-BE49-F238E27FC236}">
-                <a16:creationId xmlns:a16="http://schemas.microsoft.com/office/drawing/2014/main" id="{8837AF7F-1367-49CF-A0E6-9E4D2B0F7460}"/>
+                <a16:creationId xmlns:a16="http://schemas.microsoft.com/office/drawing/2014/main" id="{12EFEC36-7ED8-47C7-8257-A608412EA536}"/>
               </a:ext>
             </a:extLst>
           </p:cNvPr>
@@ -18171,7 +18171,7 @@
                 <a:ea typeface="Segoe UI"/>
                 <a:cs typeface="Segoe UI"/>
               </a:rPr>
-              <a:t>Lượt 1–10 ảnh • amount tùy chọn • HTTP 202/poll • dashboard + CSV tháng</a:t>
+              <a:t>Lượt 1–10 ảnh • không nhập amount • HTTP 202/poll • dashboard + CSV tháng</a:t>
             </a:r>
           </a:p>
         </p:txBody>
@@ -18181,7 +18181,7 @@
           <p:cNvPr id="7" name="S4_LayerConnector_1">
             <a:extLst xmlns:a="http://schemas.openxmlformats.org/drawingml/2006/main">
               <a:ext uri="{FF2B5EF4-FFF2-40B4-BE49-F238E27FC236}">
-                <a16:creationId xmlns:a16="http://schemas.microsoft.com/office/drawing/2014/main" id="{BD711228-C9AE-4408-B4EA-02C8B4B1468C}"/>
+                <a16:creationId xmlns:a16="http://schemas.microsoft.com/office/drawing/2014/main" id="{44A97078-7EC2-4FEB-8DC3-2DA0E2D7F85E}"/>
               </a:ext>
             </a:extLst>
           </p:cNvPr>
@@ -18212,7 +18212,7 @@
           <p:cNvPr id="8" name="S4_Layer_2">
             <a:extLst xmlns:a="http://schemas.openxmlformats.org/drawingml/2006/main">
               <a:ext uri="{FF2B5EF4-FFF2-40B4-BE49-F238E27FC236}">
-                <a16:creationId xmlns:a16="http://schemas.microsoft.com/office/drawing/2014/main" id="{6BA611F6-E621-44F3-9C1E-EA2083D4BBA2}"/>
+                <a16:creationId xmlns:a16="http://schemas.microsoft.com/office/drawing/2014/main" id="{D6FB9B62-F360-47FE-AB34-CC2915ED6BD2}"/>
               </a:ext>
             </a:extLst>
           </p:cNvPr>
@@ -18247,7 +18247,7 @@
           <p:cNvPr id="9" name="S4_LiveBadge_2">
             <a:extLst xmlns:a="http://schemas.openxmlformats.org/drawingml/2006/main">
               <a:ext uri="{FF2B5EF4-FFF2-40B4-BE49-F238E27FC236}">
-                <a16:creationId xmlns:a16="http://schemas.microsoft.com/office/drawing/2014/main" id="{E99A87CB-1A1F-428E-BDF9-921431636716}"/>
+                <a16:creationId xmlns:a16="http://schemas.microsoft.com/office/drawing/2014/main" id="{8C750462-184A-4D0B-94DB-A8367012038C}"/>
               </a:ext>
             </a:extLst>
           </p:cNvPr>
@@ -18412,7 +18412,7 @@
           <p:cNvPr id="10" name="S4_LayerLabel_2">
             <a:extLst xmlns:a="http://schemas.openxmlformats.org/drawingml/2006/main">
               <a:ext uri="{FF2B5EF4-FFF2-40B4-BE49-F238E27FC236}">
-                <a16:creationId xmlns:a16="http://schemas.microsoft.com/office/drawing/2014/main" id="{84066D6A-6C6D-4FD9-926C-28F2D3C354C0}"/>
+                <a16:creationId xmlns:a16="http://schemas.microsoft.com/office/drawing/2014/main" id="{230B27DC-A341-4BF9-8A84-EF2B61AFBAEA}"/>
               </a:ext>
             </a:extLst>
           </p:cNvPr>
@@ -18570,7 +18570,7 @@
           <p:cNvPr id="11" name="S4_LayerText_2">
             <a:extLst xmlns:a="http://schemas.openxmlformats.org/drawingml/2006/main">
               <a:ext uri="{FF2B5EF4-FFF2-40B4-BE49-F238E27FC236}">
-                <a16:creationId xmlns:a16="http://schemas.microsoft.com/office/drawing/2014/main" id="{301E749B-4A25-40DD-9F91-8C5DC02841D1}"/>
+                <a16:creationId xmlns:a16="http://schemas.microsoft.com/office/drawing/2014/main" id="{2B3E72FD-775C-4002-8E7E-1E136D4D8FC9}"/>
               </a:ext>
             </a:extLst>
           </p:cNvPr>
@@ -18728,7 +18728,7 @@
           <p:cNvPr id="12" name="S4_LayerConnector_2">
             <a:extLst xmlns:a="http://schemas.openxmlformats.org/drawingml/2006/main">
               <a:ext uri="{FF2B5EF4-FFF2-40B4-BE49-F238E27FC236}">
-                <a16:creationId xmlns:a16="http://schemas.microsoft.com/office/drawing/2014/main" id="{443FFFC9-E29D-496C-87B0-A70AD92B70D6}"/>
+                <a16:creationId xmlns:a16="http://schemas.microsoft.com/office/drawing/2014/main" id="{D8B33079-6ACF-4978-BFE2-C37016117D87}"/>
               </a:ext>
             </a:extLst>
           </p:cNvPr>
@@ -18759,7 +18759,7 @@
           <p:cNvPr id="13" name="S4_Layer_3">
             <a:extLst xmlns:a="http://schemas.openxmlformats.org/drawingml/2006/main">
               <a:ext uri="{FF2B5EF4-FFF2-40B4-BE49-F238E27FC236}">
-                <a16:creationId xmlns:a16="http://schemas.microsoft.com/office/drawing/2014/main" id="{33488666-2246-4284-A6EB-22CDBD279681}"/>
+                <a16:creationId xmlns:a16="http://schemas.microsoft.com/office/drawing/2014/main" id="{78B27A99-78B2-4964-B39A-30772AB18747}"/>
               </a:ext>
             </a:extLst>
           </p:cNvPr>
@@ -18794,7 +18794,7 @@
           <p:cNvPr id="14" name="S4_LiveBadge_3">
             <a:extLst xmlns:a="http://schemas.openxmlformats.org/drawingml/2006/main">
               <a:ext uri="{FF2B5EF4-FFF2-40B4-BE49-F238E27FC236}">
-                <a16:creationId xmlns:a16="http://schemas.microsoft.com/office/drawing/2014/main" id="{A3841BE8-041F-44EB-842B-F150D00D803B}"/>
+                <a16:creationId xmlns:a16="http://schemas.microsoft.com/office/drawing/2014/main" id="{D0E12004-38A7-4E7E-8D5B-90710DC046DF}"/>
               </a:ext>
             </a:extLst>
           </p:cNvPr>
@@ -18959,7 +18959,7 @@
           <p:cNvPr id="15" name="S4_LayerLabel_3">
             <a:extLst xmlns:a="http://schemas.openxmlformats.org/drawingml/2006/main">
               <a:ext uri="{FF2B5EF4-FFF2-40B4-BE49-F238E27FC236}">
-                <a16:creationId xmlns:a16="http://schemas.microsoft.com/office/drawing/2014/main" id="{8B8C0444-DE0E-447E-A907-CEB306E68ACD}"/>
+                <a16:creationId xmlns:a16="http://schemas.microsoft.com/office/drawing/2014/main" id="{557E43AA-CE57-4FFB-B5DA-C78299C95C8B}"/>
               </a:ext>
             </a:extLst>
           </p:cNvPr>
@@ -19117,7 +19117,7 @@
           <p:cNvPr id="16" name="S4_LayerText_3">
             <a:extLst xmlns:a="http://schemas.openxmlformats.org/drawingml/2006/main">
               <a:ext uri="{FF2B5EF4-FFF2-40B4-BE49-F238E27FC236}">
-                <a16:creationId xmlns:a16="http://schemas.microsoft.com/office/drawing/2014/main" id="{2BDFEAFA-3299-467A-A9BB-C7B7393DB721}"/>
+                <a16:creationId xmlns:a16="http://schemas.microsoft.com/office/drawing/2014/main" id="{CD6EA2B5-DCE5-45C0-82B6-6F5AD58E1F27}"/>
               </a:ext>
             </a:extLst>
           </p:cNvPr>
@@ -19298,7 +19298,7 @@
           <p:cNvPr id="17" name="S4_LayerConnector_3">
             <a:extLst xmlns:a="http://schemas.openxmlformats.org/drawingml/2006/main">
               <a:ext uri="{FF2B5EF4-FFF2-40B4-BE49-F238E27FC236}">
-                <a16:creationId xmlns:a16="http://schemas.microsoft.com/office/drawing/2014/main" id="{ECD9B9E1-1585-4147-B524-D86C99827AB7}"/>
+                <a16:creationId xmlns:a16="http://schemas.microsoft.com/office/drawing/2014/main" id="{B4BB03E9-5C8A-4F17-AFB3-34F64CA44976}"/>
               </a:ext>
             </a:extLst>
           </p:cNvPr>
@@ -19329,7 +19329,7 @@
           <p:cNvPr id="18" name="S4_Layer_4">
             <a:extLst xmlns:a="http://schemas.openxmlformats.org/drawingml/2006/main">
               <a:ext uri="{FF2B5EF4-FFF2-40B4-BE49-F238E27FC236}">
-                <a16:creationId xmlns:a16="http://schemas.microsoft.com/office/drawing/2014/main" id="{4B441ECE-B981-452F-8F23-003164CAD9ED}"/>
+                <a16:creationId xmlns:a16="http://schemas.microsoft.com/office/drawing/2014/main" id="{41E898A3-EE00-46F2-A8FC-96E21C9813D0}"/>
               </a:ext>
             </a:extLst>
           </p:cNvPr>
@@ -19364,7 +19364,7 @@
           <p:cNvPr id="19" name="S4_LiveBadge_4">
             <a:extLst xmlns:a="http://schemas.openxmlformats.org/drawingml/2006/main">
               <a:ext uri="{FF2B5EF4-FFF2-40B4-BE49-F238E27FC236}">
-                <a16:creationId xmlns:a16="http://schemas.microsoft.com/office/drawing/2014/main" id="{4D0ED180-4360-4160-BC20-58193F582A82}"/>
+                <a16:creationId xmlns:a16="http://schemas.microsoft.com/office/drawing/2014/main" id="{43EB78D5-7FC2-4018-B62C-797FEABA1E5B}"/>
               </a:ext>
             </a:extLst>
           </p:cNvPr>
@@ -19529,7 +19529,7 @@
           <p:cNvPr id="20" name="S4_LayerLabel_4">
             <a:extLst xmlns:a="http://schemas.openxmlformats.org/drawingml/2006/main">
               <a:ext uri="{FF2B5EF4-FFF2-40B4-BE49-F238E27FC236}">
-                <a16:creationId xmlns:a16="http://schemas.microsoft.com/office/drawing/2014/main" id="{AEDBD96F-F194-429D-BAAF-A11A3851035B}"/>
+                <a16:creationId xmlns:a16="http://schemas.microsoft.com/office/drawing/2014/main" id="{67A7CBE9-083C-4EBC-86E2-97CB47D9A928}"/>
               </a:ext>
             </a:extLst>
           </p:cNvPr>
@@ -19687,7 +19687,7 @@
           <p:cNvPr id="21" name="S4_LayerText_4">
             <a:extLst xmlns:a="http://schemas.openxmlformats.org/drawingml/2006/main">
               <a:ext uri="{FF2B5EF4-FFF2-40B4-BE49-F238E27FC236}">
-                <a16:creationId xmlns:a16="http://schemas.microsoft.com/office/drawing/2014/main" id="{F69EC45E-9419-4795-B633-06BDB514762A}"/>
+                <a16:creationId xmlns:a16="http://schemas.microsoft.com/office/drawing/2014/main" id="{FDCC622D-AE0F-41C1-B6F2-64B9EB398D4B}"/>
               </a:ext>
             </a:extLst>
           </p:cNvPr>
@@ -19845,7 +19845,7 @@
           <p:cNvPr id="22" name="S4_TestBoundary">
             <a:extLst xmlns:a="http://schemas.openxmlformats.org/drawingml/2006/main">
               <a:ext uri="{FF2B5EF4-FFF2-40B4-BE49-F238E27FC236}">
-                <a16:creationId xmlns:a16="http://schemas.microsoft.com/office/drawing/2014/main" id="{E10BE5BF-42B1-4B39-8D6B-81DD8204DF90}"/>
+                <a16:creationId xmlns:a16="http://schemas.microsoft.com/office/drawing/2014/main" id="{A0134297-D4E2-4229-B22D-1BC6DDDA1DEB}"/>
               </a:ext>
             </a:extLst>
           </p:cNvPr>
@@ -19880,7 +19880,7 @@
           <p:cNvPr id="23" name="S4_TestTitle">
             <a:extLst xmlns:a="http://schemas.openxmlformats.org/drawingml/2006/main">
               <a:ext uri="{FF2B5EF4-FFF2-40B4-BE49-F238E27FC236}">
-                <a16:creationId xmlns:a16="http://schemas.microsoft.com/office/drawing/2014/main" id="{6DF9CCBD-9AD1-4A89-9739-DC62842EF512}"/>
+                <a16:creationId xmlns:a16="http://schemas.microsoft.com/office/drawing/2014/main" id="{7F2B9C62-67FF-4654-83DB-1FC6366412C8}"/>
               </a:ext>
             </a:extLst>
           </p:cNvPr>
@@ -20038,7 +20038,7 @@
           <p:cNvPr id="24" name="S4_TestItem_1">
             <a:extLst xmlns:a="http://schemas.openxmlformats.org/drawingml/2006/main">
               <a:ext uri="{FF2B5EF4-FFF2-40B4-BE49-F238E27FC236}">
-                <a16:creationId xmlns:a16="http://schemas.microsoft.com/office/drawing/2014/main" id="{56BCB6ED-C455-4B48-8E68-F02ABF2DB37C}"/>
+                <a16:creationId xmlns:a16="http://schemas.microsoft.com/office/drawing/2014/main" id="{1BD96CF1-B5DD-4A05-9F61-51961DF6E0CE}"/>
               </a:ext>
             </a:extLst>
           </p:cNvPr>
@@ -20073,7 +20073,7 @@
           <p:cNvPr id="25" name="S4_TestBadge_1">
             <a:extLst xmlns:a="http://schemas.openxmlformats.org/drawingml/2006/main">
               <a:ext uri="{FF2B5EF4-FFF2-40B4-BE49-F238E27FC236}">
-                <a16:creationId xmlns:a16="http://schemas.microsoft.com/office/drawing/2014/main" id="{A70F1755-63E1-49DD-8166-623112D0967A}"/>
+                <a16:creationId xmlns:a16="http://schemas.microsoft.com/office/drawing/2014/main" id="{242DA673-1710-4C33-956F-9F192A0BC881}"/>
               </a:ext>
             </a:extLst>
           </p:cNvPr>
@@ -20238,7 +20238,7 @@
           <p:cNvPr id="26" name="S4_TestLabel_1">
             <a:extLst xmlns:a="http://schemas.openxmlformats.org/drawingml/2006/main">
               <a:ext uri="{FF2B5EF4-FFF2-40B4-BE49-F238E27FC236}">
-                <a16:creationId xmlns:a16="http://schemas.microsoft.com/office/drawing/2014/main" id="{3166A8B3-CE41-4D44-9001-0677BE36CBB4}"/>
+                <a16:creationId xmlns:a16="http://schemas.microsoft.com/office/drawing/2014/main" id="{8B149509-D80D-4E39-9F0A-DD6DBD27D8F6}"/>
               </a:ext>
             </a:extLst>
           </p:cNvPr>
@@ -20396,7 +20396,7 @@
           <p:cNvPr id="27" name="S4_TestDetail_1">
             <a:extLst xmlns:a="http://schemas.openxmlformats.org/drawingml/2006/main">
               <a:ext uri="{FF2B5EF4-FFF2-40B4-BE49-F238E27FC236}">
-                <a16:creationId xmlns:a16="http://schemas.microsoft.com/office/drawing/2014/main" id="{CA13CA22-57B9-4C7B-97BD-72F2B68979E9}"/>
+                <a16:creationId xmlns:a16="http://schemas.microsoft.com/office/drawing/2014/main" id="{D427B939-1667-4929-9218-3A506A39A3A5}"/>
               </a:ext>
             </a:extLst>
           </p:cNvPr>
@@ -20554,7 +20554,7 @@
           <p:cNvPr id="28" name="S4_TestItem_2">
             <a:extLst xmlns:a="http://schemas.openxmlformats.org/drawingml/2006/main">
               <a:ext uri="{FF2B5EF4-FFF2-40B4-BE49-F238E27FC236}">
-                <a16:creationId xmlns:a16="http://schemas.microsoft.com/office/drawing/2014/main" id="{F35DD2C4-00CA-4AAD-8169-B7AF5F0861EF}"/>
+                <a16:creationId xmlns:a16="http://schemas.microsoft.com/office/drawing/2014/main" id="{9F68D8EF-CA67-4320-99E4-406CE99123F6}"/>
               </a:ext>
             </a:extLst>
           </p:cNvPr>
@@ -20589,7 +20589,7 @@
           <p:cNvPr id="29" name="S4_TestBadge_2">
             <a:extLst xmlns:a="http://schemas.openxmlformats.org/drawingml/2006/main">
               <a:ext uri="{FF2B5EF4-FFF2-40B4-BE49-F238E27FC236}">
-                <a16:creationId xmlns:a16="http://schemas.microsoft.com/office/drawing/2014/main" id="{E32FEDA9-EA7C-4012-8DE4-C13CD2D4BD1D}"/>
+                <a16:creationId xmlns:a16="http://schemas.microsoft.com/office/drawing/2014/main" id="{0BD7424D-B201-4DE8-8488-6CCDEA2547FC}"/>
               </a:ext>
             </a:extLst>
           </p:cNvPr>
@@ -20754,7 +20754,7 @@
           <p:cNvPr id="30" name="S4_TestLabel_2">
             <a:extLst xmlns:a="http://schemas.openxmlformats.org/drawingml/2006/main">
               <a:ext uri="{FF2B5EF4-FFF2-40B4-BE49-F238E27FC236}">
-                <a16:creationId xmlns:a16="http://schemas.microsoft.com/office/drawing/2014/main" id="{DE58F198-90FB-4F54-B7F2-88ADCCA743E1}"/>
+                <a16:creationId xmlns:a16="http://schemas.microsoft.com/office/drawing/2014/main" id="{310FAF00-5A89-420C-894D-3E43ACCAF297}"/>
               </a:ext>
             </a:extLst>
           </p:cNvPr>
@@ -20912,7 +20912,7 @@
           <p:cNvPr id="31" name="S4_TestDetail_2">
             <a:extLst xmlns:a="http://schemas.openxmlformats.org/drawingml/2006/main">
               <a:ext uri="{FF2B5EF4-FFF2-40B4-BE49-F238E27FC236}">
-                <a16:creationId xmlns:a16="http://schemas.microsoft.com/office/drawing/2014/main" id="{621A29DE-D649-4147-AC1A-41365EAB6DC5}"/>
+                <a16:creationId xmlns:a16="http://schemas.microsoft.com/office/drawing/2014/main" id="{036C0865-C9C4-418A-AA57-0D88EDA25024}"/>
               </a:ext>
             </a:extLst>
           </p:cNvPr>
@@ -21070,7 +21070,7 @@
           <p:cNvPr id="32" name="S4_TestItem_3">
             <a:extLst xmlns:a="http://schemas.openxmlformats.org/drawingml/2006/main">
               <a:ext uri="{FF2B5EF4-FFF2-40B4-BE49-F238E27FC236}">
-                <a16:creationId xmlns:a16="http://schemas.microsoft.com/office/drawing/2014/main" id="{B7DB3D90-10E9-4E51-9F5F-272B0405F9CF}"/>
+                <a16:creationId xmlns:a16="http://schemas.microsoft.com/office/drawing/2014/main" id="{FE698569-1F52-4EDB-AFC4-3978767BBD92}"/>
               </a:ext>
             </a:extLst>
           </p:cNvPr>
@@ -21105,7 +21105,7 @@
           <p:cNvPr id="33" name="S4_TestBadge_3">
             <a:extLst xmlns:a="http://schemas.openxmlformats.org/drawingml/2006/main">
               <a:ext uri="{FF2B5EF4-FFF2-40B4-BE49-F238E27FC236}">
-                <a16:creationId xmlns:a16="http://schemas.microsoft.com/office/drawing/2014/main" id="{9C705A86-790A-45C7-89B0-4E296BA407B2}"/>
+                <a16:creationId xmlns:a16="http://schemas.microsoft.com/office/drawing/2014/main" id="{0C16260A-172E-4120-B937-52A934FB4347}"/>
               </a:ext>
             </a:extLst>
           </p:cNvPr>
@@ -21270,7 +21270,7 @@
           <p:cNvPr id="34" name="S4_TestLabel_3">
             <a:extLst xmlns:a="http://schemas.openxmlformats.org/drawingml/2006/main">
               <a:ext uri="{FF2B5EF4-FFF2-40B4-BE49-F238E27FC236}">
-                <a16:creationId xmlns:a16="http://schemas.microsoft.com/office/drawing/2014/main" id="{C14532F9-9FF6-41DE-8725-7994367FE605}"/>
+                <a16:creationId xmlns:a16="http://schemas.microsoft.com/office/drawing/2014/main" id="{7832A4A5-BC38-4705-A7E8-5080E5E34B79}"/>
               </a:ext>
             </a:extLst>
           </p:cNvPr>
@@ -21428,7 +21428,7 @@
           <p:cNvPr id="35" name="S4_TestDetail_3">
             <a:extLst xmlns:a="http://schemas.openxmlformats.org/drawingml/2006/main">
               <a:ext uri="{FF2B5EF4-FFF2-40B4-BE49-F238E27FC236}">
-                <a16:creationId xmlns:a16="http://schemas.microsoft.com/office/drawing/2014/main" id="{B708A1EF-19F0-4540-9996-64B82B05041B}"/>
+                <a16:creationId xmlns:a16="http://schemas.microsoft.com/office/drawing/2014/main" id="{DC830388-C071-429F-A47A-70F96B3E3497}"/>
               </a:ext>
             </a:extLst>
           </p:cNvPr>
@@ -21586,7 +21586,7 @@
           <p:cNvPr id="36" name="S4_DeploymentBand">
             <a:extLst xmlns:a="http://schemas.openxmlformats.org/drawingml/2006/main">
               <a:ext uri="{FF2B5EF4-FFF2-40B4-BE49-F238E27FC236}">
-                <a16:creationId xmlns:a16="http://schemas.microsoft.com/office/drawing/2014/main" id="{0BB14100-0ED1-461C-8466-1719698402FA}"/>
+                <a16:creationId xmlns:a16="http://schemas.microsoft.com/office/drawing/2014/main" id="{A01E1557-9321-4DEF-B8E9-277A33C890FD}"/>
               </a:ext>
             </a:extLst>
           </p:cNvPr>
@@ -21621,7 +21621,7 @@
           <p:cNvPr id="37" name="S4_DeploymentLabel">
             <a:extLst xmlns:a="http://schemas.openxmlformats.org/drawingml/2006/main">
               <a:ext uri="{FF2B5EF4-FFF2-40B4-BE49-F238E27FC236}">
-                <a16:creationId xmlns:a16="http://schemas.microsoft.com/office/drawing/2014/main" id="{A0ABFF2C-95CA-4EE3-A3FD-97083893B32D}"/>
+                <a16:creationId xmlns:a16="http://schemas.microsoft.com/office/drawing/2014/main" id="{73483FF7-3209-41C3-852D-0C5DD15C280E}"/>
               </a:ext>
             </a:extLst>
           </p:cNvPr>
@@ -21779,7 +21779,7 @@
           <p:cNvPr id="38" name="S4_DeploymentText">
             <a:extLst xmlns:a="http://schemas.openxmlformats.org/drawingml/2006/main">
               <a:ext uri="{FF2B5EF4-FFF2-40B4-BE49-F238E27FC236}">
-                <a16:creationId xmlns:a16="http://schemas.microsoft.com/office/drawing/2014/main" id="{62B01F37-DFE2-4470-894A-0F8567F1774F}"/>
+                <a16:creationId xmlns:a16="http://schemas.microsoft.com/office/drawing/2014/main" id="{300A963A-EA8E-421C-868F-E93435F07ED7}"/>
               </a:ext>
             </a:extLst>
           </p:cNvPr>
@@ -21937,7 +21937,7 @@
           <p:cNvPr id="39" name="S4_SecurityBoundaryText">
             <a:extLst xmlns:a="http://schemas.openxmlformats.org/drawingml/2006/main">
               <a:ext uri="{FF2B5EF4-FFF2-40B4-BE49-F238E27FC236}">
-                <a16:creationId xmlns:a16="http://schemas.microsoft.com/office/drawing/2014/main" id="{3ABF1DF3-B894-49B0-A734-99BF3EECBC90}"/>
+                <a16:creationId xmlns:a16="http://schemas.microsoft.com/office/drawing/2014/main" id="{DC8141FE-5F29-4C23-9852-3A7153A17B27}"/>
               </a:ext>
             </a:extLst>
           </p:cNvPr>
@@ -22093,7 +22093,7 @@
     </p:spTree>
     <p:extLst>
       <p:ext uri="{BB962C8B-B14F-4D97-AF65-F5344CB8AC3E}">
-        <p14:creationId xmlns:p14="http://schemas.microsoft.com/office/powerpoint/2010/main" val="1762637079"/>
+        <p14:creationId xmlns:p14="http://schemas.microsoft.com/office/powerpoint/2010/main" val="1626335215"/>
       </p:ext>
     </p:extLst>
   </p:cSld>
@@ -22124,7 +22124,7 @@
           <p:cNvPr id="9" name="Slide_Title">
             <a:extLst xmlns:a="http://schemas.openxmlformats.org/drawingml/2006/main">
               <a:ext uri="{FF2B5EF4-FFF2-40B4-BE49-F238E27FC236}">
-                <a16:creationId xmlns:a16="http://schemas.microsoft.com/office/drawing/2014/main" id="{A13FA6FB-4586-436F-9213-8685AB67BBBA}"/>
+                <a16:creationId xmlns:a16="http://schemas.microsoft.com/office/drawing/2014/main" id="{A5A1F0DA-9564-4ECE-86F4-49DEAAF9AC3E}"/>
               </a:ext>
             </a:extLst>
           </p:cNvPr>
@@ -22282,7 +22282,7 @@
           <p:cNvPr id="2" name="Slide_Subtitle">
             <a:extLst xmlns:a="http://schemas.openxmlformats.org/drawingml/2006/main">
               <a:ext uri="{FF2B5EF4-FFF2-40B4-BE49-F238E27FC236}">
-                <a16:creationId xmlns:a16="http://schemas.microsoft.com/office/drawing/2014/main" id="{CA35BC4F-372F-4AE3-B8D0-50B66F0B2C04}"/>
+                <a16:creationId xmlns:a16="http://schemas.microsoft.com/office/drawing/2014/main" id="{6651A6A6-9EEF-41AC-BCCE-F63562AB1BD2}"/>
               </a:ext>
             </a:extLst>
           </p:cNvPr>
@@ -22440,7 +22440,7 @@
           <p:cNvPr id="3" name="S5_ObservedHeading">
             <a:extLst xmlns:a="http://schemas.openxmlformats.org/drawingml/2006/main">
               <a:ext uri="{FF2B5EF4-FFF2-40B4-BE49-F238E27FC236}">
-                <a16:creationId xmlns:a16="http://schemas.microsoft.com/office/drawing/2014/main" id="{B03073D2-9B01-4BCC-B5CF-4DA87481E0EB}"/>
+                <a16:creationId xmlns:a16="http://schemas.microsoft.com/office/drawing/2014/main" id="{1656508F-B047-4160-AC52-EF6F4A20FB40}"/>
               </a:ext>
             </a:extLst>
           </p:cNvPr>
@@ -22598,7 +22598,7 @@
           <p:cNvPr id="4" name="S5_RoadmapHeading">
             <a:extLst xmlns:a="http://schemas.openxmlformats.org/drawingml/2006/main">
               <a:ext uri="{FF2B5EF4-FFF2-40B4-BE49-F238E27FC236}">
-                <a16:creationId xmlns:a16="http://schemas.microsoft.com/office/drawing/2014/main" id="{1998C943-2DEA-426B-AC68-BA6E4EC650BA}"/>
+                <a16:creationId xmlns:a16="http://schemas.microsoft.com/office/drawing/2014/main" id="{BF43B77D-848A-4AD8-B3D2-5FA60342584C}"/>
               </a:ext>
             </a:extLst>
           </p:cNvPr>
@@ -22756,7 +22756,7 @@
           <p:cNvPr id="5" name="S5_ObservedErrorsTable">
             <a:extLst xmlns:a="http://schemas.openxmlformats.org/drawingml/2006/main">
               <a:ext uri="{FF2B5EF4-FFF2-40B4-BE49-F238E27FC236}">
-                <a16:creationId xmlns:a16="http://schemas.microsoft.com/office/drawing/2014/main" id="{FD8DFCCD-B856-489A-9952-24700A49E4AF}"/>
+                <a16:creationId xmlns:a16="http://schemas.microsoft.com/office/drawing/2014/main" id="{DA6696CA-475D-4CE6-B803-CD5190034260}"/>
               </a:ext>
             </a:extLst>
           </p:cNvPr>
@@ -23155,7 +23155,7 @@
           <p:cNvPr id="6" name="S5_RoadmapTable">
             <a:extLst xmlns:a="http://schemas.openxmlformats.org/drawingml/2006/main">
               <a:ext uri="{FF2B5EF4-FFF2-40B4-BE49-F238E27FC236}">
-                <a16:creationId xmlns:a16="http://schemas.microsoft.com/office/drawing/2014/main" id="{E97B22D1-9997-401C-BE75-8BF4928E841A}"/>
+                <a16:creationId xmlns:a16="http://schemas.microsoft.com/office/drawing/2014/main" id="{D8231307-28C0-45DB-80EC-E158619B7464}"/>
               </a:ext>
             </a:extLst>
           </p:cNvPr>
@@ -23675,7 +23675,7 @@
           <p:cNvPr id="7" name="S5_PrincipleBand">
             <a:extLst xmlns:a="http://schemas.openxmlformats.org/drawingml/2006/main">
               <a:ext uri="{FF2B5EF4-FFF2-40B4-BE49-F238E27FC236}">
-                <a16:creationId xmlns:a16="http://schemas.microsoft.com/office/drawing/2014/main" id="{10EB2F53-E75E-4844-9238-5BB300CD8FA6}"/>
+                <a16:creationId xmlns:a16="http://schemas.microsoft.com/office/drawing/2014/main" id="{8E20B4A6-6D0E-484A-98E7-4C85E0DCDC51}"/>
               </a:ext>
             </a:extLst>
           </p:cNvPr>
@@ -23710,7 +23710,7 @@
           <p:cNvPr id="8" name="S5_PrincipleText">
             <a:extLst xmlns:a="http://schemas.openxmlformats.org/drawingml/2006/main">
               <a:ext uri="{FF2B5EF4-FFF2-40B4-BE49-F238E27FC236}">
-                <a16:creationId xmlns:a16="http://schemas.microsoft.com/office/drawing/2014/main" id="{8196BA33-2C02-42B0-B18F-8986F67B88DD}"/>
+                <a16:creationId xmlns:a16="http://schemas.microsoft.com/office/drawing/2014/main" id="{5ACD28FC-A177-4732-B4DF-15E46A156BBC}"/>
               </a:ext>
             </a:extLst>
           </p:cNvPr>
@@ -23858,7 +23858,7 @@
                 <a:ea typeface="Segoe UI"/>
                 <a:cs typeface="Segoe UI"/>
               </a:rPr>
-              <a:t>ĐÃ LÀM: multi-file • AI amount • privacy triage • dashboard + CSV | CHƯA CLAIM LIVE: publish + smoke</a:t>
+              <a:t>ĐÃ LÀM: multi-file • bỏ nhập amount • privacy triage • dashboard + CSV | CHƯA CLAIM LIVE: publish + smoke</a:t>
             </a:r>
           </a:p>
         </p:txBody>
@@ -23866,7 +23866,7 @@
     </p:spTree>
     <p:extLst>
       <p:ext uri="{BB962C8B-B14F-4D97-AF65-F5344CB8AC3E}">
-        <p14:creationId xmlns:p14="http://schemas.microsoft.com/office/powerpoint/2010/main" val="250379316"/>
+        <p14:creationId xmlns:p14="http://schemas.microsoft.com/office/powerpoint/2010/main" val="932364115"/>
       </p:ext>
     </p:extLst>
   </p:cSld>

</xml_diff>

<commit_message>
Synchronize Drive UX evidence and contest artifacts
</commit_message>
<xml_diff>
--- a/AURA/submission/AURA_5_SLIDES_AFTER_FEEDBACK_FINAL.pptx
+++ b/AURA/submission/AURA_5_SLIDES_AFTER_FEEDBACK_FINAL.pptx
@@ -17310,7 +17310,7 @@
                 <a:ea typeface="Segoe UI"/>
                 <a:cs typeface="Segoe UI"/>
               </a:rPr>
-              <a:t>181/181 offline    live baseline 5/5 • 65.004s    re-smoke: PENDING</a:t>
+              <a:t>Mốc nộp: 181/181 offline • Verify 5/5 | Source local: 378/378 unit</a:t>
             </a:r>
           </a:p>
         </p:txBody>
@@ -20386,7 +20386,7 @@
                 <a:ea typeface="Segoe UI"/>
                 <a:cs typeface="Segoe UI"/>
               </a:rPr>
-              <a:t>Mailbox connector</a:t>
+              <a:t>Drive sandbox local</a:t>
             </a:r>
           </a:p>
         </p:txBody>
@@ -20544,7 +20544,7 @@
                 <a:ea typeface="Segoe UI"/>
                 <a:cs typeface="Segoe UI"/>
               </a:rPr>
-              <a:t>Agent gọi tool; connector giữ OAuth + cursor</a:t>
+              <a:t>Restricted + Viewer; synthetic; public vẫn tắt</a:t>
             </a:r>
           </a:p>
         </p:txBody>
@@ -20902,7 +20902,7 @@
                 <a:ea typeface="Segoe UI"/>
                 <a:cs typeface="Segoe UI"/>
               </a:rPr>
-              <a:t>Strict ZDR</a:t>
+              <a:t>Strict ZDR request</a:t>
             </a:r>
           </a:p>
         </p:txBody>
@@ -21060,7 +21060,7 @@
                 <a:ea typeface="Segoe UI"/>
                 <a:cs typeface="Segoe UI"/>
               </a:rPr>
-              <a:t>Cần probe route/provider trước khi bật</a:t>
+              <a:t>Đã gửi route request; chưa chứng nhận retention</a:t>
             </a:r>
           </a:p>
         </p:txBody>
@@ -21927,7 +21927,7 @@
                 <a:ea typeface="Segoe UI"/>
                 <a:cs typeface="Segoe UI"/>
               </a:rPr>
-              <a:t>candidate source • một process • OpenRouter / Alibaba • fallback Ollama tắt</a:t>
+              <a:t>Local synthetic • 1 AI permit • OpenRouter route • fallback tắt</a:t>
             </a:r>
           </a:p>
         </p:txBody>
@@ -22085,7 +22085,7 @@
                 <a:ea typeface="Segoe UI"/>
                 <a:cs typeface="Segoe UI"/>
               </a:rPr>
-              <a:t>181/181 offline • cần publish + health + synthetic smoke trước khi gọi là live</a:t>
+              <a:t>378/378 unit • Drive local • cần staging smoke trước publish</a:t>
             </a:r>
           </a:p>
         </p:txBody>
@@ -23281,7 +23281,7 @@
                           <a:ea typeface="Segoe UI"/>
                           <a:cs typeface="Segoe UI"/>
                         </a:rPr>
-                        <a:t>Candidate chưa publish</a:t>
+                        <a:t>Source mới chưa publish</a:t>
                       </a:r>
                     </a:p>
                   </a:txBody>
@@ -23323,7 +23323,7 @@
                           <a:ea typeface="Segoe UI"/>
                           <a:cs typeface="Segoe UI"/>
                         </a:rPr>
-                        <a:t>Publish/recycle; health 200; single + multi-file + privacy synthetic smoke. Không dùng baseline cũ để claim UI mới.</a:t>
+                        <a:t>Staging: health, migration, web upload và synthetic smoke; Drive vẫn off trên SmartASP.</a:t>
                       </a:r>
                     </a:p>
                   </a:txBody>
@@ -23361,7 +23361,7 @@
                           <a:ea typeface="Segoe UI"/>
                           <a:cs typeface="Segoe UI"/>
                         </a:rPr>
-                        <a:t>Privacy chỉ là triage</a:t>
+                        <a:t>Privacy chưa chốt pilot</a:t>
                       </a:r>
                     </a:p>
                   </a:txBody>
@@ -23403,7 +23403,7 @@
                           <a:ea typeface="Segoe UI"/>
                           <a:cs typeface="Segoe UI"/>
                         </a:rPr>
-                        <a:t>Demo dùng dữ liệu tổng hợp hoặc đã ẩn danh. Production thêm pre-inference control, OIDC/RBAC, retention và legal review.</a:t>
+                        <a:t>Exact-hash synthetic gate trước AI; dữ liệu thật cần PII control, RBAC và legal review.</a:t>
                       </a:r>
                     </a:p>
                   </a:txBody>
@@ -23441,7 +23441,7 @@
                           <a:ea typeface="Segoe UI"/>
                           <a:cs typeface="Segoe UI"/>
                         </a:rPr>
-                        <a:t>Mailbox chưa nối</a:t>
+                        <a:t>Drive chỉ ở local</a:t>
                       </a:r>
                     </a:p>
                   </a:txBody>
@@ -23483,7 +23483,7 @@
                           <a:ea typeface="Segoe UI"/>
                           <a:cs typeface="Segoe UI"/>
                         </a:rPr>
-                        <a:t>Agent chỉ điều phối; connector giữ OAuth + cursor; cần idempotency, quarantine, backfill. Gate: duplicate và malicious-file tests pass.</a:t>
+                        <a:t>Folder Restricted, service account Viewer, poll read-only; chưa là cổng upload công khai.</a:t>
                       </a:r>
                     </a:p>
                   </a:txBody>
@@ -23521,7 +23521,7 @@
                           <a:ea typeface="Segoe UI"/>
                           <a:cs typeface="Segoe UI"/>
                         </a:rPr>
-                        <a:t>Limiter / lock một process</a:t>
+                        <a:t>Local storage / một host</a:t>
                       </a:r>
                     </a:p>
                   </a:txBody>
@@ -23563,7 +23563,7 @@
                           <a:ea typeface="Segoe UI"/>
                           <a:cs typeface="Segoe UI"/>
                         </a:rPr>
-                        <a:t>Đưa limiter, cooldown, circuit và Verify lock ra storage phân tán. Gate: capacity test multi-instance.</a:t>
+                        <a:t>Trước multi-host: shared private storage, distributed limit, load và restore drill đúng host.</a:t>
                       </a:r>
                     </a:p>
                   </a:txBody>
@@ -23601,7 +23601,7 @@
                           <a:ea typeface="Segoe UI"/>
                           <a:cs typeface="Segoe UI"/>
                         </a:rPr>
-                        <a:t>ZDR / local VLM chưa chốt</a:t>
+                        <a:t>Strict ZDR là yêu cầu</a:t>
                       </a:r>
                     </a:p>
                   </a:txBody>
@@ -23643,7 +23643,7 @@
                           <a:ea typeface="Segoe UI"/>
                           <a:cs typeface="Segoe UI"/>
                         </a:rPr>
-                        <a:t>Probe route trước strict ZDR; benchmark local về quality, latency và capacity trước luồng nhạy cảm.</a:t>
+                        <a:t>Xác minh route/provider và điều khoản; không coi routing flag là che PII hay bảo đảm pháp lý.</a:t>
                       </a:r>
                     </a:p>
                   </a:txBody>
@@ -23858,7 +23858,7 @@
                 <a:ea typeface="Segoe UI"/>
                 <a:cs typeface="Segoe UI"/>
               </a:rPr>
-              <a:t>ĐÃ LÀM: multi-file • bỏ nhập amount • privacy triage • dashboard + CSV | CHƯA CLAIM LIVE: publish + smoke</a:t>
+              <a:t>ĐÃ LÀM: Drive local → SQL • fetch status • privacy gate | CHƯA CLAIM LIVE: SmartASP smoke</a:t>
             </a:r>
           </a:p>
         </p:txBody>

</xml_diff>